<commit_message>
docs: slide viet lai cho de hieu, them khung thanh vien nhom
Co-Authored-By: Claude Opus 5.5 (1M context) <noreply@anthropic.com>
</commit_message>
<xml_diff>
--- a/docs/kien-truc-he-thong.pptx
+++ b/docs/kien-truc-he-thong.pptx
@@ -113,29 +113,29 @@
   <p:extLst>
     <p:ext uri="{521415D9-36F7-43E2-AB2F-B90AF26B5E84}">
       <p14:sectionLst xmlns:p14="http://schemas.microsoft.com/office/powerpoint/2010/main">
-        <p14:section name="Mở đầu" id="{f506ea04-fbd8-8b2a-35e9-a6a53d80c806}">
+        <p14:section name="Mở đầu" id="{eec76b90-e498-2cd4-d51c-3c8c4dcd0236}">
           <p14:sldIdLst>
             <p14:sldId id="256"/>
             <p14:sldId id="257"/>
           </p14:sldIdLst>
         </p14:section>
-        <p14:section name="Part 1: Device" id="{698e0f54-7701-bacd-e204-6cb29022f4ae}">
+        <p14:section name="Part 1: Device" id="{1fcb38e7-2eb2-25ab-0e70-fe395294b5fd}">
           <p14:sldIdLst>
             <p14:sldId id="258"/>
           </p14:sldIdLst>
         </p14:section>
-        <p14:section name="Part 2: MQTT" id="{32fb6d92-c4ac-3ee5-ab86-7c278b06ca82}">
+        <p14:section name="Part 2: MQTT" id="{68adc79b-7d30-7f6a-e9e0-4bb000980de0}">
           <p14:sldIdLst>
             <p14:sldId id="259"/>
           </p14:sldIdLst>
         </p14:section>
-        <p14:section name="Part 3: Web Server App" id="{a0f102c8-0d42-eeb5-9f00-c4eea09121a4}">
+        <p14:section name="Part 3: Web Server App" id="{c88f4cf2-8ca3-1c20-9924-1cd75a3f1bc8}">
           <p14:sldIdLst>
             <p14:sldId id="260"/>
             <p14:sldId id="261"/>
           </p14:sldIdLst>
         </p14:section>
-        <p14:section name="Kết luận" id="{978a9aeb-24d2-990f-a495-be8215f359bb}">
+        <p14:section name="Kết luận" id="{cf8d71e6-a15e-abd4-87d8-abb0cc6f940d}">
           <p14:sldIdLst>
             <p14:sldId id="262"/>
           </p14:sldIdLst>
@@ -1178,8 +1178,8 @@
         </p:nvSpPr>
         <p:spPr>
           <a:xfrm>
-            <a:off x="731520" y="1920240"/>
-            <a:ext cx="10698480" cy="1280160"/>
+            <a:off x="731520" y="822960"/>
+            <a:ext cx="8595360" cy="1280160"/>
           </a:xfrm>
           <a:prstGeom prst="rect">
             <a:avLst/>
@@ -1220,8 +1220,8 @@
         </p:nvSpPr>
         <p:spPr>
           <a:xfrm>
-            <a:off x="731520" y="3291840"/>
-            <a:ext cx="10698480" cy="731520"/>
+            <a:off x="731520" y="2194560"/>
+            <a:ext cx="8595360" cy="731520"/>
           </a:xfrm>
           <a:prstGeom prst="rect">
             <a:avLst/>
@@ -1925,8 +1925,8 @@
         </p:nvSpPr>
         <p:spPr>
           <a:xfrm>
-            <a:off x="731520" y="1920240"/>
-            <a:ext cx="10698480" cy="1280160"/>
+            <a:off x="731520" y="822960"/>
+            <a:ext cx="8595360" cy="1280160"/>
           </a:xfrm>
           <a:prstGeom prst="rect">
             <a:avLst/>
@@ -1966,8 +1966,8 @@
         </p:nvSpPr>
         <p:spPr>
           <a:xfrm>
-            <a:off x="731520" y="3291840"/>
-            <a:ext cx="10698480" cy="731520"/>
+            <a:off x="731520" y="2194560"/>
+            <a:ext cx="8595360" cy="731520"/>
           </a:xfrm>
           <a:prstGeom prst="rect">
             <a:avLst/>
@@ -1988,7 +1988,7 @@
                   <a:srgbClr val="CFE3D6"/>
                 </a:solidFill>
               </a:rPr>
-              <a:t>Kiến trúc hệ thống: thiết bị biên, dịch vụ MQTT và ứng dụng web điều hành</a:t>
+              <a:t>Hệ thống tự động đo và chăm sóc vườn lan, theo dõi và điều khiển từ xa qua web</a:t>
             </a:r>
             <a:endParaRPr lang="en-US" sz="2000" dirty="0"/>
           </a:p>
@@ -2002,7 +2002,7 @@
         </p:nvSpPr>
         <p:spPr>
           <a:xfrm>
-            <a:off x="731520" y="4572000"/>
+            <a:off x="731520" y="3246120"/>
             <a:ext cx="731520" cy="731520"/>
           </a:xfrm>
           <a:prstGeom prst="ellipse">
@@ -2035,7 +2035,7 @@
         </p:blipFill>
         <p:spPr>
           <a:xfrm>
-            <a:off x="892454" y="4732934"/>
+            <a:off x="892454" y="3407054"/>
             <a:ext cx="409651" cy="409651"/>
           </a:xfrm>
           <a:prstGeom prst="rect">
@@ -2051,7 +2051,7 @@
         </p:nvSpPr>
         <p:spPr>
           <a:xfrm>
-            <a:off x="1645920" y="4617720"/>
+            <a:off x="1645920" y="3291840"/>
             <a:ext cx="2560320" cy="685800"/>
           </a:xfrm>
           <a:prstGeom prst="rect">
@@ -2073,7 +2073,7 @@
                   <a:srgbClr val="CFE3D6"/>
                 </a:solidFill>
               </a:rPr>
-              <a:t>Part 1</a:t>
+              <a:t>Phần 1</a:t>
             </a:r>
             <a:endParaRPr lang="en-US" sz="1400" dirty="0"/>
           </a:p>
@@ -2087,7 +2087,7 @@
                   <a:schemeClr val="bg1"/>
                 </a:solidFill>
               </a:rPr>
-              <a:t>Device (ESP32)</a:t>
+              <a:t>Thiết bị ESP32</a:t>
             </a:r>
             <a:endParaRPr lang="en-US" sz="1400" dirty="0"/>
           </a:p>
@@ -2101,7 +2101,7 @@
         </p:nvSpPr>
         <p:spPr>
           <a:xfrm>
-            <a:off x="4297680" y="4572000"/>
+            <a:off x="4297680" y="3246120"/>
             <a:ext cx="731520" cy="731520"/>
           </a:xfrm>
           <a:prstGeom prst="ellipse">
@@ -2134,7 +2134,7 @@
         </p:blipFill>
         <p:spPr>
           <a:xfrm>
-            <a:off x="4458614" y="4732934"/>
+            <a:off x="4458614" y="3407054"/>
             <a:ext cx="409651" cy="409651"/>
           </a:xfrm>
           <a:prstGeom prst="rect">
@@ -2150,7 +2150,7 @@
         </p:nvSpPr>
         <p:spPr>
           <a:xfrm>
-            <a:off x="5212080" y="4617720"/>
+            <a:off x="5212080" y="3291840"/>
             <a:ext cx="2560320" cy="685800"/>
           </a:xfrm>
           <a:prstGeom prst="rect">
@@ -2172,7 +2172,7 @@
                   <a:srgbClr val="CFE3D6"/>
                 </a:solidFill>
               </a:rPr>
-              <a:t>Part 2</a:t>
+              <a:t>Phần 2</a:t>
             </a:r>
             <a:endParaRPr lang="en-US" sz="1400" dirty="0"/>
           </a:p>
@@ -2186,7 +2186,7 @@
                   <a:schemeClr val="bg1"/>
                 </a:solidFill>
               </a:rPr>
-              <a:t>MQTT Services</a:t>
+              <a:t>Truyền tin MQTT</a:t>
             </a:r>
             <a:endParaRPr lang="en-US" sz="1400" dirty="0"/>
           </a:p>
@@ -2200,7 +2200,7 @@
         </p:nvSpPr>
         <p:spPr>
           <a:xfrm>
-            <a:off x="7863840" y="4572000"/>
+            <a:off x="7863840" y="3246120"/>
             <a:ext cx="731520" cy="731520"/>
           </a:xfrm>
           <a:prstGeom prst="ellipse">
@@ -2233,7 +2233,7 @@
         </p:blipFill>
         <p:spPr>
           <a:xfrm>
-            <a:off x="8024774" y="4732934"/>
+            <a:off x="8024774" y="3407054"/>
             <a:ext cx="409651" cy="409651"/>
           </a:xfrm>
           <a:prstGeom prst="rect">
@@ -2249,7 +2249,7 @@
         </p:nvSpPr>
         <p:spPr>
           <a:xfrm>
-            <a:off x="8778240" y="4617720"/>
+            <a:off x="8778240" y="3291840"/>
             <a:ext cx="2560320" cy="685800"/>
           </a:xfrm>
           <a:prstGeom prst="rect">
@@ -2271,7 +2271,7 @@
                   <a:srgbClr val="CFE3D6"/>
                 </a:solidFill>
               </a:rPr>
-              <a:t>Part 3</a:t>
+              <a:t>Phần 3</a:t>
             </a:r>
             <a:endParaRPr lang="en-US" sz="1400" dirty="0"/>
           </a:p>
@@ -2285,7 +2285,7 @@
                   <a:schemeClr val="bg1"/>
                 </a:solidFill>
               </a:rPr>
-              <a:t>Web Server App</a:t>
+              <a:t>Ứng dụng web Node-RED</a:t>
             </a:r>
             <a:endParaRPr lang="en-US" sz="1400" dirty="0"/>
           </a:p>
@@ -2317,6 +2317,309 @@
           </a:prstGeom>
         </p:spPr>
       </p:pic>
+      <p:sp>
+        <p:nvSpPr>
+          <p:cNvPr id="14" name="cover-team-label"/>
+          <p:cNvSpPr txBox="1"/>
+          <p:nvPr/>
+        </p:nvSpPr>
+        <p:spPr>
+          <a:xfrm>
+            <a:off x="731520" y="4526280"/>
+            <a:ext cx="5486400" cy="274320"/>
+          </a:xfrm>
+          <a:prstGeom prst="rect">
+            <a:avLst/>
+          </a:prstGeom>
+          <a:noFill/>
+          <a:ln/>
+        </p:spPr>
+        <p:txBody>
+          <a:bodyPr wrap="square" lIns="0" tIns="0" rIns="0" bIns="0" rtlCol="0" anchor="t"/>
+          <a:lstStyle/>
+          <a:p>
+            <a:pPr indent="0" marL="0">
+              <a:buNone/>
+            </a:pPr>
+            <a:r>
+              <a:rPr lang="en-US" sz="1200" b="1" spc="200" kern="0" dirty="0">
+                <a:solidFill>
+                  <a:srgbClr val="F2B8D6"/>
+                </a:solidFill>
+              </a:rPr>
+              <a:t>NHÓM THỰC HIỆN</a:t>
+            </a:r>
+            <a:endParaRPr lang="en-US" sz="1200" dirty="0"/>
+          </a:p>
+        </p:txBody>
+      </p:sp>
+      <p:sp>
+        <p:nvSpPr>
+          <p:cNvPr id="15" name="cover-member1"/>
+          <p:cNvSpPr/>
+          <p:nvPr/>
+        </p:nvSpPr>
+        <p:spPr>
+          <a:xfrm>
+            <a:off x="731520" y="4892040"/>
+            <a:ext cx="3337560" cy="960120"/>
+          </a:xfrm>
+          <a:prstGeom prst="roundRect">
+            <a:avLst>
+              <a:gd name="adj" fmla="val 11429"/>
+            </a:avLst>
+          </a:prstGeom>
+          <a:solidFill>
+            <a:srgbClr val="21503A"/>
+          </a:solidFill>
+          <a:ln w="12700">
+            <a:solidFill>
+              <a:srgbClr val="21503A"/>
+            </a:solidFill>
+            <a:prstDash val="solid"/>
+          </a:ln>
+        </p:spPr>
+      </p:sp>
+      <p:sp>
+        <p:nvSpPr>
+          <p:cNvPr id="16" name="cover-member1-text"/>
+          <p:cNvSpPr txBox="1"/>
+          <p:nvPr/>
+        </p:nvSpPr>
+        <p:spPr>
+          <a:xfrm>
+            <a:off x="914400" y="5001768"/>
+            <a:ext cx="3017520" cy="777240"/>
+          </a:xfrm>
+          <a:prstGeom prst="rect">
+            <a:avLst/>
+          </a:prstGeom>
+          <a:noFill/>
+          <a:ln/>
+        </p:spPr>
+        <p:txBody>
+          <a:bodyPr wrap="square" lIns="0" tIns="0" rIns="0" bIns="0" rtlCol="0" anchor="t"/>
+          <a:lstStyle/>
+          <a:p>
+            <a:pPr indent="0" marL="0">
+              <a:buNone/>
+            </a:pPr>
+            <a:r>
+              <a:rPr lang="en-US" sz="1600" b="1" dirty="0">
+                <a:solidFill>
+                  <a:schemeClr val="bg1"/>
+                </a:solidFill>
+              </a:rPr>
+              <a:t>Người 1 – Họ và tên</a:t>
+            </a:r>
+            <a:endParaRPr lang="en-US" sz="1400" dirty="0"/>
+          </a:p>
+          <a:p>
+            <a:pPr indent="0" marL="0">
+              <a:buNone/>
+            </a:pPr>
+            <a:r>
+              <a:rPr lang="en-US" sz="1200" dirty="0">
+                <a:solidFill>
+                  <a:srgbClr val="CFE3D6"/>
+                </a:solidFill>
+              </a:rPr>
+              <a:t>Firmware ESP32, lọc tín hiệu, gửi dữ liệu lên (uplink)</a:t>
+            </a:r>
+            <a:endParaRPr lang="en-US" sz="1400" dirty="0"/>
+          </a:p>
+        </p:txBody>
+      </p:sp>
+      <p:sp>
+        <p:nvSpPr>
+          <p:cNvPr id="17" name="cover-member2"/>
+          <p:cNvSpPr/>
+          <p:nvPr/>
+        </p:nvSpPr>
+        <p:spPr>
+          <a:xfrm>
+            <a:off x="4297680" y="4892040"/>
+            <a:ext cx="3337560" cy="960120"/>
+          </a:xfrm>
+          <a:prstGeom prst="roundRect">
+            <a:avLst>
+              <a:gd name="adj" fmla="val 11429"/>
+            </a:avLst>
+          </a:prstGeom>
+          <a:solidFill>
+            <a:srgbClr val="21503A"/>
+          </a:solidFill>
+          <a:ln w="12700">
+            <a:solidFill>
+              <a:srgbClr val="21503A"/>
+            </a:solidFill>
+            <a:prstDash val="solid"/>
+          </a:ln>
+        </p:spPr>
+      </p:sp>
+      <p:sp>
+        <p:nvSpPr>
+          <p:cNvPr id="18" name="cover-member2-text"/>
+          <p:cNvSpPr txBox="1"/>
+          <p:nvPr/>
+        </p:nvSpPr>
+        <p:spPr>
+          <a:xfrm>
+            <a:off x="4480560" y="5001768"/>
+            <a:ext cx="3017520" cy="777240"/>
+          </a:xfrm>
+          <a:prstGeom prst="rect">
+            <a:avLst/>
+          </a:prstGeom>
+          <a:noFill/>
+          <a:ln/>
+        </p:spPr>
+        <p:txBody>
+          <a:bodyPr wrap="square" lIns="0" tIns="0" rIns="0" bIns="0" rtlCol="0" anchor="t"/>
+          <a:lstStyle/>
+          <a:p>
+            <a:pPr indent="0" marL="0">
+              <a:buNone/>
+            </a:pPr>
+            <a:r>
+              <a:rPr lang="en-US" sz="1600" b="1" dirty="0">
+                <a:solidFill>
+                  <a:schemeClr val="bg1"/>
+                </a:solidFill>
+              </a:rPr>
+              <a:t>Người 2 – Họ và tên</a:t>
+            </a:r>
+            <a:endParaRPr lang="en-US" sz="1400" dirty="0"/>
+          </a:p>
+          <a:p>
+            <a:pPr indent="0" marL="0">
+              <a:buNone/>
+            </a:pPr>
+            <a:r>
+              <a:rPr lang="en-US" sz="1200" dirty="0">
+                <a:solidFill>
+                  <a:srgbClr val="CFE3D6"/>
+                </a:solidFill>
+              </a:rPr>
+              <a:t>Dashboard Node-RED, điều khiển xuống (downlink)</a:t>
+            </a:r>
+            <a:endParaRPr lang="en-US" sz="1400" dirty="0"/>
+          </a:p>
+        </p:txBody>
+      </p:sp>
+      <p:sp>
+        <p:nvSpPr>
+          <p:cNvPr id="19" name="cover-member3"/>
+          <p:cNvSpPr/>
+          <p:nvPr/>
+        </p:nvSpPr>
+        <p:spPr>
+          <a:xfrm>
+            <a:off x="7863840" y="4892040"/>
+            <a:ext cx="3337560" cy="960120"/>
+          </a:xfrm>
+          <a:prstGeom prst="roundRect">
+            <a:avLst>
+              <a:gd name="adj" fmla="val 11429"/>
+            </a:avLst>
+          </a:prstGeom>
+          <a:solidFill>
+            <a:srgbClr val="21503A"/>
+          </a:solidFill>
+          <a:ln w="12700">
+            <a:solidFill>
+              <a:srgbClr val="21503A"/>
+            </a:solidFill>
+            <a:prstDash val="solid"/>
+          </a:ln>
+        </p:spPr>
+      </p:sp>
+      <p:sp>
+        <p:nvSpPr>
+          <p:cNvPr id="20" name="cover-member3-text"/>
+          <p:cNvSpPr txBox="1"/>
+          <p:nvPr/>
+        </p:nvSpPr>
+        <p:spPr>
+          <a:xfrm>
+            <a:off x="8046720" y="5001768"/>
+            <a:ext cx="3017520" cy="777240"/>
+          </a:xfrm>
+          <a:prstGeom prst="rect">
+            <a:avLst/>
+          </a:prstGeom>
+          <a:noFill/>
+          <a:ln/>
+        </p:spPr>
+        <p:txBody>
+          <a:bodyPr wrap="square" lIns="0" tIns="0" rIns="0" bIns="0" rtlCol="0" anchor="t"/>
+          <a:lstStyle/>
+          <a:p>
+            <a:pPr indent="0" marL="0">
+              <a:buNone/>
+            </a:pPr>
+            <a:r>
+              <a:rPr lang="en-US" sz="1600" b="1" dirty="0">
+                <a:solidFill>
+                  <a:schemeClr val="bg1"/>
+                </a:solidFill>
+              </a:rPr>
+              <a:t>Người 3 – Họ và tên</a:t>
+            </a:r>
+            <a:endParaRPr lang="en-US" sz="1400" dirty="0"/>
+          </a:p>
+          <a:p>
+            <a:pPr indent="0" marL="0">
+              <a:buNone/>
+            </a:pPr>
+            <a:r>
+              <a:rPr lang="en-US" sz="1200" dirty="0">
+                <a:solidFill>
+                  <a:srgbClr val="CFE3D6"/>
+                </a:solidFill>
+              </a:rPr>
+              <a:t>Cảnh báo Telegram, ghép hệ thống, kiểm thử</a:t>
+            </a:r>
+            <a:endParaRPr lang="en-US" sz="1400" dirty="0"/>
+          </a:p>
+        </p:txBody>
+      </p:sp>
+      <p:sp>
+        <p:nvSpPr>
+          <p:cNvPr id="21" name="cover-supervisor"/>
+          <p:cNvSpPr txBox="1"/>
+          <p:nvPr/>
+        </p:nvSpPr>
+        <p:spPr>
+          <a:xfrm>
+            <a:off x="731520" y="6080760"/>
+            <a:ext cx="10698480" cy="320040"/>
+          </a:xfrm>
+          <a:prstGeom prst="rect">
+            <a:avLst/>
+          </a:prstGeom>
+          <a:noFill/>
+          <a:ln/>
+        </p:spPr>
+        <p:txBody>
+          <a:bodyPr wrap="square" lIns="0" tIns="0" rIns="0" bIns="0" rtlCol="0" anchor="t"/>
+          <a:lstStyle/>
+          <a:p>
+            <a:pPr indent="0" marL="0">
+              <a:buNone/>
+            </a:pPr>
+            <a:r>
+              <a:rPr lang="en-US" sz="1300" dirty="0">
+                <a:solidFill>
+                  <a:srgbClr val="CFE3D6"/>
+                </a:solidFill>
+              </a:rPr>
+              <a:t>Giảng viên hướng dẫn: …</a:t>
+            </a:r>
+            <a:endParaRPr lang="en-US" sz="1300" dirty="0"/>
+          </a:p>
+        </p:txBody>
+      </p:sp>
     </p:spTree>
   </p:cSld>
   <p:clrMapOvr>
@@ -2779,7 +3082,7 @@
                   <a:schemeClr val="tx1"/>
                 </a:solidFill>
               </a:rPr>
-              <a:t>Dashboard theo dõi thời gian thực, điều khiển tay có xác nhận (ACK)</a:t>
+              <a:t>Trang web theo dõi trực tiếp, bấm điều khiển và thấy thiết bị xác nhận</a:t>
             </a:r>
             <a:endParaRPr lang="en-US" sz="1500" dirty="0"/>
           </a:p>
@@ -2797,7 +3100,7 @@
                   <a:schemeClr val="tx1"/>
                 </a:solidFill>
               </a:rPr>
-              <a:t>Khóa an toàn nằm ở firmware: mất mạng vẫn chạy AUTO an toàn</a:t>
+              <a:t>Các khóa an toàn chạy ngay trên ESP32: mất mạng vẫn tự chăm vườn an toàn</a:t>
             </a:r>
             <a:endParaRPr lang="en-US" sz="1500" dirty="0"/>
           </a:p>
@@ -3261,7 +3564,7 @@
                   <a:schemeClr val="accent5"/>
                 </a:solidFill>
               </a:rPr>
-              <a:t>Node-RED: luật, gateway, log</a:t>
+              <a:t>Node-RED: luật tự động, nhật ký</a:t>
             </a:r>
             <a:endParaRPr lang="en-US" sz="1400" dirty="0"/>
           </a:p>
@@ -3448,7 +3751,7 @@
                   <a:schemeClr val="accent5"/>
                 </a:solidFill>
               </a:rPr>
-              <a:t>Mũi tên hai chiều: uplink (dữ liệu cảm biến lên) và downlink (lệnh xuống, ACK về)</a:t>
+              <a:t>Mũi tên hai chiều: số đo đi lên (uplink), lệnh điều khiển đi xuống và xác nhận quay về (downlink)</a:t>
             </a:r>
             <a:endParaRPr lang="en-US" sz="1100" dirty="0"/>
           </a:p>
@@ -3559,7 +3862,7 @@
                 <a:ea typeface="Cambria" pitchFamily="34" charset="-122"/>
                 <a:cs typeface="Cambria" pitchFamily="34" charset="-120"/>
               </a:rPr>
-              <a:t>Part 1: Device (ESP32)</a:t>
+              <a:t>Phần 1: Thiết bị ESP32 tại vườn</a:t>
             </a:r>
             <a:endParaRPr lang="en-US" sz="3200" dirty="0"/>
           </a:p>
@@ -3597,7 +3900,7 @@
                   <a:schemeClr val="accent5"/>
                 </a:solidFill>
               </a:rPr>
-              <a:t>Thiết bị trạm đo và điều khiển vi khí hậu vườn lan tại biên (Edge Device)</a:t>
+              <a:t>Bộ não nhỏ đặt ngay tại vườn: tự đo môi trường và tự bật/tắt thiết bị, không cần chờ server</a:t>
             </a:r>
             <a:endParaRPr lang="en-US" sz="1600" dirty="0"/>
           </a:p>
@@ -3663,7 +3966,7 @@
                 <a:ea typeface="Cambria" pitchFamily="34" charset="-122"/>
                 <a:cs typeface="Cambria" pitchFamily="34" charset="-120"/>
               </a:rPr>
-              <a:t>Sensors &amp; Actuators</a:t>
+              <a:t>Cảm biến và thiết bị điều khiển</a:t>
             </a:r>
             <a:endParaRPr lang="en-US" sz="2000" dirty="0"/>
           </a:p>
@@ -3735,7 +4038,7 @@
                   <a:schemeClr val="accent2"/>
                 </a:solidFill>
               </a:rPr>
-              <a:t>CƠ CẤU CHẤP HÀNH (3 RELAY)</a:t>
+              <a:t>THIẾT BỊ ĐƯỢC BẬT/TẮT (3 RELAY)</a:t>
             </a:r>
             <a:endParaRPr lang="en-US" sz="1100" dirty="0"/>
           </a:p>
@@ -3933,7 +4236,7 @@
                   <a:schemeClr val="tx1"/>
                 </a:solidFill>
               </a:rPr>
-              <a:t>LDR  </a:t>
+              <a:t>Quang trở LDR  </a:t>
             </a:r>
             <a:pPr indent="0" marL="0">
               <a:buNone/>
@@ -3961,7 +4264,7 @@
                   <a:schemeClr val="accent5"/>
                 </a:solidFill>
               </a:rPr>
-              <a:t>Độ rọi ánh sáng (ADC)</a:t>
+              <a:t>Biết trời đang sáng hay tối</a:t>
             </a:r>
             <a:endParaRPr lang="en-US" sz="1400" dirty="0"/>
           </a:p>
@@ -4046,7 +4349,7 @@
                   <a:schemeClr val="tx1"/>
                 </a:solidFill>
               </a:rPr>
-              <a:t>Mực nước  </a:t>
+              <a:t>Cảm biến mực nước  </a:t>
             </a:r>
             <a:pPr indent="0" marL="0">
               <a:buNone/>
@@ -4074,7 +4377,7 @@
                   <a:schemeClr val="accent5"/>
                 </a:solidFill>
               </a:rPr>
-              <a:t>Mực nước bình phun sương (ADC)</a:t>
+              <a:t>Biết bình nước còn đủ hay sắp cạn</a:t>
             </a:r>
             <a:endParaRPr lang="en-US" sz="1400" dirty="0"/>
           </a:p>
@@ -4159,7 +4462,7 @@
                   <a:schemeClr val="tx1"/>
                 </a:solidFill>
               </a:rPr>
-              <a:t>Relay phun sương  </a:t>
+              <a:t>Relay bơm phun sương  </a:t>
             </a:r>
             <a:pPr indent="0" marL="0">
               <a:buNone/>
@@ -4187,7 +4490,7 @@
                   <a:schemeClr val="accent5"/>
                 </a:solidFill>
               </a:rPr>
-              <a:t>Bơm tạo sương, giữ ẩm và làm mát</a:t>
+              <a:t>Phun sương để tăng độ ẩm, làm mát</a:t>
             </a:r>
             <a:endParaRPr lang="en-US" sz="1400" dirty="0"/>
           </a:p>
@@ -4300,7 +4603,7 @@
                   <a:schemeClr val="accent5"/>
                 </a:solidFill>
               </a:rPr>
-              <a:t>Thông gió, làm ráo nước đọng trên lá</a:t>
+              <a:t>Thông gió, làm khô nước đọng trên lá</a:t>
             </a:r>
             <a:endParaRPr lang="en-US" sz="1400" dirty="0"/>
           </a:p>
@@ -4413,7 +4716,7 @@
                   <a:schemeClr val="accent5"/>
                 </a:solidFill>
               </a:rPr>
-              <a:t>Đèn LED bù sáng sinh trưởng</a:t>
+              <a:t>Đèn LED bù sáng khi trời tối</a:t>
             </a:r>
             <a:endParaRPr lang="en-US" sz="1400" dirty="0"/>
           </a:p>
@@ -4452,7 +4755,7 @@
                 <a:ea typeface="Cambria" pitchFamily="34" charset="-122"/>
                 <a:cs typeface="Cambria" pitchFamily="34" charset="-120"/>
               </a:rPr>
-              <a:t>Firmware: 2 tác vụ cốt lõi</a:t>
+              <a:t>Chương trình trên ESP32 làm 2 việc chính</a:t>
             </a:r>
             <a:endParaRPr lang="en-US" sz="2000" dirty="0"/>
           </a:p>
@@ -4564,7 +4867,7 @@
                   <a:schemeClr val="tx2"/>
                 </a:solidFill>
               </a:rPr>
-              <a:t>Collect Task</a:t>
+              <a:t>1. Đọc cảm biến</a:t>
             </a:r>
             <a:endParaRPr lang="en-US" sz="1600" dirty="0"/>
           </a:p>
@@ -4604,7 +4907,7 @@
                   <a:schemeClr val="tx1"/>
                 </a:solidFill>
               </a:rPr>
-              <a:t>Đọc mỗi 2,5 s, non-blocking (không delay())</a:t>
+              <a:t>Đo 2,5 giây một lần, không dừng chương trình</a:t>
             </a:r>
             <a:endParaRPr lang="en-US" sz="1300" dirty="0"/>
           </a:p>
@@ -4622,7 +4925,7 @@
                   <a:schemeClr val="tx1"/>
                 </a:solidFill>
               </a:rPr>
-              <a:t>Lọc 2 lớp: loại xung đột biến + trung bình trượt 5 mẫu</a:t>
+              <a:t>Lọc nhiễu: bỏ số nhảy vọt, lấy trung bình 5 lần đo</a:t>
             </a:r>
             <a:endParaRPr lang="en-US" sz="1300" dirty="0"/>
           </a:p>
@@ -4640,7 +4943,7 @@
                   <a:schemeClr val="tx1"/>
                 </a:solidFill>
               </a:rPr>
-              <a:t>DHT lỗi 3 lần liên tiếp → SENSOR_FAULT</a:t>
+              <a:t>Lỗi 3 lần liền → báo hỏng (SENSOR_FAULT)</a:t>
             </a:r>
             <a:endParaRPr lang="en-US" sz="1300" dirty="0"/>
           </a:p>
@@ -4752,7 +5055,7 @@
                   <a:schemeClr val="tx2"/>
                 </a:solidFill>
               </a:rPr>
-              <a:t>Control Task</a:t>
+              <a:t>2. Điều khiển an toàn</a:t>
             </a:r>
             <a:endParaRPr lang="en-US" sz="1600" dirty="0"/>
           </a:p>
@@ -4792,7 +5095,7 @@
                   <a:schemeClr val="tx1"/>
                 </a:solidFill>
               </a:rPr>
-              <a:t>Máy trạng thái (FSM) cho bơm phun</a:t>
+              <a:t>Bơm chạy theo các trạng thái bên dưới</a:t>
             </a:r>
             <a:endParaRPr lang="en-US" sz="1300" dirty="0"/>
           </a:p>
@@ -4810,7 +5113,7 @@
                   <a:schemeClr val="tx1"/>
                 </a:solidFill>
               </a:rPr>
-              <a:t>Nước cạn (ADC &lt; 1200): ngắt bơm, từ chối mọi lệnh bật phun</a:t>
+              <a:t>Bình cạn: tắt bơm, không cho bật phun kể cả lệnh từ xa</a:t>
             </a:r>
             <a:endParaRPr lang="en-US" sz="1300" dirty="0"/>
           </a:p>
@@ -4828,7 +5131,7 @@
                   <a:schemeClr val="tx1"/>
                 </a:solidFill>
               </a:rPr>
-              <a:t>Lệnh tay có TTL, hết giờ tự về AUTO</a:t>
+              <a:t>Lệnh bấm tay có hạn, hết giờ tự về tự động</a:t>
             </a:r>
             <a:endParaRPr lang="en-US" sz="1300" dirty="0"/>
           </a:p>
@@ -4864,7 +5167,7 @@
                   <a:schemeClr val="accent5"/>
                 </a:solidFill>
               </a:rPr>
-              <a:t>FSM bơm phun sương</a:t>
+              <a:t>Các trạng thái của bơm phun sương</a:t>
             </a:r>
             <a:endParaRPr lang="en-US" sz="1300" dirty="0"/>
           </a:p>
@@ -4935,7 +5238,43 @@
       </p:sp>
       <p:sp>
         <p:nvSpPr>
-          <p:cNvPr id="40" name="p1-fsm-arrow0"/>
+          <p:cNvPr id="40" name="p1-fsm-IDLE-vi"/>
+          <p:cNvSpPr txBox="1"/>
+          <p:nvPr/>
+        </p:nvSpPr>
+        <p:spPr>
+          <a:xfrm>
+            <a:off x="6035040" y="5532120"/>
+            <a:ext cx="1463040" cy="274320"/>
+          </a:xfrm>
+          <a:prstGeom prst="rect">
+            <a:avLst/>
+          </a:prstGeom>
+          <a:noFill/>
+          <a:ln/>
+        </p:spPr>
+        <p:txBody>
+          <a:bodyPr wrap="square" lIns="0" tIns="0" rIns="0" bIns="0" rtlCol="0" anchor="t"/>
+          <a:lstStyle/>
+          <a:p>
+            <a:pPr algn="ctr" indent="0" marL="0">
+              <a:buNone/>
+            </a:pPr>
+            <a:r>
+              <a:rPr lang="en-US" sz="1200" dirty="0">
+                <a:solidFill>
+                  <a:schemeClr val="accent5"/>
+                </a:solidFill>
+              </a:rPr>
+              <a:t>chờ</a:t>
+            </a:r>
+            <a:endParaRPr lang="en-US" sz="1200" dirty="0"/>
+          </a:p>
+        </p:txBody>
+      </p:sp>
+      <p:sp>
+        <p:nvSpPr>
+          <p:cNvPr id="41" name="p1-fsm-arrow0"/>
           <p:cNvSpPr/>
           <p:nvPr/>
         </p:nvSpPr>
@@ -4960,7 +5299,7 @@
       </p:sp>
       <p:sp>
         <p:nvSpPr>
-          <p:cNvPr id="41" name="p1-fsm-RUNNING"/>
+          <p:cNvPr id="42" name="p1-fsm-RUNNING"/>
           <p:cNvSpPr/>
           <p:nvPr/>
         </p:nvSpPr>
@@ -4987,7 +5326,7 @@
       </p:sp>
       <p:sp>
         <p:nvSpPr>
-          <p:cNvPr id="42" name="p1-fsm-RUNNING-text"/>
+          <p:cNvPr id="43" name="p1-fsm-RUNNING-text"/>
           <p:cNvSpPr txBox="1"/>
           <p:nvPr/>
         </p:nvSpPr>
@@ -5023,7 +5362,43 @@
       </p:sp>
       <p:sp>
         <p:nvSpPr>
-          <p:cNvPr id="43" name="p1-fsm-arrow1"/>
+          <p:cNvPr id="44" name="p1-fsm-RUNNING-vi"/>
+          <p:cNvSpPr txBox="1"/>
+          <p:nvPr/>
+        </p:nvSpPr>
+        <p:spPr>
+          <a:xfrm>
+            <a:off x="7955280" y="5532120"/>
+            <a:ext cx="1463040" cy="274320"/>
+          </a:xfrm>
+          <a:prstGeom prst="rect">
+            <a:avLst/>
+          </a:prstGeom>
+          <a:noFill/>
+          <a:ln/>
+        </p:spPr>
+        <p:txBody>
+          <a:bodyPr wrap="square" lIns="0" tIns="0" rIns="0" bIns="0" rtlCol="0" anchor="t"/>
+          <a:lstStyle/>
+          <a:p>
+            <a:pPr algn="ctr" indent="0" marL="0">
+              <a:buNone/>
+            </a:pPr>
+            <a:r>
+              <a:rPr lang="en-US" sz="1200" dirty="0">
+                <a:solidFill>
+                  <a:schemeClr val="accent5"/>
+                </a:solidFill>
+              </a:rPr>
+              <a:t>đang phun</a:t>
+            </a:r>
+            <a:endParaRPr lang="en-US" sz="1200" dirty="0"/>
+          </a:p>
+        </p:txBody>
+      </p:sp>
+      <p:sp>
+        <p:nvSpPr>
+          <p:cNvPr id="45" name="p1-fsm-arrow1"/>
           <p:cNvSpPr/>
           <p:nvPr/>
         </p:nvSpPr>
@@ -5048,7 +5423,7 @@
       </p:sp>
       <p:sp>
         <p:nvSpPr>
-          <p:cNvPr id="44" name="p1-fsm-COOLDOWN"/>
+          <p:cNvPr id="46" name="p1-fsm-COOLDOWN"/>
           <p:cNvSpPr/>
           <p:nvPr/>
         </p:nvSpPr>
@@ -5075,7 +5450,7 @@
       </p:sp>
       <p:sp>
         <p:nvSpPr>
-          <p:cNvPr id="45" name="p1-fsm-COOLDOWN-text"/>
+          <p:cNvPr id="47" name="p1-fsm-COOLDOWN-text"/>
           <p:cNvSpPr txBox="1"/>
           <p:nvPr/>
         </p:nvSpPr>
@@ -5111,13 +5486,49 @@
       </p:sp>
       <p:sp>
         <p:nvSpPr>
-          <p:cNvPr id="46" name="p1-fsm-back"/>
+          <p:cNvPr id="48" name="p1-fsm-COOLDOWN-vi"/>
           <p:cNvSpPr txBox="1"/>
           <p:nvPr/>
         </p:nvSpPr>
         <p:spPr>
           <a:xfrm>
-            <a:off x="9921240" y="5559552"/>
+            <a:off x="9875520" y="5532120"/>
+            <a:ext cx="1463040" cy="274320"/>
+          </a:xfrm>
+          <a:prstGeom prst="rect">
+            <a:avLst/>
+          </a:prstGeom>
+          <a:noFill/>
+          <a:ln/>
+        </p:spPr>
+        <p:txBody>
+          <a:bodyPr wrap="square" lIns="0" tIns="0" rIns="0" bIns="0" rtlCol="0" anchor="t"/>
+          <a:lstStyle/>
+          <a:p>
+            <a:pPr algn="ctr" indent="0" marL="0">
+              <a:buNone/>
+            </a:pPr>
+            <a:r>
+              <a:rPr lang="en-US" sz="1200" dirty="0">
+                <a:solidFill>
+                  <a:schemeClr val="accent5"/>
+                </a:solidFill>
+              </a:rPr>
+              <a:t>nghỉ cho bơm</a:t>
+            </a:r>
+            <a:endParaRPr lang="en-US" sz="1200" dirty="0"/>
+          </a:p>
+        </p:txBody>
+      </p:sp>
+      <p:sp>
+        <p:nvSpPr>
+          <p:cNvPr id="49" name="p1-fsm-back"/>
+          <p:cNvSpPr txBox="1"/>
+          <p:nvPr/>
+        </p:nvSpPr>
+        <p:spPr>
+          <a:xfrm>
+            <a:off x="9921240" y="4709160"/>
             <a:ext cx="1691640" cy="274320"/>
           </a:xfrm>
           <a:prstGeom prst="rect">
@@ -5139,7 +5550,7 @@
                   <a:schemeClr val="accent5"/>
                 </a:solidFill>
               </a:rPr>
-              <a:t>hết giờ nghỉ → IDLE</a:t>
+              <a:t>nghỉ xong → quay về chờ</a:t>
             </a:r>
             <a:endParaRPr lang="en-US" sz="1100" dirty="0"/>
           </a:p>
@@ -5147,7 +5558,7 @@
       </p:sp>
       <p:sp>
         <p:nvSpPr>
-          <p:cNvPr id="47" name="p1-fsm-fault"/>
+          <p:cNvPr id="50" name="p1-fsm-fault"/>
           <p:cNvSpPr/>
           <p:nvPr/>
         </p:nvSpPr>
@@ -5174,7 +5585,7 @@
       </p:sp>
       <p:sp>
         <p:nvSpPr>
-          <p:cNvPr id="48" name="p1-fsm-fault-text"/>
+          <p:cNvPr id="51" name="p1-fsm-fault-text"/>
           <p:cNvSpPr txBox="1"/>
           <p:nvPr/>
         </p:nvSpPr>
@@ -5202,7 +5613,7 @@
                   <a:schemeClr val="accent4"/>
                 </a:solidFill>
               </a:rPr>
-              <a:t>WATER_LOCKOUT</a:t>
+              <a:t>Cạn nước</a:t>
             </a:r>
             <a:pPr indent="0" marL="0">
               <a:buNone/>
@@ -5224,7 +5635,7 @@
                   <a:schemeClr val="accent4"/>
                 </a:solidFill>
               </a:rPr>
-              <a:t>SENSOR_FAULT</a:t>
+              <a:t>hỏng cảm biến</a:t>
             </a:r>
             <a:pPr indent="0" marL="0">
               <a:buNone/>
@@ -5235,7 +5646,7 @@
                   <a:schemeClr val="tx1"/>
                 </a:solidFill>
               </a:rPr>
-              <a:t>: vào từ mọi trạng thái, bơm tắt ngay</a:t>
+              <a:t>: bơm tắt ngay, dù đang ở trạng thái nào</a:t>
             </a:r>
             <a:endParaRPr lang="en-US" sz="1300" dirty="0"/>
           </a:p>
@@ -5346,7 +5757,7 @@
                 <a:ea typeface="Cambria" pitchFamily="34" charset="-122"/>
                 <a:cs typeface="Cambria" pitchFamily="34" charset="-120"/>
               </a:rPr>
-              <a:t>Part 2: MQTT Services on Server</a:t>
+              <a:t>Phần 2: Truyền tin qua MQTT</a:t>
             </a:r>
             <a:endParaRPr lang="en-US" sz="3200" dirty="0"/>
           </a:p>
@@ -5384,7 +5795,7 @@
                   <a:schemeClr val="accent5"/>
                 </a:solidFill>
               </a:rPr>
-              <a:t>Tầng truyền thông trung gian qua broker broker.emqx.io:1883 · tiền tố topic garden/orchid/orchid-01/</a:t>
+              <a:t>MQTT giống một bưu điện: ESP32 và server gửi tin qua broker broker.emqx.io, mỗi loại tin có một địa chỉ riêng (topic)</a:t>
             </a:r>
             <a:endParaRPr lang="en-US" sz="1600" dirty="0"/>
           </a:p>
@@ -5496,7 +5907,7 @@
                   <a:schemeClr val="tx2"/>
                 </a:solidFill>
               </a:rPr>
-              <a:t>1) Keep-Alive &amp; Availability</a:t>
+              <a:t>1) Báo thiết bị còn hoạt động</a:t>
             </a:r>
             <a:endParaRPr lang="en-US" sz="1400" dirty="0"/>
           </a:p>
@@ -5510,7 +5921,7 @@
                   <a:schemeClr val="accent5"/>
                 </a:solidFill>
               </a:rPr>
-              <a:t>Giám sát trạm ESP32 còn sống hay không; báo ngay khi mất nguồn, mất mạng</a:t>
+              <a:t>Server luôn biết ESP32 đang chạy hay đã mất kết nối</a:t>
             </a:r>
             <a:endParaRPr lang="en-US" sz="1400" dirty="0"/>
           </a:p>
@@ -5566,7 +5977,7 @@
                   <a:schemeClr val="tx1"/>
                 </a:solidFill>
               </a:rPr>
-              <a:t>  ESP32 publish "online" (retained)</a:t>
+              <a:t>  ESP32 báo "online" khi vừa kết nối</a:t>
             </a:r>
             <a:endParaRPr lang="en-US" sz="1400" dirty="0"/>
           </a:p>
@@ -5600,7 +6011,7 @@
                   <a:schemeClr val="tx1"/>
                 </a:solidFill>
               </a:rPr>
-              <a:t>  Broker tự phát "offline" khi TCP đứt đột ngột</a:t>
+              <a:t>  ESP32 mất điện, mất mạng đột ngột: broker tự báo "offline" thay nó</a:t>
             </a:r>
             <a:endParaRPr lang="en-US" sz="1400" dirty="0"/>
           </a:p>
@@ -5634,7 +6045,7 @@
                   <a:schemeClr val="tx1"/>
                 </a:solidFill>
               </a:rPr>
-              <a:t>  Hiện ONLINE / STALE (&gt; 15 s không có tin) / OFFLINE</a:t>
+              <a:t>  Quá 15 giây không có dữ liệu mới: báo STALE (dữ liệu cũ)</a:t>
             </a:r>
             <a:endParaRPr lang="en-US" sz="1400" dirty="0"/>
           </a:p>
@@ -5746,7 +6157,7 @@
                   <a:schemeClr val="tx2"/>
                 </a:solidFill>
               </a:rPr>
-              <a:t>2) Collect (Sensors Data)</a:t>
+              <a:t>2) Gửi số đo cảm biến</a:t>
             </a:r>
             <a:endParaRPr lang="en-US" sz="1400" dirty="0"/>
           </a:p>
@@ -5760,7 +6171,7 @@
                   <a:schemeClr val="accent5"/>
                 </a:solidFill>
               </a:rPr>
-              <a:t>Nhận dữ liệu cảm biến định kỳ và trạng thái thực của relay</a:t>
+              <a:t>Đưa số đo và tình trạng thiết bị lên server</a:t>
             </a:r>
             <a:endParaRPr lang="en-US" sz="1400" dirty="0"/>
           </a:p>
@@ -5816,7 +6227,7 @@
                   <a:schemeClr val="tx1"/>
                 </a:solidFill>
               </a:rPr>
-              <a:t>  Mỗi 2,5 s: temperature_c, humidity_pct, light_adc, water_adc</a:t>
+              <a:t>  Cứ 2,5 giây gửi nhiệt độ, độ ẩm, ánh sáng, mực nước</a:t>
             </a:r>
             <a:endParaRPr lang="en-US" sz="1400" dirty="0"/>
           </a:p>
@@ -5850,7 +6261,7 @@
                   <a:schemeClr val="tx1"/>
                 </a:solidFill>
               </a:rPr>
-              <a:t>  Trạng thái relay, FSM, ngưỡng (retained)</a:t>
+              <a:t>  Bơm, quạt, đèn đang bật hay tắt; chế độ tự động hay bấm tay</a:t>
             </a:r>
             <a:endParaRPr lang="en-US" sz="1400" dirty="0"/>
           </a:p>
@@ -5884,7 +6295,7 @@
                   <a:schemeClr val="tx1"/>
                 </a:solidFill>
               </a:rPr>
-              <a:t>  Subscribe, bóc tách JSON, cập nhật dashboard</a:t>
+              <a:t>  Nhận tin và cập nhật lên dashboard</a:t>
             </a:r>
             <a:endParaRPr lang="en-US" sz="1400" dirty="0"/>
           </a:p>
@@ -5996,7 +6407,7 @@
                   <a:schemeClr val="tx2"/>
                 </a:solidFill>
               </a:rPr>
-              <a:t>3) Control &amp; Safety</a:t>
+              <a:t>3) Điều khiển có xác nhận</a:t>
             </a:r>
             <a:endParaRPr lang="en-US" sz="1400" dirty="0"/>
           </a:p>
@@ -6010,7 +6421,7 @@
                   <a:schemeClr val="accent5"/>
                 </a:solidFill>
               </a:rPr>
-              <a:t>Gửi lệnh điều khiển hai chiều và nhận xác nhận (ACK)</a:t>
+              <a:t>Gửi lệnh bật/tắt xuống và chờ ESP32 trả lời đã làm chưa (ACK)</a:t>
             </a:r>
             <a:endParaRPr lang="en-US" sz="1400" dirty="0"/>
           </a:p>
@@ -6052,7 +6463,7 @@
                 <a:ea typeface="Courier New" pitchFamily="34" charset="-122"/>
                 <a:cs typeface="Courier New" pitchFamily="34" charset="-120"/>
               </a:rPr>
-              <a:t>cmd/mist|fan|light</a:t>
+              <a:t>cmd/…</a:t>
             </a:r>
             <a:pPr indent="0" marL="0">
               <a:spcAft>
@@ -6066,7 +6477,7 @@
                   <a:schemeClr val="tx1"/>
                 </a:solidFill>
               </a:rPr>
-              <a:t>  request_id, mode (AUTO/MANUAL), state, ttl_s</a:t>
+              <a:t>  Lệnh gồm: mã lệnh, chế độ, bật hay tắt, thời hạn</a:t>
             </a:r>
             <a:endParaRPr lang="en-US" sz="1400" dirty="0"/>
           </a:p>
@@ -6100,7 +6511,7 @@
                   <a:schemeClr val="tx1"/>
                 </a:solidFill>
               </a:rPr>
-              <a:t>  APPLIED hoặc REJECTED: WATER_LOCKOUT, MIST_COOLDOWN, SENSOR_FAULT</a:t>
+              <a:t>  ESP32 trả lời: đã làm (APPLIED) hoặc từ chối kèm lý do, ví dụ đang cạn nước</a:t>
             </a:r>
             <a:endParaRPr lang="en-US" sz="1400" dirty="0"/>
           </a:p>
@@ -6134,7 +6545,7 @@
                   <a:schemeClr val="tx1"/>
                 </a:solidFill>
               </a:rPr>
-              <a:t>  Ghép theo request_id; quá 6 s báo NO_ACK</a:t>
+              <a:t>  Quá 6 giây không có trả lời: báo NO_ACK</a:t>
             </a:r>
             <a:endParaRPr lang="en-US" sz="1400" dirty="0"/>
           </a:p>
@@ -6246,7 +6657,7 @@
                   <a:schemeClr val="tx2"/>
                 </a:solidFill>
               </a:rPr>
-              <a:t>4) Dynamic Config</a:t>
+              <a:t>4) Đổi ngưỡng từ xa</a:t>
             </a:r>
             <a:endParaRPr lang="en-US" sz="1400" dirty="0"/>
           </a:p>
@@ -6260,7 +6671,7 @@
                   <a:schemeClr val="accent5"/>
                 </a:solidFill>
               </a:rPr>
-              <a:t>Đổi ngưỡng nhiệt độ, độ ẩm, ánh sáng, mực nước từ xa, không cần nạp lại code</a:t>
+              <a:t>Chỉnh mức độ ẩm, nhiệt độ, ánh sáng, nước mà không phải nạp lại chương trình</a:t>
             </a:r>
             <a:endParaRPr lang="en-US" sz="1400" dirty="0"/>
           </a:p>
@@ -6316,7 +6727,7 @@
                   <a:schemeClr val="tx1"/>
                 </a:solidFill>
               </a:rPr>
-              <a:t>  Server gửi ngưỡng mới; ACK APPLIED CONFIG</a:t>
+              <a:t>  Server gửi ngưỡng mới, ESP32 trả lời đã áp dụng</a:t>
             </a:r>
             <a:endParaRPr lang="en-US" sz="1400" dirty="0"/>
           </a:p>
@@ -6336,7 +6747,7 @@
                 <a:ea typeface="Courier New" pitchFamily="34" charset="-122"/>
                 <a:cs typeface="Courier New" pitchFamily="34" charset="-120"/>
               </a:rPr>
-              <a:t>ConfigLimits</a:t>
+              <a:t>giới hạn</a:t>
             </a:r>
             <a:pPr indent="0" marL="0">
               <a:spcAft>
@@ -6350,7 +6761,7 @@
                   <a:schemeClr val="tx1"/>
                 </a:solidFill>
               </a:rPr>
-              <a:t>  Firmware chặn ngưỡng ngoài vùng an toàn (cạn nước không thấp hơn 1200)</a:t>
+              <a:t>  ESP32 từ chối ngưỡng nguy hiểm, ví dụ mức báo cạn nước không được dưới 1200</a:t>
             </a:r>
             <a:endParaRPr lang="en-US" sz="1400" dirty="0"/>
           </a:p>
@@ -6461,7 +6872,7 @@
                 <a:ea typeface="Cambria" pitchFamily="34" charset="-122"/>
                 <a:cs typeface="Cambria" pitchFamily="34" charset="-120"/>
               </a:rPr>
-              <a:t>Part 3: Web Server App – Giám sát và dữ liệu</a:t>
+              <a:t>Phần 3: Ứng dụng web – Theo dõi và lưu dữ liệu</a:t>
             </a:r>
             <a:endParaRPr lang="en-US" sz="3200" dirty="0"/>
           </a:p>
@@ -6499,7 +6910,7 @@
                   <a:schemeClr val="accent5"/>
                 </a:solidFill>
               </a:rPr>
-              <a:t>Node-RED middleware + Dashboard 2.0: điều hành trung tâm, giám sát thời gian thực</a:t>
+              <a:t>Node-RED là phần mềm trung tâm trên server: nhận dữ liệu, chạy luật tự động và tạo trang dashboard</a:t>
             </a:r>
             <a:endParaRPr lang="en-US" sz="1600" dirty="0"/>
           </a:p>
@@ -6587,7 +6998,7 @@
                 <a:ea typeface="Cambria" pitchFamily="34" charset="-122"/>
                 <a:cs typeface="Cambria" pitchFamily="34" charset="-120"/>
               </a:rPr>
-              <a:t>1. Data Representation</a:t>
+              <a:t>1. Hiển thị dữ liệu</a:t>
             </a:r>
             <a:endParaRPr lang="en-US" sz="2000" dirty="0"/>
           </a:p>
@@ -6627,7 +7038,7 @@
                   <a:schemeClr val="tx1"/>
                 </a:solidFill>
               </a:rPr>
-              <a:t>Dashboard 2.0 dùng được trên PC và điện thoại</a:t>
+              <a:t>Mở được trên máy tính và điện thoại</a:t>
             </a:r>
             <a:endParaRPr lang="en-US" sz="1500" dirty="0"/>
           </a:p>
@@ -6645,7 +7056,7 @@
                   <a:schemeClr val="tx1"/>
                 </a:solidFill>
               </a:rPr>
-              <a:t>Ô số trực tiếp: nhiệt độ (°C), độ ẩm (%), ADC ánh sáng, ADC nước</a:t>
+              <a:t>Số đo trực tiếp: nhiệt độ (°C), độ ẩm (%), ánh sáng, mực nước</a:t>
             </a:r>
             <a:endParaRPr lang="en-US" sz="1500" dirty="0"/>
           </a:p>
@@ -6663,7 +7074,7 @@
                   <a:schemeClr val="tx1"/>
                 </a:solidFill>
               </a:rPr>
-              <a:t>2 biểu đồ lịch sử 1 giờ: nhiệt độ/độ ẩm và ánh sáng/nước</a:t>
+              <a:t>2 biểu đồ cho thấy diễn biến trong 1 giờ gần nhất</a:t>
             </a:r>
             <a:endParaRPr lang="en-US" sz="1500" dirty="0"/>
           </a:p>
@@ -6681,7 +7092,7 @@
                   <a:schemeClr val="tx1"/>
                 </a:solidFill>
               </a:rPr>
-              <a:t>DHT hỏng hiện "DHT fault", không hiện số 0 giả</a:t>
+              <a:t>Cảm biến hỏng thì hiện chữ "DHT fault", không hiện số sai</a:t>
             </a:r>
             <a:endParaRPr lang="en-US" sz="1500" dirty="0"/>
           </a:p>
@@ -6816,7 +7227,7 @@
                   <a:schemeClr val="accent5"/>
                 </a:solidFill>
               </a:rPr>
-              <a:t>có telemetry mới</a:t>
+              <a:t>đang nhận dữ liệu</a:t>
             </a:r>
             <a:endParaRPr lang="en-US" sz="1100" dirty="0"/>
           </a:p>
@@ -6915,7 +7326,7 @@
                   <a:schemeClr val="accent5"/>
                 </a:solidFill>
               </a:rPr>
-              <a:t>&gt; 15 s không có tin</a:t>
+              <a:t>15 s chưa có số mới</a:t>
             </a:r>
             <a:endParaRPr lang="en-US" sz="1100" dirty="0"/>
           </a:p>
@@ -7014,7 +7425,7 @@
                   <a:schemeClr val="accent5"/>
                 </a:solidFill>
               </a:rPr>
-              <a:t>LWT từ broker</a:t>
+              <a:t>thiết bị mất kết nối</a:t>
             </a:r>
             <a:endParaRPr lang="en-US" sz="1100" dirty="0"/>
           </a:p>
@@ -7129,7 +7540,7 @@
                 <a:ea typeface="Cambria" pitchFamily="34" charset="-122"/>
                 <a:cs typeface="Cambria" pitchFamily="34" charset="-120"/>
               </a:rPr>
-              <a:t>2. Data Management</a:t>
+              <a:t>2. Lưu nhật ký</a:t>
             </a:r>
             <a:endParaRPr lang="en-US" sz="2000" dirty="0"/>
           </a:p>
@@ -7165,7 +7576,7 @@
                   <a:schemeClr val="accent5"/>
                 </a:solidFill>
               </a:rPr>
-              <a:t>Không dùng database nặng: ghi sự kiện nối tiếp (event stream) vào một file JSON Lines</a:t>
+              <a:t>Không cần cơ sở dữ liệu: mọi sự kiện được ghi nối tiếp vào một file nhật ký</a:t>
             </a:r>
             <a:endParaRPr lang="en-US" sz="1400" dirty="0"/>
           </a:p>
@@ -7271,7 +7682,7 @@
                   <a:schemeClr val="tx1"/>
                 </a:solidFill>
               </a:rPr>
-              <a:t>Mỗi dòng một sự kiện: thời gian, request_id, người bấm, kết quả ACK, độ trễ (ms)</a:t>
+              <a:t>Mỗi dòng một sự kiện: lúc nào, ai bấm, lệnh gì, kết quả, mất bao lâu</a:t>
             </a:r>
             <a:endParaRPr lang="en-US" sz="1400" dirty="0"/>
           </a:p>
@@ -7289,7 +7700,7 @@
                   <a:schemeClr val="tx1"/>
                 </a:solidFill>
               </a:rPr>
-              <a:t>Sự kiện an toàn: lỗi cảm biến, cạn nước, mất kết nối</a:t>
+              <a:t>Ghi cả sự cố: cảm biến hỏng, cạn nước, mất kết nối</a:t>
             </a:r>
             <a:endParaRPr lang="en-US" sz="1400" dirty="0"/>
           </a:p>
@@ -7307,7 +7718,7 @@
                   <a:schemeClr val="tx1"/>
                 </a:solidFill>
               </a:rPr>
-              <a:t>Là nguồn dữ liệu đối chiếu khi nghiệm thu M4 (log lệnh, độ trễ)</a:t>
+              <a:t>Dùng làm bằng chứng khi nghiệm thu và khi tìm lỗi</a:t>
             </a:r>
             <a:endParaRPr lang="en-US" sz="1400" dirty="0"/>
           </a:p>
@@ -7418,7 +7829,7 @@
                 <a:ea typeface="Cambria" pitchFamily="34" charset="-122"/>
                 <a:cs typeface="Cambria" pitchFamily="34" charset="-120"/>
               </a:rPr>
-              <a:t>Part 3: Web Server App – Điều khiển và tự động hóa</a:t>
+              <a:t>Phần 3: Ứng dụng web – Điều khiển và tự động</a:t>
             </a:r>
             <a:endParaRPr lang="en-US" sz="3200" dirty="0"/>
           </a:p>
@@ -7456,7 +7867,7 @@
                   <a:schemeClr val="accent5"/>
                 </a:solidFill>
               </a:rPr>
-              <a:t>Giao diện điều khiển có khóa an toàn, phân quyền, luật tự động và cảnh báo</a:t>
+              <a:t>Người dùng bấm điều khiển được, nhưng hệ thống tự khóa những thao tác có thể gây hại cho lan</a:t>
             </a:r>
             <a:endParaRPr lang="en-US" sz="1600" dirty="0"/>
           </a:p>
@@ -7544,7 +7955,7 @@
                 <a:ea typeface="Cambria" pitchFamily="34" charset="-122"/>
                 <a:cs typeface="Cambria" pitchFamily="34" charset="-120"/>
               </a:rPr>
-              <a:t>3. Control GUI &amp; Security</a:t>
+              <a:t>3. Điều khiển và phân quyền</a:t>
             </a:r>
             <a:endParaRPr lang="en-US" sz="2000" dirty="0"/>
           </a:p>
@@ -7584,7 +7995,7 @@
                   <a:schemeClr val="tx1"/>
                 </a:solidFill>
               </a:rPr>
-              <a:t>AUTO (theo luật) / MANUAL (lệnh tay có hạn 1–60 phút)</a:t>
+              <a:t>AUTO: hệ thống tự làm theo luật. MANUAL: người dùng bấm tay, có hạn 1–60 phút</a:t>
             </a:r>
             <a:endParaRPr lang="en-US" sz="1500" dirty="0"/>
           </a:p>
@@ -7602,7 +8013,7 @@
                   <a:schemeClr val="tx1"/>
                 </a:solidFill>
               </a:rPr>
-              <a:t>Khóa mọi nút khi đang AUTO hoặc thiết bị không ONLINE</a:t>
+              <a:t>Đang AUTO hoặc thiết bị mất kết nối: khóa hết nút bấm</a:t>
             </a:r>
             <a:endParaRPr lang="en-US" sz="1500" dirty="0"/>
           </a:p>
@@ -7620,7 +8031,7 @@
                   <a:schemeClr val="tx1"/>
                 </a:solidFill>
               </a:rPr>
-              <a:t>Khóa riêng Mist ON khi WATER_LOCKOUT, COOLDOWN hoặc SENSOR_FAULT</a:t>
+              <a:t>Cạn nước, bơm đang nghỉ hoặc cảm biến hỏng: khóa riêng nút bật phun</a:t>
             </a:r>
             <a:endParaRPr lang="en-US" sz="1500" dirty="0"/>
           </a:p>
@@ -7638,7 +8049,7 @@
                   <a:schemeClr val="tx1"/>
                 </a:solidFill>
               </a:rPr>
-              <a:t>Khóa nút đang chờ ACK, mỗi relay chỉ một lệnh chờ</a:t>
+              <a:t>Bấm xong phải chờ ESP32 xác nhận mới bấm tiếp được</a:t>
             </a:r>
             <a:endParaRPr lang="en-US" sz="1500" dirty="0"/>
           </a:p>
@@ -7751,7 +8162,7 @@
                   <a:schemeClr val="tx1"/>
                 </a:solidFill>
               </a:rPr>
-              <a:t>toàn quyền, sửa flow</a:t>
+              <a:t>toàn quyền, sửa cấu hình</a:t>
             </a:r>
             <a:endParaRPr lang="en-US" sz="1400" dirty="0"/>
           </a:p>
@@ -7828,7 +8239,7 @@
                   <a:schemeClr val="tx1"/>
                 </a:solidFill>
               </a:rPr>
-              <a:t>vận hành, gửi lệnh</a:t>
+              <a:t>được bấm điều khiển</a:t>
             </a:r>
             <a:endParaRPr lang="en-US" sz="1400" dirty="0"/>
           </a:p>
@@ -7905,7 +8316,7 @@
                   <a:schemeClr val="tx1"/>
                 </a:solidFill>
               </a:rPr>
-              <a:t>chỉ xem, bị chặn lệnh</a:t>
+              <a:t>chỉ được xem</a:t>
             </a:r>
             <a:endParaRPr lang="en-US" sz="1400" dirty="0"/>
           </a:p>
@@ -7993,7 +8404,7 @@
                 <a:ea typeface="Cambria" pitchFamily="34" charset="-122"/>
                 <a:cs typeface="Cambria" pitchFamily="34" charset="-120"/>
               </a:rPr>
-              <a:t>4. Data Analysis &amp; Business Rules</a:t>
+              <a:t>4. Luật tự động</a:t>
             </a:r>
             <a:endParaRPr lang="en-US" sz="2000" dirty="0"/>
           </a:p>
@@ -8105,7 +8516,7 @@
                   <a:schemeClr val="tx2"/>
                 </a:solidFill>
               </a:rPr>
-              <a:t>Rule 1 – Đèn theo chu kỳ sinh học</a:t>
+              <a:t>Luật 1 – Đèn bù sáng</a:t>
             </a:r>
             <a:endParaRPr lang="en-US" sz="1400" dirty="0"/>
           </a:p>
@@ -8119,7 +8530,7 @@
                   <a:schemeClr val="tx1"/>
                 </a:solidFill>
               </a:rPr>
-              <a:t>Bật trong 06:00–21:00 khi trời tối (light_adc &gt; 2200), tắt khi đủ sáng; không bật ban đêm, tối đa 240 phút/ngày</a:t>
+              <a:t>Chỉ bật từ 06:00 đến 21:00 khi trời tối, tắt khi đủ sáng. Ban đêm không bật để lan nghỉ; tối đa 4 giờ/ngày</a:t>
             </a:r>
             <a:endParaRPr lang="en-US" sz="1400" dirty="0"/>
           </a:p>
@@ -8231,7 +8642,7 @@
                   <a:schemeClr val="tx2"/>
                 </a:solidFill>
               </a:rPr>
-              <a:t>Rule 2 – Quạt sau phun sương</a:t>
+              <a:t>Luật 2 – Quạt sau khi phun</a:t>
             </a:r>
             <a:endParaRPr lang="en-US" sz="1400" dirty="0"/>
           </a:p>
@@ -8245,7 +8656,7 @@
                   <a:schemeClr val="tx1"/>
                 </a:solidFill>
               </a:rPr>
-              <a:t>Bơm vừa ngắt thì quạt chạy 60 s để hong ráo nước đọng trên lá, giảm nguy cơ thối nõn</a:t>
+              <a:t>Phun xong, quạt chạy 60 giây cho lá khô, tránh thối nõn và nấm</a:t>
             </a:r>
             <a:endParaRPr lang="en-US" sz="1400" dirty="0"/>
           </a:p>
@@ -8357,7 +8768,7 @@
                   <a:schemeClr val="tx2"/>
                 </a:solidFill>
               </a:rPr>
-              <a:t>Cảnh báo Telegram</a:t>
+              <a:t>Cảnh báo qua Telegram</a:t>
             </a:r>
             <a:endParaRPr lang="en-US" sz="1400" dirty="0"/>
           </a:p>
@@ -8371,7 +8782,7 @@
                   <a:schemeClr val="tx1"/>
                 </a:solidFill>
               </a:rPr>
-              <a:t>Gửi vào nhóm chat khi cạn nước hoặc mất kết nối quá 5 phút</a:t>
+              <a:t>Nhắn vào nhóm chat khi bình cạn nước hoặc thiết bị mất kết nối quá 5 phút</a:t>
             </a:r>
             <a:endParaRPr lang="en-US" sz="1400" dirty="0"/>
           </a:p>
@@ -8520,7 +8931,7 @@
                   <a:srgbClr val="CFE3D6"/>
                 </a:solidFill>
               </a:rPr>
-              <a:t>Hệ thống chạy ổn định hai chiều, kiểm chứng trên mô phỏng Wokwi với broker và dashboard thật</a:t>
+              <a:t>Dữ liệu đi lên và lệnh đi xuống đều chạy ổn định, kiểm chứng trên mô phỏng Wokwi với broker và dashboard thật</a:t>
             </a:r>
             <a:endParaRPr lang="en-US" sz="1800" dirty="0"/>
           </a:p>
@@ -8595,7 +9006,7 @@
                   <a:srgbClr val="CFE3D6"/>
                 </a:solidFill>
               </a:rPr>
-              <a:t>gói telemetry khớp Serial trong 12 phút uplink</a:t>
+              <a:t>lần đo gửi lên server khớp đúng số trên thiết bị (chạy liên tục 12 phút)</a:t>
             </a:r>
             <a:endParaRPr lang="en-US" sz="1400" dirty="0"/>
           </a:p>
@@ -8670,7 +9081,7 @@
                   <a:srgbClr val="CFE3D6"/>
                 </a:solidFill>
               </a:rPr>
-              <a:t>ca downlink đạt: AUTO/MANUAL, LOCKOUT, lệnh lặp, mất kết nối</a:t>
+              <a:t>tình huống điều khiển chạy đúng, kể cả lúc cạn nước và mất mạng</a:t>
             </a:r>
             <a:endParaRPr lang="en-US" sz="1400" dirty="0"/>
           </a:p>
@@ -8745,7 +9156,7 @@
                   <a:srgbClr val="CFE3D6"/>
                 </a:solidFill>
               </a:rPr>
-              <a:t>vòng chạy lặp M4 liên tiếp, kết quả giống hệt nhau</a:t>
+              <a:t>lần chạy lại toàn bộ đều đạt, kết quả giống nhau</a:t>
             </a:r>
             <a:endParaRPr lang="en-US" sz="1400" dirty="0"/>
           </a:p>
@@ -8820,7 +9231,7 @@
                   <a:srgbClr val="CFE3D6"/>
                 </a:solidFill>
               </a:rPr>
-              <a:t>từ lúc bấm nút đến khi dashboard nhận ACK</a:t>
+              <a:t>từ lúc bấm nút đến khi thấy thiết bị xác nhận</a:t>
             </a:r>
             <a:endParaRPr lang="en-US" sz="1400" dirty="0"/>
           </a:p>
@@ -8944,7 +9355,7 @@
                   <a:schemeClr val="bg1"/>
                 </a:solidFill>
               </a:rPr>
-              <a:t>Chạy trên board ESP32-S3 thật (phần Bonus)</a:t>
+              <a:t>Chạy trên board ESP32-S3 thật thay cho mô phỏng</a:t>
             </a:r>
             <a:endParaRPr lang="en-US" sz="1400" dirty="0"/>
           </a:p>
@@ -9029,7 +9440,7 @@
                   <a:schemeClr val="bg1"/>
                 </a:solidFill>
               </a:rPr>
-              <a:t>Broker riêng có mật khẩu và TLS thay broker công khai</a:t>
+              <a:t>Dùng broker riêng có mật khẩu và mã hóa</a:t>
             </a:r>
             <a:endParaRPr lang="en-US" sz="1400" dirty="0"/>
           </a:p>
@@ -9114,7 +9525,7 @@
                   <a:schemeClr val="bg1"/>
                 </a:solidFill>
               </a:rPr>
-              <a:t>Lưu dữ liệu dài hạn để thống kê theo mùa</a:t>
+              <a:t>Lưu dữ liệu lâu dài để xem xu hướng theo mùa</a:t>
             </a:r>
             <a:endParaRPr lang="en-US" sz="1400" dirty="0"/>
           </a:p>

</xml_diff>

<commit_message>
docs: ghi chu thuyet trinh chi tiet cho tung slide
Co-Authored-By: Claude Opus 5.5 (1M context) <noreply@anthropic.com>
</commit_message>
<xml_diff>
--- a/docs/kien-truc-he-thong.pptx
+++ b/docs/kien-truc-he-thong.pptx
@@ -4,6 +4,9 @@
   <p:sldMasterIdLst>
     <p:sldMasterId id="2147483648" r:id="rId1"/>
   </p:sldMasterIdLst>
+  <p:notesMasterIdLst>
+    <p:notesMasterId r:id="rId11"/>
+  </p:notesMasterIdLst>
   <p:sldIdLst>
     <p:sldId id="256" r:id="rId2"/>
     <p:sldId id="257" r:id="rId3"/>
@@ -15,9 +18,6 @@
     <p:sldId id="263" r:id="rId9"/>
     <p:sldId id="264" r:id="rId10"/>
   </p:sldIdLst>
-  <p:notesMasterIdLst>
-    <p:notesMasterId r:id="rId11"/>
-  </p:notesMasterIdLst>
   <p:sldSz cx="12192000" cy="6858000"/>
   <p:notesSz cx="6858000" cy="12192000"/>
   <p:defaultTextStyle>
@@ -115,31 +115,31 @@
   <p:extLst>
     <p:ext uri="{521415D9-36F7-43E2-AB2F-B90AF26B5E84}">
       <p14:sectionLst xmlns:p14="http://schemas.microsoft.com/office/powerpoint/2010/main">
-        <p14:section name="Mở đầu" id="{2ebc0e7e-ae78-d958-d459-b037b1fdd22f}">
+        <p14:section name="Mở đầu" id="{2EBC0E7E-AE78-D958-D459-B037B1FDD22F}">
           <p14:sldIdLst>
             <p14:sldId id="256"/>
             <p14:sldId id="257"/>
           </p14:sldIdLst>
         </p14:section>
-        <p14:section name="Part 1: Device" id="{e5beb859-e7e7-3875-74d0-eadaddc483ba}">
+        <p14:section name="Part 1: Device" id="{E5BEB859-E7E7-3875-74D0-EADADDC483BA}">
           <p14:sldIdLst>
             <p14:sldId id="258"/>
             <p14:sldId id="259"/>
           </p14:sldIdLst>
         </p14:section>
-        <p14:section name="Part 2: MQTT" id="{3a2dc56b-8f21-cd53-1f77-f290baffff18}">
+        <p14:section name="Part 2: MQTT" id="{3A2DC56B-8F21-CD53-1F77-F290BAFFFF18}">
           <p14:sldIdLst>
             <p14:sldId id="260"/>
             <p14:sldId id="261"/>
           </p14:sldIdLst>
         </p14:section>
-        <p14:section name="Part 3: Web Server App" id="{d794913b-a080-1b27-bea8-7060063037a5}">
+        <p14:section name="Part 3: Web Server App" id="{D794913B-A080-1B27-BEA8-7060063037A5}">
           <p14:sldIdLst>
             <p14:sldId id="262"/>
             <p14:sldId id="263"/>
           </p14:sldIdLst>
         </p14:section>
-        <p14:section name="Kết luận" id="{6ee9ea24-75e1-4a66-0da0-513be593e2ed}">
+        <p14:section name="Kết luận" id="{6EE9EA24-75E1-4A66-0DA0-513BE593E2ED}">
           <p14:sldIdLst>
             <p14:sldId id="264"/>
           </p14:sldIdLst>
@@ -175,234 +175,10 @@
           <a:chExt cx="0" cy="0"/>
         </a:xfrm>
       </p:grpSpPr>
-      <p:sp>
-        <p:nvSpPr>
-          <p:cNvPr id="2" name="Header Placeholder 1"/>
-          <p:cNvSpPr>
-            <a:spLocks noGrp="1"/>
-          </p:cNvSpPr>
-          <p:nvPr>
-            <p:ph type="hdr" sz="quarter"/>
-          </p:nvPr>
-        </p:nvSpPr>
-        <p:spPr>
-          <a:xfrm>
-            <a:off x="0" y="0"/>
-            <a:ext cx="2971800" cy="458788"/>
-          </a:xfrm>
-          <a:prstGeom prst="rect">
-            <a:avLst/>
-          </a:prstGeom>
-        </p:spPr>
-        <p:txBody>
-          <a:bodyPr vert="horz" lIns="91440" tIns="45720" rIns="91440" bIns="45720" rtlCol="0"/>
-          <a:lstStyle>
-            <a:lvl1pPr algn="l">
-              <a:defRPr sz="1200"/>
-            </a:lvl1pPr>
-          </a:lstStyle>
-          <a:p>
-            <a:endParaRPr lang="en-US"/>
-          </a:p>
-        </p:txBody>
-      </p:sp>
-      <p:sp>
-        <p:nvSpPr>
-          <p:cNvPr id="3" name="Date Placeholder 2"/>
-          <p:cNvSpPr>
-            <a:spLocks noGrp="1"/>
-          </p:cNvSpPr>
-          <p:nvPr>
-            <p:ph type="dt" idx="1"/>
-          </p:nvPr>
-        </p:nvSpPr>
-        <p:spPr>
-          <a:xfrm>
-            <a:off x="3884613" y="0"/>
-            <a:ext cx="2971800" cy="458788"/>
-          </a:xfrm>
-          <a:prstGeom prst="rect">
-            <a:avLst/>
-          </a:prstGeom>
-        </p:spPr>
-        <p:txBody>
-          <a:bodyPr vert="horz" lIns="91440" tIns="45720" rIns="91440" bIns="45720" rtlCol="0"/>
-          <a:lstStyle>
-            <a:lvl1pPr algn="r">
-              <a:defRPr sz="1200"/>
-            </a:lvl1pPr>
-          </a:lstStyle>
-          <a:p>
-            <a:fld id="{5282F153-3F37-0F45-9E97-73ACFA13230C}" type="datetimeFigureOut">
-              <a:rPr lang="en-US"/>
-              <a:t>7/23/19</a:t>
-            </a:fld>
-            <a:endParaRPr lang="en-US"/>
-          </a:p>
-        </p:txBody>
-      </p:sp>
-      <p:sp>
-        <p:nvSpPr>
-          <p:cNvPr id="4" name="Slide Image Placeholder 3"/>
-          <p:cNvSpPr>
-            <a:spLocks noGrp="1" noRot="1" noChangeAspect="1"/>
-          </p:cNvSpPr>
-          <p:nvPr>
-            <p:ph type="sldImg" idx="2"/>
-          </p:nvPr>
-        </p:nvSpPr>
-        <p:spPr>
-          <a:xfrm>
-            <a:off x="685800" y="1143000"/>
-            <a:ext cx="5486400" cy="3086100"/>
-          </a:xfrm>
-          <a:prstGeom prst="rect">
-            <a:avLst/>
-          </a:prstGeom>
-          <a:noFill/>
-          <a:ln w="12700">
-            <a:solidFill>
-              <a:prstClr val="black"/>
-            </a:solidFill>
-          </a:ln>
-        </p:spPr>
-        <p:txBody>
-          <a:bodyPr vert="horz" lIns="91440" tIns="45720" rIns="91440" bIns="45720" rtlCol="0" anchor="ctr"/>
-          <a:lstStyle/>
-          <a:p>
-            <a:endParaRPr lang="en-US"/>
-          </a:p>
-        </p:txBody>
-      </p:sp>
-      <p:sp>
-        <p:nvSpPr>
-          <p:cNvPr id="5" name="Notes Placeholder 4"/>
-          <p:cNvSpPr>
-            <a:spLocks noGrp="1"/>
-          </p:cNvSpPr>
-          <p:nvPr>
-            <p:ph type="body" sz="quarter" idx="3"/>
-          </p:nvPr>
-        </p:nvSpPr>
-        <p:spPr>
-          <a:xfrm>
-            <a:off x="685800" y="4400550"/>
-            <a:ext cx="5486400" cy="3600450"/>
-          </a:xfrm>
-          <a:prstGeom prst="rect">
-            <a:avLst/>
-          </a:prstGeom>
-        </p:spPr>
-        <p:txBody>
-          <a:bodyPr vert="horz" lIns="91440" tIns="45720" rIns="91440" bIns="45720" rtlCol="0"/>
-          <a:lstStyle/>
-          <a:p>
-            <a:pPr lvl="0"/>
-            <a:r>
-              <a:rPr lang="en-US"/>
-              <a:t>Click to edit Master text styles</a:t>
-            </a:r>
-          </a:p>
-          <a:p>
-            <a:pPr lvl="1"/>
-            <a:r>
-              <a:rPr lang="en-US"/>
-              <a:t>Second level</a:t>
-            </a:r>
-          </a:p>
-          <a:p>
-            <a:pPr lvl="2"/>
-            <a:r>
-              <a:rPr lang="en-US"/>
-              <a:t>Third level</a:t>
-            </a:r>
-          </a:p>
-          <a:p>
-            <a:pPr lvl="3"/>
-            <a:r>
-              <a:rPr lang="en-US"/>
-              <a:t>Fourth level</a:t>
-            </a:r>
-          </a:p>
-          <a:p>
-            <a:pPr lvl="4"/>
-            <a:r>
-              <a:rPr lang="en-US"/>
-              <a:t>Fifth level</a:t>
-            </a:r>
-          </a:p>
-        </p:txBody>
-      </p:sp>
-      <p:sp>
-        <p:nvSpPr>
-          <p:cNvPr id="6" name="Footer Placeholder 5"/>
-          <p:cNvSpPr>
-            <a:spLocks noGrp="1"/>
-          </p:cNvSpPr>
-          <p:nvPr>
-            <p:ph type="ftr" sz="quarter" idx="4"/>
-          </p:nvPr>
-        </p:nvSpPr>
-        <p:spPr>
-          <a:xfrm>
-            <a:off x="0" y="8685213"/>
-            <a:ext cx="2971800" cy="458787"/>
-          </a:xfrm>
-          <a:prstGeom prst="rect">
-            <a:avLst/>
-          </a:prstGeom>
-        </p:spPr>
-        <p:txBody>
-          <a:bodyPr vert="horz" lIns="91440" tIns="45720" rIns="91440" bIns="45720" rtlCol="0" anchor="b"/>
-          <a:lstStyle>
-            <a:lvl1pPr algn="l">
-              <a:defRPr sz="1200"/>
-            </a:lvl1pPr>
-          </a:lstStyle>
-          <a:p>
-            <a:endParaRPr lang="en-US"/>
-          </a:p>
-        </p:txBody>
-      </p:sp>
-      <p:sp>
-        <p:nvSpPr>
-          <p:cNvPr id="7" name="Slide Number Placeholder 6"/>
-          <p:cNvSpPr>
-            <a:spLocks noGrp="1"/>
-          </p:cNvSpPr>
-          <p:nvPr>
-            <p:ph type="sldNum" sz="quarter" idx="5"/>
-          </p:nvPr>
-        </p:nvSpPr>
-        <p:spPr>
-          <a:xfrm>
-            <a:off x="3884613" y="8685213"/>
-            <a:ext cx="2971800" cy="458787"/>
-          </a:xfrm>
-          <a:prstGeom prst="rect">
-            <a:avLst/>
-          </a:prstGeom>
-        </p:spPr>
-        <p:txBody>
-          <a:bodyPr vert="horz" lIns="91440" tIns="45720" rIns="91440" bIns="45720" rtlCol="0" anchor="b"/>
-          <a:lstStyle>
-            <a:lvl1pPr algn="r">
-              <a:defRPr sz="1200"/>
-            </a:lvl1pPr>
-          </a:lstStyle>
-          <a:p>
-            <a:fld id="{CE5E9CC1-C706-0F49-92D6-E571CC5EEA8F}" type="slidenum">
-              <a:rPr lang="en-US"/>
-              <a:t>‹#›</a:t>
-            </a:fld>
-            <a:endParaRPr lang="en-US"/>
-          </a:p>
-        </p:txBody>
-      </p:sp>
     </p:spTree>
     <p:extLst>
       <p:ext uri="{BB962C8B-B14F-4D97-AF65-F5344CB8AC3E}">
-        <p14:creationId xmlns:p14="http://schemas.microsoft.com/office/powerpoint/2010/main" val="1024086991"/>
+        <p14:creationId xmlns:p14="http://schemas.microsoft.com/office/powerpoint/2010/main" val="1123021113"/>
       </p:ext>
     </p:extLst>
   </p:cSld>
@@ -547,10 +323,39 @@
           <a:lstStyle/>
           <a:p>
             <a:r>
-              <a:rPr lang="en-US" dirty="0"/>
-              <a:t>Giới thiệu 3 phần của hệ thống: thiết bị ESP32 tại vườn, tầng MQTT trung gian và ứng dụng Node-RED điều hành.</a:t>
-            </a:r>
-            <a:endParaRPr lang="en-US" dirty="0"/>
+              <a:rPr lang="vi-VN" dirty="0"/>
+              <a:t>Ý CHÍNH: Đề tài là hệ thống tự đo và chăm sóc vườn lan, theo dõi và điều khiển từ xa qua web. Hệ thống có 3 phần, tương ứng 3 thành viên.</a:t>
+            </a:r>
+          </a:p>
+          <a:p>
+            <a:r>
+              <a:rPr lang="vi-VN" dirty="0"/>
+              <a:t>Cách hình dung (nói khi thuyết trình):</a:t>
+            </a:r>
+          </a:p>
+          <a:p>
+            <a:r>
+              <a:rPr lang="vi-VN" dirty="0"/>
+              <a:t>- Phần 1, ESP32: "tay chân và giác quan" đặt ở vườn, đo và bật/tắt thiết bị.</a:t>
+            </a:r>
+          </a:p>
+          <a:p>
+            <a:r>
+              <a:rPr lang="vi-VN" dirty="0"/>
+              <a:t>- Phần 2, MQTT: "đường dây liên lạc" giữa vườn và máy chủ.</a:t>
+            </a:r>
+          </a:p>
+          <a:p>
+            <a:r>
+              <a:rPr lang="vi-VN" dirty="0"/>
+              <a:t>- Phần 3, Node-RED: "phòng điều hành", nơi người dùng xem số liệu và ra lệnh.</a:t>
+            </a:r>
+          </a:p>
+          <a:p>
+            <a:r>
+              <a:rPr lang="vi-VN" dirty="0"/>
+              <a:t>Giới thiệu nhanh từng thành viên và phần việc của mỗi người.</a:t>
+            </a:r>
           </a:p>
         </p:txBody>
       </p:sp>
@@ -635,10 +440,63 @@
           <a:lstStyle/>
           <a:p>
             <a:r>
-              <a:rPr lang="en-US" dirty="0"/>
-              <a:t>Nêu bài toán chăm lan, giải pháp và 4 tầng kiến trúc. Ba phần tiếp theo đi lần lượt từ tầng thiết bị lên tầng ứng dụng.</a:t>
-            </a:r>
-            <a:endParaRPr lang="en-US" dirty="0"/>
+              <a:rPr lang="vi-VN" dirty="0"/>
+              <a:t>Ý CHÍNH: Vì sao cần hệ thống, và hệ thống gồm 4 tầng.</a:t>
+            </a:r>
+          </a:p>
+          <a:p>
+            <a:r>
+              <a:rPr lang="vi-VN" dirty="0"/>
+              <a:t>Vấn đề khi chăm lan bằng tay:</a:t>
+            </a:r>
+          </a:p>
+          <a:p>
+            <a:r>
+              <a:rPr lang="vi-VN" dirty="0"/>
+              <a:t>- Phải giữ độ ẩm, nhiệt độ, ánh sáng đều đặn; người chăm dễ quên.</a:t>
+            </a:r>
+          </a:p>
+          <a:p>
+            <a:r>
+              <a:rPr lang="vi-VN" dirty="0"/>
+              <a:t>- Phun quá nhiều hoặc lá đọng nước lâu thì lan dễ thối nõn, sinh nấm.</a:t>
+            </a:r>
+          </a:p>
+          <a:p>
+            <a:r>
+              <a:rPr lang="vi-VN" dirty="0"/>
+              <a:t>- Bơm chạy khi bình cạn nước thì dễ hỏng bơm.</a:t>
+            </a:r>
+          </a:p>
+          <a:p>
+            <a:r>
+              <a:rPr lang="vi-VN" dirty="0"/>
+              <a:t>Giải pháp: ESP32 tự chăm ngay tại vườn; có web để xem và bấm điều khiển; các khóa an toàn nằm trong ESP32 nên mất mạng vườn vẫn an toàn.</a:t>
+            </a:r>
+          </a:p>
+          <a:p>
+            <a:r>
+              <a:rPr lang="vi-VN" dirty="0"/>
+              <a:t>4 tầng: Thiết bị (ESP32, cảm biến, relay) → Truyền thông (broker MQTT) → Xử lý (Node-RED) → Ứng dụng (dashboard, Telegram).</a:t>
+            </a:r>
+          </a:p>
+          <a:p>
+            <a:r>
+              <a:rPr lang="vi-VN" dirty="0"/>
+              <a:t>Mũi tên hai chiều: uplink = số đo đi lên server; downlink = lệnh đi xuống, xác nhận quay về.</a:t>
+            </a:r>
+          </a:p>
+          <a:p>
+            <a:r>
+              <a:rPr lang="vi-VN" dirty="0"/>
+              <a:t>CÂU HỎI CÓ THỂ GẶP: "Tại sao không để server quyết định hết?"</a:t>
+            </a:r>
+          </a:p>
+          <a:p>
+            <a:r>
+              <a:rPr lang="vi-VN" dirty="0"/>
+              <a:t>→ Vì mạng có thể mất. Nếu mọi quyết định nằm ở server thì mất mạng là vườn không ai chăm. ESP32 tự quyết nên luôn an toàn.</a:t>
+            </a:r>
           </a:p>
         </p:txBody>
       </p:sp>
@@ -723,10 +581,57 @@
           <a:lstStyle/>
           <a:p>
             <a:r>
-              <a:rPr lang="en-US" dirty="0"/>
-              <a:t>3 cảm biến đưa dữ liệu vào ESP32, ESP32 quyết định rồi bật/tắt 3 relay. Số GPIO là chân nối trên mạch (diagram.json).</a:t>
-            </a:r>
-            <a:endParaRPr lang="en-US" dirty="0"/>
+              <a:rPr lang="vi-VN" dirty="0"/>
+              <a:t>Ý CHÍNH: 3 cảm biến đưa thông tin vào, ESP32 suy nghĩ, rồi bật/tắt 3 thiết bị.</a:t>
+            </a:r>
+          </a:p>
+          <a:p>
+            <a:r>
+              <a:rPr lang="vi-VN" dirty="0"/>
+              <a:t>Cảm biến (đầu vào):</a:t>
+            </a:r>
+          </a:p>
+          <a:p>
+            <a:r>
+              <a:rPr lang="vi-VN" dirty="0"/>
+              <a:t>- DHT22 (chân 15): đo nhiệt độ và độ ẩm không khí.</a:t>
+            </a:r>
+          </a:p>
+          <a:p>
+            <a:r>
+              <a:rPr lang="vi-VN" dirty="0"/>
+              <a:t>- Quang trở LDR (chân 34): biết trời sáng hay tối. Số đọc càng lớn là trời càng tối.</a:t>
+            </a:r>
+          </a:p>
+          <a:p>
+            <a:r>
+              <a:rPr lang="vi-VN" dirty="0"/>
+              <a:t>- Cảm biến mực nước (chân 35): biết bình còn nước hay sắp cạn. Trong mô phỏng là một biến trở.</a:t>
+            </a:r>
+          </a:p>
+          <a:p>
+            <a:r>
+              <a:rPr lang="vi-VN" dirty="0"/>
+              <a:t>Đầu ra: relay là công tắc điện do ESP32 bật/tắt: bơm phun sương (chân 25), quạt (chân 26), đèn (chân 27).</a:t>
+            </a:r>
+          </a:p>
+          <a:p>
+            <a:r>
+              <a:rPr lang="vi-VN" dirty="0"/>
+              <a:t>GPIO là số chân trên ESP32 nối với từng linh kiện.</a:t>
+            </a:r>
+          </a:p>
+          <a:p>
+            <a:r>
+              <a:rPr lang="vi-VN" dirty="0"/>
+              <a:t>CÂU HỎI CÓ THỂ GẶP: "Sao LDR và cảm biến nước dùng chân 34, 35?"</a:t>
+            </a:r>
+          </a:p>
+          <a:p>
+            <a:r>
+              <a:rPr lang="vi-VN" dirty="0"/>
+              <a:t>→ Hai chân này thuộc ADC1, vẫn đọc được khi Wi-Fi đang bật. Các chân ADC2 bị Wi-Fi chiếm mất.</a:t>
+            </a:r>
           </a:p>
         </p:txBody>
       </p:sp>
@@ -811,10 +716,93 @@
           <a:lstStyle/>
           <a:p>
             <a:r>
-              <a:rPr lang="en-US" dirty="0"/>
-              <a:t>Việc 1 đọc và lọc số đo. Việc 2 quyết định bật tắt bơm theo các trạng thái: chờ, đang phun, nghỉ. Thời gian phun tối đa và thời gian nghỉ giúp bơm không chạy liên tục.</a:t>
-            </a:r>
-            <a:endParaRPr lang="en-US" dirty="0"/>
+              <a:rPr lang="vi-VN" dirty="0"/>
+              <a:t>Ý CHÍNH: Chương trình làm 2 việc liên tục, không bao giờ đứng chờ nên không bị treo.</a:t>
+            </a:r>
+          </a:p>
+          <a:p>
+            <a:r>
+              <a:rPr lang="vi-VN" dirty="0"/>
+              <a:t>Việc 1 – Đọc cảm biến:</a:t>
+            </a:r>
+          </a:p>
+          <a:p>
+            <a:r>
+              <a:rPr lang="vi-VN" dirty="0"/>
+              <a:t>- Cứ 2,5 giây đo một lần.</a:t>
+            </a:r>
+          </a:p>
+          <a:p>
+            <a:r>
+              <a:rPr lang="vi-VN" dirty="0"/>
+              <a:t>- Lọc nhiễu 2 bước: (1) bỏ số nhảy vọt bất thường, ví dụ độ ẩm đang 72% bỗng thành 99%: bỏ qua 2 lần đầu, lần thứ 3 vẫn lệch mới tin là thay đổi thật; (2) lấy trung bình 5 lần đo gần nhất cho số mượt.</a:t>
+            </a:r>
+          </a:p>
+          <a:p>
+            <a:r>
+              <a:rPr lang="vi-VN" dirty="0"/>
+              <a:t>- DHT đọc lỗi 3 lần liền thì báo SENSOR_FAULT (cảm biến hỏng).</a:t>
+            </a:r>
+          </a:p>
+          <a:p>
+            <a:r>
+              <a:rPr lang="vi-VN" dirty="0"/>
+              <a:t>Việc 2 – Điều khiển an toàn:</a:t>
+            </a:r>
+          </a:p>
+          <a:p>
+            <a:r>
+              <a:rPr lang="vi-VN" dirty="0"/>
+              <a:t>- Bình cạn (số đo &lt; 1200): tắt bơm, từ chối mọi lệnh bật phun, kể cả lệnh từ web.</a:t>
+            </a:r>
+          </a:p>
+          <a:p>
+            <a:r>
+              <a:rPr lang="vi-VN" dirty="0"/>
+              <a:t>- Lệnh bấm tay có thời hạn; hết giờ tự về chế độ tự động, không bị kẹt bật mãi.</a:t>
+            </a:r>
+          </a:p>
+          <a:p>
+            <a:r>
+              <a:rPr lang="vi-VN" dirty="0"/>
+              <a:t>Sơ đồ trạng thái bơm (FSM), bơm luôn ở đúng 1 trạng thái:</a:t>
+            </a:r>
+          </a:p>
+          <a:p>
+            <a:r>
+              <a:rPr lang="vi-VN" dirty="0"/>
+              <a:t>- IDLE (chờ) → độ ẩm &lt; 65% → RUNNING (đang phun).</a:t>
+            </a:r>
+          </a:p>
+          <a:p>
+            <a:r>
+              <a:rPr lang="vi-VN" dirty="0"/>
+              <a:t>- RUNNING → phun đủ 120 giây → COOLDOWN (nghỉ), để bơm không chạy liên tục mà nóng.</a:t>
+            </a:r>
+          </a:p>
+          <a:p>
+            <a:r>
+              <a:rPr lang="vi-VN" dirty="0"/>
+              <a:t>- Quay về chờ khi độ ẩm ≥ 80% (đủ ẩm) hoặc sau 60 giây nghỉ.</a:t>
+            </a:r>
+          </a:p>
+          <a:p>
+            <a:r>
+              <a:rPr lang="vi-VN" dirty="0"/>
+              <a:t>- Cạn nước hoặc hỏng cảm biến: tắt bơm ngay, dù đang ở trạng thái nào.</a:t>
+            </a:r>
+          </a:p>
+          <a:p>
+            <a:r>
+              <a:rPr lang="vi-VN" dirty="0"/>
+              <a:t>CÂU HỎI CÓ THỂ GẶP: "Sao bật ở 65% mà tắt ở 80%, không dùng một mốc?"</a:t>
+            </a:r>
+          </a:p>
+          <a:p>
+            <a:r>
+              <a:rPr lang="vi-VN" dirty="0"/>
+              <a:t>→ Đây là vùng trễ. Nếu chỉ dùng một mốc (ví dụ 70%), độ ẩm dao động quanh 70% sẽ làm bơm bật tắt liên tục, rất hại bơm.</a:t>
+            </a:r>
           </a:p>
         </p:txBody>
       </p:sp>
@@ -899,10 +887,45 @@
           <a:lstStyle/>
           <a:p>
             <a:r>
-              <a:rPr lang="en-US" dirty="0"/>
-              <a:t>Mọi topic có chung tiền tố garden/orchid/orchid-01/. Gửi tin gọi là publish, đăng ký nhận tin gọi là subscribe. Tên topic và nội dung tin đã chốt từ tuần 8.</a:t>
-            </a:r>
-            <a:endParaRPr lang="en-US" dirty="0"/>
+              <a:rPr lang="vi-VN" dirty="0"/>
+              <a:t>Ý CHÍNH: ESP32 và server không nói chuyện trực tiếp, mà gửi tin qua một "bưu điện" chung gọi là broker (broker.emqx.io).</a:t>
+            </a:r>
+          </a:p>
+          <a:p>
+            <a:r>
+              <a:rPr lang="vi-VN" dirty="0"/>
+              <a:t>- Topic = địa chỉ của từng loại tin, ví dụ garden/orchid/orchid-01/telemetry.</a:t>
+            </a:r>
+          </a:p>
+          <a:p>
+            <a:r>
+              <a:rPr lang="vi-VN" dirty="0"/>
+              <a:t>- Publish = gửi tin vào topic; Subscribe = đăng ký nhận tin của topic đó.</a:t>
+            </a:r>
+          </a:p>
+          <a:p>
+            <a:r>
+              <a:rPr lang="vi-VN" dirty="0"/>
+              <a:t>Tin đi lên (ESP32 → server): telemetry (số đo, 2,5 giây/lần), state (thiết bị nào đang bật/tắt), availability (online/offline), ack (trả lời đã làm lệnh chưa).</a:t>
+            </a:r>
+          </a:p>
+          <a:p>
+            <a:r>
+              <a:rPr lang="vi-VN" dirty="0"/>
+              <a:t>Tin đi xuống (server → ESP32): cmd/mist, cmd/fan, cmd/light (lệnh cho bơm, quạt, đèn), config (đổi ngưỡng).</a:t>
+            </a:r>
+          </a:p>
+          <a:p>
+            <a:r>
+              <a:rPr lang="vi-VN" dirty="0"/>
+              <a:t>CÂU HỎI CÓ THỂ GẶP: "Vì sao dùng MQTT mà không dùng HTTP?"</a:t>
+            </a:r>
+          </a:p>
+          <a:p>
+            <a:r>
+              <a:rPr lang="vi-VN" dirty="0"/>
+              <a:t>→ MQTT nhẹ, hợp thiết bị nhỏ; kết nối luôn mở nên lệnh xuống tới ngay, không phải hỏi đi hỏi lại; có sẵn cơ chế báo mất kết nối (LWT).</a:t>
+            </a:r>
           </a:p>
         </p:txBody>
       </p:sp>
@@ -987,10 +1010,45 @@
           <a:lstStyle/>
           <a:p>
             <a:r>
-              <a:rPr lang="en-US" dirty="0"/>
-              <a:t>4 dịch vụ trên MQTT. Topic và payload đã chốt từ tuần 8. Mỗi lệnh đều có request_id để ghép ACK; firmware luôn là lớp an toàn cuối cùng.</a:t>
-            </a:r>
-            <a:endParaRPr lang="en-US" dirty="0"/>
+              <a:rPr lang="vi-VN" dirty="0"/>
+              <a:t>Ý CHÍNH: 4 việc mà MQTT đảm nhận.</a:t>
+            </a:r>
+          </a:p>
+          <a:p>
+            <a:r>
+              <a:rPr lang="vi-VN" dirty="0"/>
+              <a:t>1) Báo thiết bị còn hoạt động: ESP32 báo "online" khi kết nối. LWT là "lời dặn trước": lúc kết nối, ESP32 dặn broker nếu nó mất kết nối đột ngột thì gửi "offline" giúp nó, nên ESP32 mất điện server vẫn biết. Quá 15 giây không có số mới → STALE (số trên màn hình là số cũ).</a:t>
+            </a:r>
+          </a:p>
+          <a:p>
+            <a:r>
+              <a:rPr lang="vi-VN" dirty="0"/>
+              <a:t>2) Gửi số đo: telemetry và state đi lên, dashboard cập nhật.</a:t>
+            </a:r>
+          </a:p>
+          <a:p>
+            <a:r>
+              <a:rPr lang="vi-VN" dirty="0"/>
+              <a:t>3) Điều khiển có xác nhận: lệnh gồm mã lệnh (request_id), chế độ, bật/tắt, thời hạn. ESP32 trả lời ACK: APPLIED (đã làm) hoặc REJECTED kèm lý do (ví dụ cạn nước). Quá 6 giây không có trả lời → NO_ACK.</a:t>
+            </a:r>
+          </a:p>
+          <a:p>
+            <a:r>
+              <a:rPr lang="vi-VN" dirty="0"/>
+              <a:t>4) Đổi ngưỡng từ xa: chỉnh mức độ ẩm, nhiệt độ… không cần nạp lại chương trình. ESP32 từ chối ngưỡng nguy hiểm, ví dụ mức báo cạn nước không được dưới 1200.</a:t>
+            </a:r>
+          </a:p>
+          <a:p>
+            <a:r>
+              <a:rPr lang="vi-VN" dirty="0"/>
+              <a:t>CÂU HỎI CÓ THỂ GẶP: "Làm sao biết lệnh đã thật sự được thực hiện?"</a:t>
+            </a:r>
+          </a:p>
+          <a:p>
+            <a:r>
+              <a:rPr lang="vi-VN" dirty="0"/>
+              <a:t>→ Nhờ ACK. Dashboard chỉ báo thành công khi ESP32 trả lời APPLIED đúng mã lệnh; không có trả lời thì báo NO_ACK, không báo thành công giả.</a:t>
+            </a:r>
           </a:p>
         </p:txBody>
       </p:sp>
@@ -1075,10 +1133,39 @@
           <a:lstStyle/>
           <a:p>
             <a:r>
-              <a:rPr lang="en-US" dirty="0"/>
-              <a:t>Bên trái: cách dashboard hiển thị dữ liệu và trạng thái kết nối. Bên phải: toàn bộ sự kiện ghi vào orchid-history.jsonl, dùng làm bằng chứng nghiệm thu.</a:t>
-            </a:r>
-            <a:endParaRPr lang="en-US" dirty="0"/>
+              <a:rPr lang="vi-VN" dirty="0"/>
+              <a:t>Ý CHÍNH: Node-RED là phần mềm trên server: nhận dữ liệu, chạy luật tự động, tạo trang web dashboard.</a:t>
+            </a:r>
+          </a:p>
+          <a:p>
+            <a:r>
+              <a:rPr lang="vi-VN" dirty="0"/>
+              <a:t>Hiển thị:</a:t>
+            </a:r>
+          </a:p>
+          <a:p>
+            <a:r>
+              <a:rPr lang="vi-VN" dirty="0"/>
+              <a:t>- Xem được trên máy tính và điện thoại; có số đo trực tiếp và 2 biểu đồ 1 giờ gần nhất.</a:t>
+            </a:r>
+          </a:p>
+          <a:p>
+            <a:r>
+              <a:rPr lang="vi-VN" dirty="0"/>
+              <a:t>- Cảm biến hỏng thì hiện chữ "DHT fault", không hiện số sai (ví dụ 0 °C) làm hiểu nhầm.</a:t>
+            </a:r>
+          </a:p>
+          <a:p>
+            <a:r>
+              <a:rPr lang="vi-VN" dirty="0"/>
+              <a:t>3 trạng thái kết nối: xanh ONLINE (đang nhận dữ liệu), vàng STALE (15 giây chưa có số mới), đỏ OFFLINE (thiết bị mất kết nối).</a:t>
+            </a:r>
+          </a:p>
+          <a:p>
+            <a:r>
+              <a:rPr lang="vi-VN" dirty="0"/>
+              <a:t>Lưu nhật ký: mọi sự kiện ghi vào file orchid-history.jsonl, mỗi dòng một sự kiện: lúc nào, ai bấm, lệnh gì, kết quả, mất bao lâu. Không cần cơ sở dữ liệu mà vẫn đủ làm bằng chứng khi nghiệm thu và khi tìm lỗi.</a:t>
+            </a:r>
           </a:p>
         </p:txBody>
       </p:sp>
@@ -1163,10 +1250,81 @@
           <a:lstStyle/>
           <a:p>
             <a:r>
-              <a:rPr lang="en-US" dirty="0"/>
-              <a:t>Bên trái: chế độ AUTO/MANUAL, các khóa nút và 3 vai trò. Bên phải: 2 luật tự động chính và cảnh báo Telegram.</a:t>
-            </a:r>
-            <a:endParaRPr lang="en-US" dirty="0"/>
+              <a:rPr lang="vi-VN" dirty="0"/>
+              <a:t>Ý CHÍNH: Người dùng điều khiển được, nhưng hệ thống tự khóa những thao tác có thể gây hại.</a:t>
+            </a:r>
+          </a:p>
+          <a:p>
+            <a:r>
+              <a:rPr lang="vi-VN" dirty="0"/>
+              <a:t>Hai chế độ: AUTO = hệ thống tự làm theo luật; MANUAL = người dùng bấm tay, có hạn 1–60 phút.</a:t>
+            </a:r>
+          </a:p>
+          <a:p>
+            <a:r>
+              <a:rPr lang="vi-VN" dirty="0"/>
+              <a:t>Khóa nút:</a:t>
+            </a:r>
+          </a:p>
+          <a:p>
+            <a:r>
+              <a:rPr lang="vi-VN" dirty="0"/>
+              <a:t>- Đang AUTO hoặc mất kết nối: khóa hết.</a:t>
+            </a:r>
+          </a:p>
+          <a:p>
+            <a:r>
+              <a:rPr lang="vi-VN" dirty="0"/>
+              <a:t>- Cạn nước, bơm đang nghỉ hoặc cảm biến hỏng: khóa riêng nút bật phun.</a:t>
+            </a:r>
+          </a:p>
+          <a:p>
+            <a:r>
+              <a:rPr lang="vi-VN" dirty="0"/>
+              <a:t>- Bấm xong phải chờ ESP32 xác nhận mới bấm tiếp, tránh gửi lệnh trùng.</a:t>
+            </a:r>
+          </a:p>
+          <a:p>
+            <a:r>
+              <a:rPr lang="vi-VN" dirty="0"/>
+              <a:t>Phân quyền: admin toàn quyền; operator được điều khiển; viewer chỉ được xem.</a:t>
+            </a:r>
+          </a:p>
+          <a:p>
+            <a:r>
+              <a:rPr lang="vi-VN" dirty="0"/>
+              <a:t>Luật tự động:</a:t>
+            </a:r>
+          </a:p>
+          <a:p>
+            <a:r>
+              <a:rPr lang="vi-VN" dirty="0"/>
+              <a:t>- Đèn bù sáng: chỉ bật 06:00–21:00 khi trời tối; ban đêm không bật để lan nghỉ; tối đa 4 giờ/ngày.</a:t>
+            </a:r>
+          </a:p>
+          <a:p>
+            <a:r>
+              <a:rPr lang="vi-VN" dirty="0"/>
+              <a:t>- Quạt sau khi phun: phun xong quạt chạy 60 giây cho lá khô.</a:t>
+            </a:r>
+          </a:p>
+          <a:p>
+            <a:r>
+              <a:rPr lang="vi-VN" dirty="0"/>
+              <a:t>- Telegram: nhắn vào nhóm chat khi cạn nước hoặc mất kết nối quá 5 phút.</a:t>
+            </a:r>
+          </a:p>
+          <a:p>
+            <a:r>
+              <a:rPr lang="vi-VN" dirty="0"/>
+              <a:t>CÂU HỎI CÓ THỂ GẶP: "Nếu ai đó lách qua giao diện, gửi thẳng lệnh bật phun khi cạn nước?"</a:t>
+            </a:r>
+          </a:p>
+          <a:p>
+            <a:r>
+              <a:rPr lang="vi-VN" dirty="0"/>
+              <a:t>→ Bị chặn 2 lần: gateway Node-RED chặn, và ESP32 tự từ chối (REJECTED WATER_LOCKOUT). Đã kiểm thử thật ở ca D6.</a:t>
+            </a:r>
           </a:p>
         </p:txBody>
       </p:sp>
@@ -1251,10 +1409,63 @@
           <a:lstStyle/>
           <a:p>
             <a:r>
-              <a:rPr lang="en-US" dirty="0"/>
-              <a:t>Tóm tắt kết quả nghiệm thu tuần 8-9 (số liệu lấy từ test-results/week8-m4 và week9-rerun) và hướng phát triển.</a:t>
-            </a:r>
-            <a:endParaRPr lang="en-US" dirty="0"/>
+              <a:rPr lang="vi-VN" dirty="0"/>
+              <a:t>Ý CHÍNH: Hệ thống chạy ổn định 2 chiều, có số liệu đo được để chứng minh.</a:t>
+            </a:r>
+          </a:p>
+          <a:p>
+            <a:r>
+              <a:rPr lang="vi-VN" dirty="0"/>
+              <a:t>- 199/199: chạy liên tục 12 phút, cả 199 lần đo gửi lên server đều khớp đúng số trên ESP32.</a:t>
+            </a:r>
+          </a:p>
+          <a:p>
+            <a:r>
+              <a:rPr lang="vi-VN" dirty="0"/>
+              <a:t>- 10/10: 10 tình huống điều khiển đều đúng, kể cả cạn nước, lệnh trùng, mất mạng.</a:t>
+            </a:r>
+          </a:p>
+          <a:p>
+            <a:r>
+              <a:rPr lang="vi-VN" dirty="0"/>
+              <a:t>- 3/3: chạy lại toàn bộ 3 lần liên tiếp đều đạt, kết quả giống nhau (điều kiện M4: không phải may mắn một lần).</a:t>
+            </a:r>
+          </a:p>
+          <a:p>
+            <a:r>
+              <a:rPr lang="vi-VN" dirty="0"/>
+              <a:t>- ~0,6 giây: từ lúc bấm nút đến khi thấy ESP32 xác nhận.</a:t>
+            </a:r>
+          </a:p>
+          <a:p>
+            <a:r>
+              <a:rPr lang="vi-VN" dirty="0"/>
+              <a:t>Hướng phát triển: chạy trên board thật; dùng broker riêng có mật khẩu và mã hóa (broker công cộng ai cũng gửi tin vào được); lưu dữ liệu lâu dài để xem xu hướng theo mùa.</a:t>
+            </a:r>
+          </a:p>
+          <a:p>
+            <a:r>
+              <a:rPr lang="vi-VN" dirty="0"/>
+              <a:t>3 CÂU NÊN TẬP TRẢ LỜI:</a:t>
+            </a:r>
+          </a:p>
+          <a:p>
+            <a:r>
+              <a:rPr lang="vi-VN" dirty="0"/>
+              <a:t>1) Bấm "Fan ON" thì sao? → Dashboard → gateway tạo mã lệnh → gửi topic cmd/fan → broker → ESP32 bật relay chân 26 → gửi ACK APPLIED → dashboard hiện "APPLIED, ~0,6 s".</a:t>
+            </a:r>
+          </a:p>
+          <a:p>
+            <a:r>
+              <a:rPr lang="vi-VN" dirty="0"/>
+              <a:t>2) Mất mạng thì sao? → Broker gửi LWT "offline"; dashboard báo OFFLINE và khóa nút; ESP32 xóa lệnh tay, tự chạy AUTO an toàn, rồi tự kết nối lại.</a:t>
+            </a:r>
+          </a:p>
+          <a:p>
+            <a:r>
+              <a:rPr lang="vi-VN" dirty="0"/>
+              <a:t>3) Cạn nước thì sao? → ESP32 tắt bơm, vào WATER_LOCKOUT; dashboard khóa nút phun; Telegram cảnh báo; đổ nước lại thì tự mở khóa.</a:t>
+            </a:r>
           </a:p>
         </p:txBody>
       </p:sp>
@@ -1332,6 +1543,7 @@
         <a:solidFill>
           <a:srgbClr val="17402C"/>
         </a:solidFill>
+        <a:effectLst/>
       </p:bgPr>
     </p:bg>
     <p:spTree>
@@ -1351,9 +1563,11 @@
       <p:sp>
         <p:nvSpPr>
           <p:cNvPr id="2" name="Text 0"/>
-          <p:cNvSpPr/>
+          <p:cNvSpPr>
+            <a:spLocks noGrp="1"/>
+          </p:cNvSpPr>
           <p:nvPr>
-            <p:ph idx="100" type="title" hasCustomPrompt="1"/>
+            <p:ph type="title" idx="100" hasCustomPrompt="1"/>
           </p:nvPr>
         </p:nvSpPr>
         <p:spPr>
@@ -1370,7 +1584,7 @@
         <p:txBody>
           <a:bodyPr wrap="square" rtlCol="0"/>
           <a:lstStyle>
-            <a:lvl1pPr algn="l" indent="0" marL="0">
+            <a:lvl1pPr marL="0" indent="0" algn="l">
               <a:buNone/>
               <a:defRPr lang="en-US" sz="4400" b="1" dirty="0">
                 <a:solidFill>
@@ -1383,7 +1597,7 @@
             </a:lvl1pPr>
           </a:lstStyle>
           <a:p>
-            <a:pPr algn="l" indent="0" marL="0">
+            <a:pPr marL="0" indent="0" algn="l">
               <a:buNone/>
             </a:pPr>
             <a:endParaRPr lang="en-US" sz="4400" dirty="0"/>
@@ -1393,9 +1607,11 @@
       <p:sp>
         <p:nvSpPr>
           <p:cNvPr id="3" name="Text 0"/>
-          <p:cNvSpPr/>
+          <p:cNvSpPr>
+            <a:spLocks noGrp="1"/>
+          </p:cNvSpPr>
           <p:nvPr>
-            <p:ph idx="101" type="body" hasCustomPrompt="1"/>
+            <p:ph type="body" idx="101" hasCustomPrompt="1"/>
           </p:nvPr>
         </p:nvSpPr>
         <p:spPr>
@@ -1412,7 +1628,7 @@
         <p:txBody>
           <a:bodyPr wrap="square" rtlCol="0"/>
           <a:lstStyle>
-            <a:lvl1pPr indent="0" marL="0">
+            <a:lvl1pPr marL="0" indent="0">
               <a:buNone/>
               <a:defRPr lang="en-US" sz="2000" dirty="0">
                 <a:solidFill>
@@ -1422,7 +1638,7 @@
             </a:lvl1pPr>
           </a:lstStyle>
           <a:p>
-            <a:pPr indent="0" marL="0">
+            <a:pPr marL="0" indent="0">
               <a:buNone/>
             </a:pPr>
             <a:endParaRPr lang="en-US" sz="2000" dirty="0"/>
@@ -1445,6 +1661,7 @@
         <a:solidFill>
           <a:srgbClr val="17402C"/>
         </a:solidFill>
+        <a:effectLst/>
       </p:bgPr>
     </p:bg>
     <p:spTree>
@@ -1464,9 +1681,11 @@
       <p:sp>
         <p:nvSpPr>
           <p:cNvPr id="2" name="Text 0"/>
-          <p:cNvSpPr/>
+          <p:cNvSpPr>
+            <a:spLocks noGrp="1"/>
+          </p:cNvSpPr>
           <p:nvPr>
-            <p:ph idx="100" type="title" hasCustomPrompt="1"/>
+            <p:ph type="title" idx="100" hasCustomPrompt="1"/>
           </p:nvPr>
         </p:nvSpPr>
         <p:spPr>
@@ -1483,7 +1702,7 @@
         <p:txBody>
           <a:bodyPr wrap="square" rtlCol="0"/>
           <a:lstStyle>
-            <a:lvl1pPr algn="l" indent="0" marL="0">
+            <a:lvl1pPr marL="0" indent="0" algn="l">
               <a:buNone/>
               <a:defRPr lang="en-US" sz="3600" b="1" dirty="0">
                 <a:solidFill>
@@ -1496,7 +1715,7 @@
             </a:lvl1pPr>
           </a:lstStyle>
           <a:p>
-            <a:pPr algn="l" indent="0" marL="0">
+            <a:pPr marL="0" indent="0" algn="l">
               <a:buNone/>
             </a:pPr>
             <a:endParaRPr lang="en-US" sz="3600" dirty="0"/>
@@ -1506,9 +1725,11 @@
       <p:sp>
         <p:nvSpPr>
           <p:cNvPr id="3" name="Text 0"/>
-          <p:cNvSpPr/>
+          <p:cNvSpPr>
+            <a:spLocks noGrp="1"/>
+          </p:cNvSpPr>
           <p:nvPr>
-            <p:ph idx="101" type="body" hasCustomPrompt="1"/>
+            <p:ph type="body" idx="101" hasCustomPrompt="1"/>
           </p:nvPr>
         </p:nvSpPr>
         <p:spPr>
@@ -1525,7 +1746,7 @@
         <p:txBody>
           <a:bodyPr wrap="square" rtlCol="0"/>
           <a:lstStyle>
-            <a:lvl1pPr indent="0" marL="0">
+            <a:lvl1pPr marL="0" indent="0">
               <a:buNone/>
               <a:defRPr lang="en-US" sz="1800" i="1" dirty="0">
                 <a:solidFill>
@@ -1535,7 +1756,7 @@
             </a:lvl1pPr>
           </a:lstStyle>
           <a:p>
-            <a:pPr indent="0" marL="0">
+            <a:pPr marL="0" indent="0">
               <a:buNone/>
             </a:pPr>
             <a:endParaRPr lang="en-US" sz="1800" dirty="0"/>
@@ -1562,7 +1783,7 @@
           </a:prstGeom>
           <a:extLst>
             <a:ext uri="{C572A759-6A51-4108-AA02-DFA0A04FC94B}">
-              <ma14:wrappingTextBoxFlag xmlns:ma14="http://schemas.microsoft.com/office/mac/drawingml/2011/main" val="0"/>
+              <ma14:wrappingTextBoxFlag xmlns="" xmlns:ma14="http://schemas.microsoft.com/office/mac/drawingml/2011/main" val="0"/>
             </a:ext>
           </a:extLst>
         </p:spPr>
@@ -1580,8 +1801,8 @@
           <a:p>
             <a:pPr algn="r"/>
             <a:fld id="{F7021451-1387-4CA6-816F-3879F97B5CBC}" type="slidenum">
-              <a:rPr b="0" lang="en-US"/>
-              <a:t>1003</a:t>
+              <a:rPr lang="en-US" b="0"/>
+              <a:t>‹#›</a:t>
             </a:fld>
             <a:endParaRPr lang="en-US"/>
           </a:p>
@@ -1603,6 +1824,7 @@
         <a:solidFill>
           <a:schemeClr val="bg1"/>
         </a:solidFill>
+        <a:effectLst/>
       </p:bgPr>
     </p:bg>
     <p:spTree>
@@ -1622,9 +1844,11 @@
       <p:sp>
         <p:nvSpPr>
           <p:cNvPr id="2" name="Text 0"/>
-          <p:cNvSpPr/>
+          <p:cNvSpPr>
+            <a:spLocks noGrp="1"/>
+          </p:cNvSpPr>
           <p:nvPr>
-            <p:ph idx="100" type="title" hasCustomPrompt="1"/>
+            <p:ph type="title" idx="100" hasCustomPrompt="1"/>
           </p:nvPr>
         </p:nvSpPr>
         <p:spPr>
@@ -1641,7 +1865,7 @@
         <p:txBody>
           <a:bodyPr wrap="square" rtlCol="0"/>
           <a:lstStyle>
-            <a:lvl1pPr algn="l" indent="0" marL="0">
+            <a:lvl1pPr marL="0" indent="0" algn="l">
               <a:buNone/>
               <a:defRPr lang="en-US" sz="3200" b="1" dirty="0">
                 <a:solidFill>
@@ -1654,7 +1878,7 @@
             </a:lvl1pPr>
           </a:lstStyle>
           <a:p>
-            <a:pPr algn="l" indent="0" marL="0">
+            <a:pPr marL="0" indent="0" algn="l">
               <a:buNone/>
             </a:pPr>
             <a:endParaRPr lang="en-US" sz="3200" dirty="0"/>
@@ -1664,9 +1888,11 @@
       <p:sp>
         <p:nvSpPr>
           <p:cNvPr id="3" name="Text 0"/>
-          <p:cNvSpPr/>
+          <p:cNvSpPr>
+            <a:spLocks noGrp="1"/>
+          </p:cNvSpPr>
           <p:nvPr>
-            <p:ph idx="101" type="body" hasCustomPrompt="1"/>
+            <p:ph type="body" idx="101" hasCustomPrompt="1"/>
           </p:nvPr>
         </p:nvSpPr>
         <p:spPr>
@@ -1683,7 +1909,7 @@
         <p:txBody>
           <a:bodyPr wrap="square" rtlCol="0"/>
           <a:lstStyle>
-            <a:lvl1pPr indent="0" marL="0">
+            <a:lvl1pPr marL="0" indent="0">
               <a:buNone/>
               <a:defRPr lang="en-US" sz="1600" i="1" dirty="0">
                 <a:solidFill>
@@ -1693,7 +1919,7 @@
             </a:lvl1pPr>
           </a:lstStyle>
           <a:p>
-            <a:pPr indent="0" marL="0">
+            <a:pPr marL="0" indent="0">
               <a:buNone/>
             </a:pPr>
             <a:endParaRPr lang="en-US" sz="1600" dirty="0"/>
@@ -1720,7 +1946,7 @@
           </a:prstGeom>
           <a:extLst>
             <a:ext uri="{C572A759-6A51-4108-AA02-DFA0A04FC94B}">
-              <ma14:wrappingTextBoxFlag xmlns:ma14="http://schemas.microsoft.com/office/mac/drawingml/2011/main" val="0"/>
+              <ma14:wrappingTextBoxFlag xmlns="" xmlns:ma14="http://schemas.microsoft.com/office/mac/drawingml/2011/main" val="0"/>
             </a:ext>
           </a:extLst>
         </p:spPr>
@@ -1738,8 +1964,8 @@
           <a:p>
             <a:pPr algn="r"/>
             <a:fld id="{F7021451-1387-4CA6-816F-3879F97B5CBC}" type="slidenum">
-              <a:rPr b="0" lang="en-US"/>
-              <a:t>1004</a:t>
+              <a:rPr lang="en-US" b="0"/>
+              <a:t>‹#›</a:t>
             </a:fld>
             <a:endParaRPr lang="en-US"/>
           </a:p>
@@ -1756,6 +1982,11 @@
 <file path=ppt/slideMasters/slideMaster1.xml><?xml version="1.0" encoding="utf-8"?>
 <p:sldMaster xmlns:a="http://schemas.openxmlformats.org/drawingml/2006/main" xmlns:r="http://schemas.openxmlformats.org/officeDocument/2006/relationships" xmlns:p="http://schemas.openxmlformats.org/presentationml/2006/main">
   <p:cSld>
+    <p:bg>
+      <p:bgRef idx="1001">
+        <a:schemeClr val="bg1"/>
+      </p:bgRef>
+    </p:bg>
     <p:spTree>
       <p:nvGrpSpPr>
         <p:cNvPr id="1" name=""/>
@@ -1790,7 +2021,7 @@
           </a:prstGeom>
           <a:extLst>
             <a:ext uri="{C572A759-6A51-4108-AA02-DFA0A04FC94B}">
-              <ma14:wrappingTextBoxFlag xmlns:ma14="http://schemas.microsoft.com/office/mac/drawingml/2011/main" val="0"/>
+              <ma14:wrappingTextBoxFlag xmlns="" xmlns:ma14="http://schemas.microsoft.com/office/mac/drawingml/2011/main" val="0"/>
             </a:ext>
           </a:extLst>
         </p:spPr>
@@ -1808,8 +2039,8 @@
           <a:p>
             <a:pPr algn="r"/>
             <a:fld id="{F7021451-1387-4CA6-816F-3879F97B5CBC}" type="slidenum">
-              <a:rPr b="0" lang="en-US"/>
-              <a:t>null</a:t>
+              <a:rPr lang="en-US" b="0"/>
+              <a:t>‹#›</a:t>
             </a:fld>
             <a:endParaRPr lang="en-US"/>
           </a:p>
@@ -2098,9 +2329,11 @@
       <p:sp>
         <p:nvSpPr>
           <p:cNvPr id="2" name="Text 0"/>
-          <p:cNvSpPr/>
+          <p:cNvSpPr>
+            <a:spLocks noGrp="1"/>
+          </p:cNvSpPr>
           <p:nvPr>
-            <p:ph idx="100" type="title" hasCustomPrompt="1"/>
+            <p:ph type="title" idx="100" hasCustomPrompt="1"/>
           </p:nvPr>
         </p:nvSpPr>
         <p:spPr>
@@ -2118,7 +2351,7 @@
           <a:bodyPr wrap="square" lIns="0" tIns="0" rIns="0" bIns="0" rtlCol="0" anchor="b"/>
           <a:lstStyle/>
           <a:p>
-            <a:pPr algn="l" indent="0" marL="0">
+            <a:pPr marL="0" indent="0" algn="l">
               <a:buNone/>
             </a:pPr>
             <a:r>
@@ -2139,9 +2372,11 @@
       <p:sp>
         <p:nvSpPr>
           <p:cNvPr id="3" name="Text 0"/>
-          <p:cNvSpPr/>
+          <p:cNvSpPr>
+            <a:spLocks noGrp="1"/>
+          </p:cNvSpPr>
           <p:nvPr>
-            <p:ph idx="101" type="body" hasCustomPrompt="1"/>
+            <p:ph type="body" idx="101" hasCustomPrompt="1"/>
           </p:nvPr>
         </p:nvSpPr>
         <p:spPr>
@@ -2159,7 +2394,7 @@
           <a:bodyPr wrap="square" lIns="0" tIns="0" rIns="0" bIns="0" rtlCol="0" anchor="t"/>
           <a:lstStyle/>
           <a:p>
-            <a:pPr indent="0" marL="0">
+            <a:pPr marL="0" indent="0">
               <a:buNone/>
             </a:pPr>
             <a:r>
@@ -2201,14 +2436,14 @@
       </p:sp>
       <p:pic>
         <p:nvPicPr>
-          <p:cNvPr id="5" name="cover-part1-icon" descr="preencoded.png">    </p:cNvPr>
+          <p:cNvPr id="5" name="cover-part1-icon" descr="preencoded.png"/>
           <p:cNvPicPr>
             <a:picLocks noChangeAspect="1"/>
           </p:cNvPicPr>
           <p:nvPr/>
         </p:nvPicPr>
         <p:blipFill>
-          <a:blip r:embed="rId1"/>
+          <a:blip r:embed="rId3"/>
           <a:stretch>
             <a:fillRect/>
           </a:stretch>
@@ -2244,7 +2479,7 @@
           <a:bodyPr wrap="square" lIns="0" tIns="0" rIns="0" bIns="0" rtlCol="0" anchor="t"/>
           <a:lstStyle/>
           <a:p>
-            <a:pPr indent="0" marL="0">
+            <a:pPr marL="0" indent="0">
               <a:buNone/>
             </a:pPr>
             <a:r>
@@ -2258,7 +2493,7 @@
             <a:endParaRPr lang="en-US" sz="1400" dirty="0"/>
           </a:p>
           <a:p>
-            <a:pPr indent="0" marL="0">
+            <a:pPr marL="0" indent="0">
               <a:buNone/>
             </a:pPr>
             <a:r>
@@ -2300,14 +2535,14 @@
       </p:sp>
       <p:pic>
         <p:nvPicPr>
-          <p:cNvPr id="8" name="cover-part2-icon" descr="preencoded.png">    </p:cNvPr>
+          <p:cNvPr id="8" name="cover-part2-icon" descr="preencoded.png"/>
           <p:cNvPicPr>
             <a:picLocks noChangeAspect="1"/>
           </p:cNvPicPr>
           <p:nvPr/>
         </p:nvPicPr>
         <p:blipFill>
-          <a:blip r:embed="rId2"/>
+          <a:blip r:embed="rId4"/>
           <a:stretch>
             <a:fillRect/>
           </a:stretch>
@@ -2343,7 +2578,7 @@
           <a:bodyPr wrap="square" lIns="0" tIns="0" rIns="0" bIns="0" rtlCol="0" anchor="t"/>
           <a:lstStyle/>
           <a:p>
-            <a:pPr indent="0" marL="0">
+            <a:pPr marL="0" indent="0">
               <a:buNone/>
             </a:pPr>
             <a:r>
@@ -2357,7 +2592,7 @@
             <a:endParaRPr lang="en-US" sz="1400" dirty="0"/>
           </a:p>
           <a:p>
-            <a:pPr indent="0" marL="0">
+            <a:pPr marL="0" indent="0">
               <a:buNone/>
             </a:pPr>
             <a:r>
@@ -2399,14 +2634,14 @@
       </p:sp>
       <p:pic>
         <p:nvPicPr>
-          <p:cNvPr id="11" name="cover-part3-icon" descr="preencoded.png">    </p:cNvPr>
+          <p:cNvPr id="11" name="cover-part3-icon" descr="preencoded.png"/>
           <p:cNvPicPr>
             <a:picLocks noChangeAspect="1"/>
           </p:cNvPicPr>
           <p:nvPr/>
         </p:nvPicPr>
         <p:blipFill>
-          <a:blip r:embed="rId3"/>
+          <a:blip r:embed="rId5"/>
           <a:stretch>
             <a:fillRect/>
           </a:stretch>
@@ -2442,7 +2677,7 @@
           <a:bodyPr wrap="square" lIns="0" tIns="0" rIns="0" bIns="0" rtlCol="0" anchor="t"/>
           <a:lstStyle/>
           <a:p>
-            <a:pPr indent="0" marL="0">
+            <a:pPr marL="0" indent="0">
               <a:buNone/>
             </a:pPr>
             <a:r>
@@ -2456,7 +2691,7 @@
             <a:endParaRPr lang="en-US" sz="1400" dirty="0"/>
           </a:p>
           <a:p>
-            <a:pPr indent="0" marL="0">
+            <a:pPr marL="0" indent="0">
               <a:buNone/>
             </a:pPr>
             <a:r>
@@ -2473,14 +2708,14 @@
       </p:sp>
       <p:pic>
         <p:nvPicPr>
-          <p:cNvPr id="13" name="cover-leaf" descr="preencoded.png">    </p:cNvPr>
+          <p:cNvPr id="13" name="cover-leaf" descr="preencoded.png"/>
           <p:cNvPicPr>
             <a:picLocks noChangeAspect="1"/>
           </p:cNvPicPr>
           <p:nvPr/>
         </p:nvPicPr>
         <p:blipFill>
-          <a:blip r:embed="rId4">
+          <a:blip r:embed="rId6">
             <a:alphaModFix amt="60000"/>
           </a:blip>
           <a:stretch>
@@ -2518,11 +2753,11 @@
           <a:bodyPr wrap="square" lIns="0" tIns="0" rIns="0" bIns="0" rtlCol="0" anchor="t"/>
           <a:lstStyle/>
           <a:p>
-            <a:pPr indent="0" marL="0">
-              <a:buNone/>
-            </a:pPr>
-            <a:r>
-              <a:rPr lang="en-US" sz="1200" b="1" spc="200" kern="0" dirty="0">
+            <a:pPr marL="0" indent="0">
+              <a:buNone/>
+            </a:pPr>
+            <a:r>
+              <a:rPr lang="en-US" sz="1200" b="1" kern="0" spc="200" dirty="0">
                 <a:solidFill>
                   <a:srgbClr val="F2B8D6"/>
                 </a:solidFill>
@@ -2581,7 +2816,7 @@
           <a:bodyPr wrap="square" lIns="0" tIns="0" rIns="0" bIns="0" rtlCol="0" anchor="t"/>
           <a:lstStyle/>
           <a:p>
-            <a:pPr indent="0" marL="0">
+            <a:pPr marL="0" indent="0">
               <a:buNone/>
             </a:pPr>
             <a:r>
@@ -2590,12 +2825,44 @@
                   <a:schemeClr val="bg1"/>
                 </a:solidFill>
               </a:rPr>
-              <a:t>Người 1 – Họ và tên</a:t>
+              <a:t>Người 1 – </a:t>
+            </a:r>
+            <a:r>
+              <a:rPr lang="en-US" sz="1600" b="1" dirty="0" err="1">
+                <a:solidFill>
+                  <a:schemeClr val="bg1"/>
+                </a:solidFill>
+              </a:rPr>
+              <a:t>Trần</a:t>
+            </a:r>
+            <a:r>
+              <a:rPr lang="en-US" sz="1600" b="1" dirty="0">
+                <a:solidFill>
+                  <a:schemeClr val="bg1"/>
+                </a:solidFill>
+              </a:rPr>
+              <a:t> </a:t>
+            </a:r>
+            <a:r>
+              <a:rPr lang="en-US" sz="1600" b="1" dirty="0" err="1">
+                <a:solidFill>
+                  <a:schemeClr val="bg1"/>
+                </a:solidFill>
+              </a:rPr>
+              <a:t>Đăng</a:t>
+            </a:r>
+            <a:r>
+              <a:rPr lang="en-US" sz="1600" b="1">
+                <a:solidFill>
+                  <a:schemeClr val="bg1"/>
+                </a:solidFill>
+              </a:rPr>
+              <a:t> Khoa</a:t>
             </a:r>
             <a:endParaRPr lang="en-US" sz="1400" dirty="0"/>
           </a:p>
           <a:p>
-            <a:pPr indent="0" marL="0">
+            <a:pPr marL="0" indent="0">
               <a:buNone/>
             </a:pPr>
             <a:r>
@@ -2658,7 +2925,7 @@
           <a:bodyPr wrap="square" lIns="0" tIns="0" rIns="0" bIns="0" rtlCol="0" anchor="t"/>
           <a:lstStyle/>
           <a:p>
-            <a:pPr indent="0" marL="0">
+            <a:pPr marL="0" indent="0">
               <a:buNone/>
             </a:pPr>
             <a:r>
@@ -2667,12 +2934,28 @@
                   <a:schemeClr val="bg1"/>
                 </a:solidFill>
               </a:rPr>
-              <a:t>Người 2 – Họ và tên</a:t>
+              <a:t>Người 2 – Lê </a:t>
+            </a:r>
+            <a:r>
+              <a:rPr lang="en-US" sz="1600" b="1" dirty="0" err="1">
+                <a:solidFill>
+                  <a:schemeClr val="bg1"/>
+                </a:solidFill>
+              </a:rPr>
+              <a:t>Ẩn</a:t>
+            </a:r>
+            <a:r>
+              <a:rPr lang="en-US" sz="1600" b="1" dirty="0">
+                <a:solidFill>
+                  <a:schemeClr val="bg1"/>
+                </a:solidFill>
+              </a:rPr>
+              <a:t> Hoàng Ý</a:t>
             </a:r>
             <a:endParaRPr lang="en-US" sz="1400" dirty="0"/>
           </a:p>
           <a:p>
-            <a:pPr indent="0" marL="0">
+            <a:pPr marL="0" indent="0">
               <a:buNone/>
             </a:pPr>
             <a:r>
@@ -2735,7 +3018,7 @@
           <a:bodyPr wrap="square" lIns="0" tIns="0" rIns="0" bIns="0" rtlCol="0" anchor="t"/>
           <a:lstStyle/>
           <a:p>
-            <a:pPr indent="0" marL="0">
+            <a:pPr marL="0" indent="0">
               <a:buNone/>
             </a:pPr>
             <a:r>
@@ -2744,12 +3027,44 @@
                   <a:schemeClr val="bg1"/>
                 </a:solidFill>
               </a:rPr>
-              <a:t>Người 3 – Họ và tên</a:t>
+              <a:t>Người 3 – </a:t>
+            </a:r>
+            <a:r>
+              <a:rPr lang="en-US" sz="1600" b="1" dirty="0" err="1">
+                <a:solidFill>
+                  <a:schemeClr val="bg1"/>
+                </a:solidFill>
+              </a:rPr>
+              <a:t>Hồ</a:t>
+            </a:r>
+            <a:r>
+              <a:rPr lang="en-US" sz="1600" b="1" dirty="0">
+                <a:solidFill>
+                  <a:schemeClr val="bg1"/>
+                </a:solidFill>
+              </a:rPr>
+              <a:t> </a:t>
+            </a:r>
+            <a:r>
+              <a:rPr lang="en-US" sz="1600" b="1" dirty="0" err="1">
+                <a:solidFill>
+                  <a:schemeClr val="bg1"/>
+                </a:solidFill>
+              </a:rPr>
+              <a:t>Sĩ</a:t>
+            </a:r>
+            <a:r>
+              <a:rPr lang="en-US" sz="1600" b="1" dirty="0">
+                <a:solidFill>
+                  <a:schemeClr val="bg1"/>
+                </a:solidFill>
+              </a:rPr>
+              <a:t> Tuấn</a:t>
             </a:r>
             <a:endParaRPr lang="en-US" sz="1400" dirty="0"/>
           </a:p>
           <a:p>
-            <a:pPr indent="0" marL="0">
+            <a:pPr marL="0" indent="0">
               <a:buNone/>
             </a:pPr>
             <a:r>
@@ -2785,17 +3100,9 @@
           <a:bodyPr wrap="square" lIns="0" tIns="0" rIns="0" bIns="0" rtlCol="0" anchor="t"/>
           <a:lstStyle/>
           <a:p>
-            <a:pPr indent="0" marL="0">
-              <a:buNone/>
-            </a:pPr>
-            <a:r>
-              <a:rPr lang="en-US" sz="1300" dirty="0">
-                <a:solidFill>
-                  <a:srgbClr val="CFE3D6"/>
-                </a:solidFill>
-              </a:rPr>
-              <a:t>Giảng viên hướng dẫn: …</a:t>
-            </a:r>
+            <a:pPr marL="0" indent="0">
+              <a:buNone/>
+            </a:pPr>
             <a:endParaRPr lang="en-US" sz="1300" dirty="0"/>
           </a:p>
         </p:txBody>
@@ -2828,9 +3135,11 @@
       <p:sp>
         <p:nvSpPr>
           <p:cNvPr id="2" name="Text 0"/>
-          <p:cNvSpPr/>
+          <p:cNvSpPr>
+            <a:spLocks noGrp="1"/>
+          </p:cNvSpPr>
           <p:nvPr>
-            <p:ph idx="100" type="title" hasCustomPrompt="1"/>
+            <p:ph type="title" idx="100" hasCustomPrompt="1"/>
           </p:nvPr>
         </p:nvSpPr>
         <p:spPr>
@@ -2848,7 +3157,7 @@
           <a:bodyPr wrap="square" lIns="0" tIns="0" rIns="0" bIns="0" rtlCol="0" anchor="ctr"/>
           <a:lstStyle/>
           <a:p>
-            <a:pPr algn="l" indent="0" marL="0">
+            <a:pPr marL="0" indent="0" algn="l">
               <a:buNone/>
             </a:pPr>
             <a:r>
@@ -2869,9 +3178,11 @@
       <p:sp>
         <p:nvSpPr>
           <p:cNvPr id="3" name="Text 0"/>
-          <p:cNvSpPr/>
+          <p:cNvSpPr>
+            <a:spLocks noGrp="1"/>
+          </p:cNvSpPr>
           <p:nvPr>
-            <p:ph idx="101" type="body" hasCustomPrompt="1"/>
+            <p:ph type="body" idx="101" hasCustomPrompt="1"/>
           </p:nvPr>
         </p:nvSpPr>
         <p:spPr>
@@ -2889,7 +3200,7 @@
           <a:bodyPr wrap="square" lIns="0" tIns="0" rIns="0" bIns="0" rtlCol="0" anchor="t"/>
           <a:lstStyle/>
           <a:p>
-            <a:pPr indent="0" marL="0">
+            <a:pPr marL="0" indent="0">
               <a:buNone/>
             </a:pPr>
             <a:r>
@@ -2958,14 +3269,14 @@
       </p:sp>
       <p:pic>
         <p:nvPicPr>
-          <p:cNvPr id="6" name="intro-problem-icon" descr="preencoded.png">    </p:cNvPr>
+          <p:cNvPr id="6" name="intro-problem-icon" descr="preencoded.png"/>
           <p:cNvPicPr>
             <a:picLocks noChangeAspect="1"/>
           </p:cNvPicPr>
           <p:nvPr/>
         </p:nvPicPr>
         <p:blipFill>
-          <a:blip r:embed="rId1"/>
+          <a:blip r:embed="rId3"/>
           <a:stretch>
             <a:fillRect/>
           </a:stretch>
@@ -3001,7 +3312,7 @@
           <a:bodyPr wrap="square" lIns="0" tIns="0" rIns="0" bIns="0" rtlCol="0" anchor="t"/>
           <a:lstStyle/>
           <a:p>
-            <a:pPr indent="0" marL="0">
+            <a:pPr marL="0" indent="0">
               <a:buNone/>
             </a:pPr>
             <a:r>
@@ -3149,14 +3460,14 @@
       </p:sp>
       <p:pic>
         <p:nvPicPr>
-          <p:cNvPr id="11" name="intro-goal-icon" descr="preencoded.png">    </p:cNvPr>
+          <p:cNvPr id="11" name="intro-goal-icon" descr="preencoded.png"/>
           <p:cNvPicPr>
             <a:picLocks noChangeAspect="1"/>
           </p:cNvPicPr>
           <p:nvPr/>
         </p:nvPicPr>
         <p:blipFill>
-          <a:blip r:embed="rId2"/>
+          <a:blip r:embed="rId4"/>
           <a:stretch>
             <a:fillRect/>
           </a:stretch>
@@ -3192,7 +3503,7 @@
           <a:bodyPr wrap="square" lIns="0" tIns="0" rIns="0" bIns="0" rtlCol="0" anchor="t"/>
           <a:lstStyle/>
           <a:p>
-            <a:pPr indent="0" marL="0">
+            <a:pPr marL="0" indent="0">
               <a:buNone/>
             </a:pPr>
             <a:r>
@@ -3307,7 +3618,7 @@
           <a:bodyPr wrap="square" lIns="0" tIns="0" rIns="0" bIns="0" rtlCol="0" anchor="t"/>
           <a:lstStyle/>
           <a:p>
-            <a:pPr indent="0" marL="0">
+            <a:pPr marL="0" indent="0">
               <a:buNone/>
             </a:pPr>
             <a:r>
@@ -3376,14 +3687,14 @@
       </p:sp>
       <p:pic>
         <p:nvPicPr>
-          <p:cNvPr id="17" name="intro-layer1-icon" descr="preencoded.png">    </p:cNvPr>
+          <p:cNvPr id="17" name="intro-layer1-icon" descr="preencoded.png"/>
           <p:cNvPicPr>
             <a:picLocks noChangeAspect="1"/>
           </p:cNvPicPr>
           <p:nvPr/>
         </p:nvPicPr>
         <p:blipFill>
-          <a:blip r:embed="rId3"/>
+          <a:blip r:embed="rId5"/>
           <a:stretch>
             <a:fillRect/>
           </a:stretch>
@@ -3419,7 +3730,7 @@
           <a:bodyPr wrap="square" lIns="0" tIns="0" rIns="0" bIns="0" rtlCol="0" anchor="t"/>
           <a:lstStyle/>
           <a:p>
-            <a:pPr indent="0" marL="0">
+            <a:pPr marL="0" indent="0">
               <a:buNone/>
             </a:pPr>
             <a:r>
@@ -3433,7 +3744,7 @@
             <a:endParaRPr lang="en-US" sz="1400" dirty="0"/>
           </a:p>
           <a:p>
-            <a:pPr indent="0" marL="0">
+            <a:pPr marL="0" indent="0">
               <a:buNone/>
             </a:pPr>
             <a:r>
@@ -3527,14 +3838,14 @@
       </p:sp>
       <p:pic>
         <p:nvPicPr>
-          <p:cNvPr id="22" name="intro-layer2-icon" descr="preencoded.png">    </p:cNvPr>
+          <p:cNvPr id="22" name="intro-layer2-icon" descr="preencoded.png"/>
           <p:cNvPicPr>
             <a:picLocks noChangeAspect="1"/>
           </p:cNvPicPr>
           <p:nvPr/>
         </p:nvPicPr>
         <p:blipFill>
-          <a:blip r:embed="rId4"/>
+          <a:blip r:embed="rId6"/>
           <a:stretch>
             <a:fillRect/>
           </a:stretch>
@@ -3570,7 +3881,7 @@
           <a:bodyPr wrap="square" lIns="0" tIns="0" rIns="0" bIns="0" rtlCol="0" anchor="t"/>
           <a:lstStyle/>
           <a:p>
-            <a:pPr indent="0" marL="0">
+            <a:pPr marL="0" indent="0">
               <a:buNone/>
             </a:pPr>
             <a:r>
@@ -3584,7 +3895,7 @@
             <a:endParaRPr lang="en-US" sz="1400" dirty="0"/>
           </a:p>
           <a:p>
-            <a:pPr indent="0" marL="0">
+            <a:pPr marL="0" indent="0">
               <a:buNone/>
             </a:pPr>
             <a:r>
@@ -3678,14 +3989,14 @@
       </p:sp>
       <p:pic>
         <p:nvPicPr>
-          <p:cNvPr id="27" name="intro-layer3-icon" descr="preencoded.png">    </p:cNvPr>
+          <p:cNvPr id="27" name="intro-layer3-icon" descr="preencoded.png"/>
           <p:cNvPicPr>
             <a:picLocks noChangeAspect="1"/>
           </p:cNvPicPr>
           <p:nvPr/>
         </p:nvPicPr>
         <p:blipFill>
-          <a:blip r:embed="rId5"/>
+          <a:blip r:embed="rId7"/>
           <a:stretch>
             <a:fillRect/>
           </a:stretch>
@@ -3721,7 +4032,7 @@
           <a:bodyPr wrap="square" lIns="0" tIns="0" rIns="0" bIns="0" rtlCol="0" anchor="t"/>
           <a:lstStyle/>
           <a:p>
-            <a:pPr indent="0" marL="0">
+            <a:pPr marL="0" indent="0">
               <a:buNone/>
             </a:pPr>
             <a:r>
@@ -3735,7 +4046,7 @@
             <a:endParaRPr lang="en-US" sz="1400" dirty="0"/>
           </a:p>
           <a:p>
-            <a:pPr indent="0" marL="0">
+            <a:pPr marL="0" indent="0">
               <a:buNone/>
             </a:pPr>
             <a:r>
@@ -3829,14 +4140,14 @@
       </p:sp>
       <p:pic>
         <p:nvPicPr>
-          <p:cNvPr id="32" name="intro-layer4-icon" descr="preencoded.png">    </p:cNvPr>
+          <p:cNvPr id="32" name="intro-layer4-icon" descr="preencoded.png"/>
           <p:cNvPicPr>
             <a:picLocks noChangeAspect="1"/>
           </p:cNvPicPr>
           <p:nvPr/>
         </p:nvPicPr>
         <p:blipFill>
-          <a:blip r:embed="rId6"/>
+          <a:blip r:embed="rId8"/>
           <a:stretch>
             <a:fillRect/>
           </a:stretch>
@@ -3872,7 +4183,7 @@
           <a:bodyPr wrap="square" lIns="0" tIns="0" rIns="0" bIns="0" rtlCol="0" anchor="t"/>
           <a:lstStyle/>
           <a:p>
-            <a:pPr indent="0" marL="0">
+            <a:pPr marL="0" indent="0">
               <a:buNone/>
             </a:pPr>
             <a:r>
@@ -3886,7 +4197,7 @@
             <a:endParaRPr lang="en-US" sz="1400" dirty="0"/>
           </a:p>
           <a:p>
-            <a:pPr indent="0" marL="0">
+            <a:pPr marL="0" indent="0">
               <a:buNone/>
             </a:pPr>
             <a:r>
@@ -3922,7 +4233,7 @@
           <a:bodyPr wrap="square" lIns="0" tIns="0" rIns="0" bIns="0" rtlCol="0" anchor="t"/>
           <a:lstStyle/>
           <a:p>
-            <a:pPr indent="0" marL="0">
+            <a:pPr marL="0" indent="0">
               <a:buNone/>
             </a:pPr>
             <a:r>
@@ -3939,7 +4250,7 @@
       </p:sp>
       <p:sp>
         <p:nvSpPr>
-          <p:cNvPr id="25" name="Slide Number Placeholder 0"/>
+          <p:cNvPr id="35" name="Slide Number Placeholder 0"/>
           <p:cNvSpPr>
             <a:spLocks noGrp="1"/>
           </p:cNvSpPr>
@@ -3957,7 +4268,7 @@
           </a:prstGeom>
           <a:extLst>
             <a:ext uri="{C572A759-6A51-4108-AA02-DFA0A04FC94B}">
-              <ma14:wrappingTextBoxFlag xmlns:ma14="http://schemas.microsoft.com/office/mac/drawingml/2011/main" val="0"/>
+              <ma14:wrappingTextBoxFlag xmlns="" xmlns:ma14="http://schemas.microsoft.com/office/mac/drawingml/2011/main" val="0"/>
             </a:ext>
           </a:extLst>
         </p:spPr>
@@ -3975,7 +4286,7 @@
           <a:p>
             <a:pPr algn="r"/>
             <a:fld id="{F7021451-1387-4CA6-816F-3879F97B5CBC}" type="slidenum">
-              <a:rPr b="0" lang="en-US"/>
+              <a:rPr lang="en-US" b="0"/>
               <a:t>2</a:t>
             </a:fld>
             <a:endParaRPr lang="en-US"/>
@@ -4010,9 +4321,11 @@
       <p:sp>
         <p:nvSpPr>
           <p:cNvPr id="2" name="Text 0"/>
-          <p:cNvSpPr/>
+          <p:cNvSpPr>
+            <a:spLocks noGrp="1"/>
+          </p:cNvSpPr>
           <p:nvPr>
-            <p:ph idx="100" type="title" hasCustomPrompt="1"/>
+            <p:ph type="title" idx="100" hasCustomPrompt="1"/>
           </p:nvPr>
         </p:nvSpPr>
         <p:spPr>
@@ -4030,7 +4343,7 @@
           <a:bodyPr wrap="square" lIns="0" tIns="0" rIns="0" bIns="0" rtlCol="0" anchor="ctr"/>
           <a:lstStyle/>
           <a:p>
-            <a:pPr algn="l" indent="0" marL="0">
+            <a:pPr marL="0" indent="0" algn="l">
               <a:buNone/>
             </a:pPr>
             <a:r>
@@ -4051,9 +4364,11 @@
       <p:sp>
         <p:nvSpPr>
           <p:cNvPr id="3" name="Text 0"/>
-          <p:cNvSpPr/>
+          <p:cNvSpPr>
+            <a:spLocks noGrp="1"/>
+          </p:cNvSpPr>
           <p:nvPr>
-            <p:ph idx="101" type="body" hasCustomPrompt="1"/>
+            <p:ph type="body" idx="101" hasCustomPrompt="1"/>
           </p:nvPr>
         </p:nvSpPr>
         <p:spPr>
@@ -4071,7 +4386,7 @@
           <a:bodyPr wrap="square" lIns="0" tIns="0" rIns="0" bIns="0" rtlCol="0" anchor="t"/>
           <a:lstStyle/>
           <a:p>
-            <a:pPr indent="0" marL="0">
+            <a:pPr marL="0" indent="0">
               <a:buNone/>
             </a:pPr>
             <a:r>
@@ -4134,7 +4449,7 @@
           <a:bodyPr wrap="square" lIns="0" tIns="0" rIns="0" bIns="0" rtlCol="0" anchor="t"/>
           <a:lstStyle/>
           <a:p>
-            <a:pPr indent="0" marL="0">
+            <a:pPr marL="0" indent="0">
               <a:buNone/>
             </a:pPr>
             <a:r>
@@ -4179,14 +4494,14 @@
       </p:sp>
       <p:pic>
         <p:nvPicPr>
-          <p:cNvPr id="7" name="p1a-sensor0-icon" descr="preencoded.png">    </p:cNvPr>
+          <p:cNvPr id="7" name="p1a-sensor0-icon" descr="preencoded.png"/>
           <p:cNvPicPr>
             <a:picLocks noChangeAspect="1"/>
           </p:cNvPicPr>
           <p:nvPr/>
         </p:nvPicPr>
         <p:blipFill>
-          <a:blip r:embed="rId1"/>
+          <a:blip r:embed="rId3"/>
           <a:stretch>
             <a:fillRect/>
           </a:stretch>
@@ -4222,7 +4537,7 @@
           <a:bodyPr wrap="square" lIns="0" tIns="0" rIns="0" bIns="0" rtlCol="0" anchor="t"/>
           <a:lstStyle/>
           <a:p>
-            <a:pPr indent="0" marL="0">
+            <a:pPr marL="0" indent="0">
               <a:buNone/>
             </a:pPr>
             <a:r>
@@ -4236,7 +4551,7 @@
             <a:endParaRPr lang="en-US" sz="1400" dirty="0"/>
           </a:p>
           <a:p>
-            <a:pPr indent="0" marL="0">
+            <a:pPr marL="0" indent="0">
               <a:buNone/>
             </a:pPr>
             <a:r>
@@ -4250,7 +4565,7 @@
             <a:endParaRPr lang="en-US" sz="1400" dirty="0"/>
           </a:p>
           <a:p>
-            <a:pPr indent="0" marL="0">
+            <a:pPr marL="0" indent="0">
               <a:buNone/>
             </a:pPr>
             <a:r>
@@ -4292,14 +4607,14 @@
       </p:sp>
       <p:pic>
         <p:nvPicPr>
-          <p:cNvPr id="10" name="p1a-sensor1-icon" descr="preencoded.png">    </p:cNvPr>
+          <p:cNvPr id="10" name="p1a-sensor1-icon" descr="preencoded.png"/>
           <p:cNvPicPr>
             <a:picLocks noChangeAspect="1"/>
           </p:cNvPicPr>
           <p:nvPr/>
         </p:nvPicPr>
         <p:blipFill>
-          <a:blip r:embed="rId2"/>
+          <a:blip r:embed="rId4"/>
           <a:stretch>
             <a:fillRect/>
           </a:stretch>
@@ -4335,7 +4650,7 @@
           <a:bodyPr wrap="square" lIns="0" tIns="0" rIns="0" bIns="0" rtlCol="0" anchor="t"/>
           <a:lstStyle/>
           <a:p>
-            <a:pPr indent="0" marL="0">
+            <a:pPr marL="0" indent="0">
               <a:buNone/>
             </a:pPr>
             <a:r>
@@ -4349,7 +4664,7 @@
             <a:endParaRPr lang="en-US" sz="1400" dirty="0"/>
           </a:p>
           <a:p>
-            <a:pPr indent="0" marL="0">
+            <a:pPr marL="0" indent="0">
               <a:buNone/>
             </a:pPr>
             <a:r>
@@ -4363,7 +4678,7 @@
             <a:endParaRPr lang="en-US" sz="1400" dirty="0"/>
           </a:p>
           <a:p>
-            <a:pPr indent="0" marL="0">
+            <a:pPr marL="0" indent="0">
               <a:buNone/>
             </a:pPr>
             <a:r>
@@ -4405,14 +4720,14 @@
       </p:sp>
       <p:pic>
         <p:nvPicPr>
-          <p:cNvPr id="13" name="p1a-sensor2-icon" descr="preencoded.png">    </p:cNvPr>
+          <p:cNvPr id="13" name="p1a-sensor2-icon" descr="preencoded.png"/>
           <p:cNvPicPr>
             <a:picLocks noChangeAspect="1"/>
           </p:cNvPicPr>
           <p:nvPr/>
         </p:nvPicPr>
         <p:blipFill>
-          <a:blip r:embed="rId3"/>
+          <a:blip r:embed="rId5"/>
           <a:stretch>
             <a:fillRect/>
           </a:stretch>
@@ -4448,7 +4763,7 @@
           <a:bodyPr wrap="square" lIns="0" tIns="0" rIns="0" bIns="0" rtlCol="0" anchor="t"/>
           <a:lstStyle/>
           <a:p>
-            <a:pPr indent="0" marL="0">
+            <a:pPr marL="0" indent="0">
               <a:buNone/>
             </a:pPr>
             <a:r>
@@ -4462,7 +4777,7 @@
             <a:endParaRPr lang="en-US" sz="1400" dirty="0"/>
           </a:p>
           <a:p>
-            <a:pPr indent="0" marL="0">
+            <a:pPr marL="0" indent="0">
               <a:buNone/>
             </a:pPr>
             <a:r>
@@ -4476,7 +4791,7 @@
             <a:endParaRPr lang="en-US" sz="1400" dirty="0"/>
           </a:p>
           <a:p>
-            <a:pPr indent="0" marL="0">
+            <a:pPr marL="0" indent="0">
               <a:buNone/>
             </a:pPr>
             <a:r>
@@ -4539,7 +4854,7 @@
           <a:bodyPr wrap="square" lIns="0" tIns="0" rIns="0" bIns="0" rtlCol="0" anchor="t"/>
           <a:lstStyle/>
           <a:p>
-            <a:pPr indent="0" marL="0">
+            <a:pPr marL="0" indent="0">
               <a:buNone/>
             </a:pPr>
             <a:r>
@@ -4584,14 +4899,14 @@
       </p:sp>
       <p:pic>
         <p:nvPicPr>
-          <p:cNvPr id="18" name="p1a-relay0-icon" descr="preencoded.png">    </p:cNvPr>
+          <p:cNvPr id="18" name="p1a-relay0-icon" descr="preencoded.png"/>
           <p:cNvPicPr>
             <a:picLocks noChangeAspect="1"/>
           </p:cNvPicPr>
           <p:nvPr/>
         </p:nvPicPr>
         <p:blipFill>
-          <a:blip r:embed="rId4"/>
+          <a:blip r:embed="rId6"/>
           <a:stretch>
             <a:fillRect/>
           </a:stretch>
@@ -4627,7 +4942,7 @@
           <a:bodyPr wrap="square" lIns="0" tIns="0" rIns="0" bIns="0" rtlCol="0" anchor="t"/>
           <a:lstStyle/>
           <a:p>
-            <a:pPr indent="0" marL="0">
+            <a:pPr marL="0" indent="0">
               <a:buNone/>
             </a:pPr>
             <a:r>
@@ -4641,7 +4956,7 @@
             <a:endParaRPr lang="en-US" sz="1400" dirty="0"/>
           </a:p>
           <a:p>
-            <a:pPr indent="0" marL="0">
+            <a:pPr marL="0" indent="0">
               <a:buNone/>
             </a:pPr>
             <a:r>
@@ -4655,7 +4970,7 @@
             <a:endParaRPr lang="en-US" sz="1400" dirty="0"/>
           </a:p>
           <a:p>
-            <a:pPr indent="0" marL="0">
+            <a:pPr marL="0" indent="0">
               <a:buNone/>
             </a:pPr>
             <a:r>
@@ -4697,14 +5012,14 @@
       </p:sp>
       <p:pic>
         <p:nvPicPr>
-          <p:cNvPr id="21" name="p1a-relay1-icon" descr="preencoded.png">    </p:cNvPr>
+          <p:cNvPr id="21" name="p1a-relay1-icon" descr="preencoded.png"/>
           <p:cNvPicPr>
             <a:picLocks noChangeAspect="1"/>
           </p:cNvPicPr>
           <p:nvPr/>
         </p:nvPicPr>
         <p:blipFill>
-          <a:blip r:embed="rId5"/>
+          <a:blip r:embed="rId7"/>
           <a:stretch>
             <a:fillRect/>
           </a:stretch>
@@ -4740,7 +5055,7 @@
           <a:bodyPr wrap="square" lIns="0" tIns="0" rIns="0" bIns="0" rtlCol="0" anchor="t"/>
           <a:lstStyle/>
           <a:p>
-            <a:pPr indent="0" marL="0">
+            <a:pPr marL="0" indent="0">
               <a:buNone/>
             </a:pPr>
             <a:r>
@@ -4754,7 +5069,7 @@
             <a:endParaRPr lang="en-US" sz="1400" dirty="0"/>
           </a:p>
           <a:p>
-            <a:pPr indent="0" marL="0">
+            <a:pPr marL="0" indent="0">
               <a:buNone/>
             </a:pPr>
             <a:r>
@@ -4768,7 +5083,7 @@
             <a:endParaRPr lang="en-US" sz="1400" dirty="0"/>
           </a:p>
           <a:p>
-            <a:pPr indent="0" marL="0">
+            <a:pPr marL="0" indent="0">
               <a:buNone/>
             </a:pPr>
             <a:r>
@@ -4810,14 +5125,14 @@
       </p:sp>
       <p:pic>
         <p:nvPicPr>
-          <p:cNvPr id="24" name="p1a-relay2-icon" descr="preencoded.png">    </p:cNvPr>
+          <p:cNvPr id="24" name="p1a-relay2-icon" descr="preencoded.png"/>
           <p:cNvPicPr>
             <a:picLocks noChangeAspect="1"/>
           </p:cNvPicPr>
           <p:nvPr/>
         </p:nvPicPr>
         <p:blipFill>
-          <a:blip r:embed="rId6"/>
+          <a:blip r:embed="rId8"/>
           <a:stretch>
             <a:fillRect/>
           </a:stretch>
@@ -4853,7 +5168,7 @@
           <a:bodyPr wrap="square" lIns="0" tIns="0" rIns="0" bIns="0" rtlCol="0" anchor="t"/>
           <a:lstStyle/>
           <a:p>
-            <a:pPr indent="0" marL="0">
+            <a:pPr marL="0" indent="0">
               <a:buNone/>
             </a:pPr>
             <a:r>
@@ -4867,7 +5182,7 @@
             <a:endParaRPr lang="en-US" sz="1400" dirty="0"/>
           </a:p>
           <a:p>
-            <a:pPr indent="0" marL="0">
+            <a:pPr marL="0" indent="0">
               <a:buNone/>
             </a:pPr>
             <a:r>
@@ -4881,7 +5196,7 @@
             <a:endParaRPr lang="en-US" sz="1400" dirty="0"/>
           </a:p>
           <a:p>
-            <a:pPr indent="0" marL="0">
+            <a:pPr marL="0" indent="0">
               <a:buNone/>
             </a:pPr>
             <a:r>
@@ -4923,14 +5238,14 @@
       </p:sp>
       <p:pic>
         <p:nvPicPr>
-          <p:cNvPr id="27" name="p1a-esp32-icon" descr="preencoded.png">    </p:cNvPr>
+          <p:cNvPr id="27" name="p1a-esp32-icon" descr="preencoded.png"/>
           <p:cNvPicPr>
             <a:picLocks noChangeAspect="1"/>
           </p:cNvPicPr>
           <p:nvPr/>
         </p:nvPicPr>
         <p:blipFill>
-          <a:blip r:embed="rId7"/>
+          <a:blip r:embed="rId9"/>
           <a:stretch>
             <a:fillRect/>
           </a:stretch>
@@ -4966,7 +5281,7 @@
           <a:bodyPr wrap="square" lIns="0" tIns="0" rIns="0" bIns="0" rtlCol="0" anchor="t"/>
           <a:lstStyle/>
           <a:p>
-            <a:pPr algn="ctr" indent="0" marL="0">
+            <a:pPr marL="0" indent="0" algn="ctr">
               <a:buNone/>
             </a:pPr>
             <a:r>
@@ -5002,7 +5317,7 @@
           <a:bodyPr wrap="square" lIns="0" tIns="0" rIns="0" bIns="0" rtlCol="0" anchor="t"/>
           <a:lstStyle/>
           <a:p>
-            <a:pPr algn="ctr" indent="0" marL="0">
+            <a:pPr marL="0" indent="0" algn="ctr">
               <a:buNone/>
             </a:pPr>
             <a:r>
@@ -5069,7 +5384,7 @@
       </p:sp>
       <p:sp>
         <p:nvSpPr>
-          <p:cNvPr id="25" name="Slide Number Placeholder 0"/>
+          <p:cNvPr id="32" name="Slide Number Placeholder 0"/>
           <p:cNvSpPr>
             <a:spLocks noGrp="1"/>
           </p:cNvSpPr>
@@ -5087,7 +5402,7 @@
           </a:prstGeom>
           <a:extLst>
             <a:ext uri="{C572A759-6A51-4108-AA02-DFA0A04FC94B}">
-              <ma14:wrappingTextBoxFlag xmlns:ma14="http://schemas.microsoft.com/office/mac/drawingml/2011/main" val="0"/>
+              <ma14:wrappingTextBoxFlag xmlns="" xmlns:ma14="http://schemas.microsoft.com/office/mac/drawingml/2011/main" val="0"/>
             </a:ext>
           </a:extLst>
         </p:spPr>
@@ -5105,7 +5420,7 @@
           <a:p>
             <a:pPr algn="r"/>
             <a:fld id="{F7021451-1387-4CA6-816F-3879F97B5CBC}" type="slidenum">
-              <a:rPr b="0" lang="en-US"/>
+              <a:rPr lang="en-US" b="0"/>
               <a:t>3</a:t>
             </a:fld>
             <a:endParaRPr lang="en-US"/>
@@ -5140,9 +5455,11 @@
       <p:sp>
         <p:nvSpPr>
           <p:cNvPr id="2" name="Text 0"/>
-          <p:cNvSpPr/>
+          <p:cNvSpPr>
+            <a:spLocks noGrp="1"/>
+          </p:cNvSpPr>
           <p:nvPr>
-            <p:ph idx="100" type="title" hasCustomPrompt="1"/>
+            <p:ph type="title" idx="100" hasCustomPrompt="1"/>
           </p:nvPr>
         </p:nvSpPr>
         <p:spPr>
@@ -5160,7 +5477,7 @@
           <a:bodyPr wrap="square" lIns="0" tIns="0" rIns="0" bIns="0" rtlCol="0" anchor="ctr"/>
           <a:lstStyle/>
           <a:p>
-            <a:pPr algn="l" indent="0" marL="0">
+            <a:pPr marL="0" indent="0" algn="l">
               <a:buNone/>
             </a:pPr>
             <a:r>
@@ -5181,9 +5498,11 @@
       <p:sp>
         <p:nvSpPr>
           <p:cNvPr id="3" name="Text 0"/>
-          <p:cNvSpPr/>
+          <p:cNvSpPr>
+            <a:spLocks noGrp="1"/>
+          </p:cNvSpPr>
           <p:nvPr>
-            <p:ph idx="101" type="body" hasCustomPrompt="1"/>
+            <p:ph type="body" idx="101" hasCustomPrompt="1"/>
           </p:nvPr>
         </p:nvSpPr>
         <p:spPr>
@@ -5201,7 +5520,7 @@
           <a:bodyPr wrap="square" lIns="0" tIns="0" rIns="0" bIns="0" rtlCol="0" anchor="t"/>
           <a:lstStyle/>
           <a:p>
-            <a:pPr indent="0" marL="0">
+            <a:pPr marL="0" indent="0">
               <a:buNone/>
             </a:pPr>
             <a:r>
@@ -5270,14 +5589,14 @@
       </p:sp>
       <p:pic>
         <p:nvPicPr>
-          <p:cNvPr id="6" name="p1b-collect-icon" descr="preencoded.png">    </p:cNvPr>
+          <p:cNvPr id="6" name="p1b-collect-icon" descr="preencoded.png"/>
           <p:cNvPicPr>
             <a:picLocks noChangeAspect="1"/>
           </p:cNvPicPr>
           <p:nvPr/>
         </p:nvPicPr>
         <p:blipFill>
-          <a:blip r:embed="rId1"/>
+          <a:blip r:embed="rId3"/>
           <a:stretch>
             <a:fillRect/>
           </a:stretch>
@@ -5313,7 +5632,7 @@
           <a:bodyPr wrap="square" lIns="0" tIns="0" rIns="0" bIns="0" rtlCol="0" anchor="t"/>
           <a:lstStyle/>
           <a:p>
-            <a:pPr indent="0" marL="0">
+            <a:pPr marL="0" indent="0">
               <a:buNone/>
             </a:pPr>
             <a:r>
@@ -5461,14 +5780,14 @@
       </p:sp>
       <p:pic>
         <p:nvPicPr>
-          <p:cNvPr id="11" name="p1b-control-icon" descr="preencoded.png">    </p:cNvPr>
+          <p:cNvPr id="11" name="p1b-control-icon" descr="preencoded.png"/>
           <p:cNvPicPr>
             <a:picLocks noChangeAspect="1"/>
           </p:cNvPicPr>
           <p:nvPr/>
         </p:nvPicPr>
         <p:blipFill>
-          <a:blip r:embed="rId2"/>
+          <a:blip r:embed="rId4"/>
           <a:stretch>
             <a:fillRect/>
           </a:stretch>
@@ -5504,7 +5823,7 @@
           <a:bodyPr wrap="square" lIns="0" tIns="0" rIns="0" bIns="0" rtlCol="0" anchor="t"/>
           <a:lstStyle/>
           <a:p>
-            <a:pPr indent="0" marL="0">
+            <a:pPr marL="0" indent="0">
               <a:buNone/>
             </a:pPr>
             <a:r>
@@ -5619,7 +5938,7 @@
           <a:bodyPr wrap="square" lIns="0" tIns="0" rIns="0" bIns="0" rtlCol="0" anchor="t"/>
           <a:lstStyle/>
           <a:p>
-            <a:pPr indent="0" marL="0">
+            <a:pPr marL="0" indent="0">
               <a:buNone/>
             </a:pPr>
             <a:r>
@@ -5682,7 +6001,7 @@
           <a:bodyPr wrap="square" lIns="0" tIns="0" rIns="0" bIns="0" rtlCol="0" anchor="ctr"/>
           <a:lstStyle/>
           <a:p>
-            <a:pPr algn="ctr" indent="0" marL="0">
+            <a:pPr marL="0" indent="0" algn="ctr">
               <a:buNone/>
             </a:pPr>
             <a:r>
@@ -5696,7 +6015,7 @@
             <a:endParaRPr lang="en-US" sz="1400" dirty="0"/>
           </a:p>
           <a:p>
-            <a:pPr algn="ctr" indent="0" marL="0">
+            <a:pPr marL="0" indent="0" algn="ctr">
               <a:buNone/>
             </a:pPr>
             <a:r>
@@ -5759,7 +6078,7 @@
           <a:bodyPr wrap="square" lIns="0" tIns="0" rIns="0" bIns="0" rtlCol="0" anchor="ctr"/>
           <a:lstStyle/>
           <a:p>
-            <a:pPr algn="ctr" indent="0" marL="0">
+            <a:pPr marL="0" indent="0" algn="ctr">
               <a:buNone/>
             </a:pPr>
             <a:r>
@@ -5773,7 +6092,7 @@
             <a:endParaRPr lang="en-US" sz="1400" dirty="0"/>
           </a:p>
           <a:p>
-            <a:pPr algn="ctr" indent="0" marL="0">
+            <a:pPr marL="0" indent="0" algn="ctr">
               <a:buNone/>
             </a:pPr>
             <a:r>
@@ -5836,7 +6155,7 @@
           <a:bodyPr wrap="square" lIns="0" tIns="0" rIns="0" bIns="0" rtlCol="0" anchor="ctr"/>
           <a:lstStyle/>
           <a:p>
-            <a:pPr algn="ctr" indent="0" marL="0">
+            <a:pPr marL="0" indent="0" algn="ctr">
               <a:buNone/>
             </a:pPr>
             <a:r>
@@ -5850,7 +6169,7 @@
             <a:endParaRPr lang="en-US" sz="1400" dirty="0"/>
           </a:p>
           <a:p>
-            <a:pPr algn="ctr" indent="0" marL="0">
+            <a:pPr marL="0" indent="0" algn="ctr">
               <a:buNone/>
             </a:pPr>
             <a:r>
@@ -5911,7 +6230,7 @@
           <a:bodyPr wrap="square" lIns="0" tIns="0" rIns="0" bIns="0" rtlCol="0" anchor="t"/>
           <a:lstStyle/>
           <a:p>
-            <a:pPr algn="ctr" indent="0" marL="0">
+            <a:pPr marL="0" indent="0" algn="ctr">
               <a:buNone/>
             </a:pPr>
             <a:r>
@@ -5972,7 +6291,7 @@
           <a:bodyPr wrap="square" lIns="0" tIns="0" rIns="0" bIns="0" rtlCol="0" anchor="t"/>
           <a:lstStyle/>
           <a:p>
-            <a:pPr algn="ctr" indent="0" marL="0">
+            <a:pPr marL="0" indent="0" algn="ctr">
               <a:buNone/>
             </a:pPr>
             <a:r>
@@ -6008,7 +6327,7 @@
           <a:bodyPr wrap="square" lIns="0" tIns="0" rIns="0" bIns="0" rtlCol="0" anchor="t"/>
           <a:lstStyle/>
           <a:p>
-            <a:pPr indent="0" marL="0">
+            <a:pPr marL="0" indent="0">
               <a:buNone/>
             </a:pPr>
             <a:r>
@@ -6019,9 +6338,6 @@
               </a:rPr>
               <a:t>Quay về chờ: </a:t>
             </a:r>
-            <a:pPr indent="0" marL="0">
-              <a:buNone/>
-            </a:pPr>
             <a:r>
               <a:rPr lang="en-US" sz="1400" dirty="0">
                 <a:solidFill>
@@ -6030,9 +6346,6 @@
               </a:rPr>
               <a:t>khi độ ẩm ≥ 80% (đủ ẩm), hoặc sau 60 giây nghỉ.  </a:t>
             </a:r>
-            <a:pPr indent="0" marL="0">
-              <a:buNone/>
-            </a:pPr>
             <a:r>
               <a:rPr lang="en-US" sz="1400" b="1" dirty="0">
                 <a:solidFill>
@@ -6041,9 +6354,6 @@
               </a:rPr>
               <a:t>Cạn nước hoặc hỏng cảm biến: </a:t>
             </a:r>
-            <a:pPr indent="0" marL="0">
-              <a:buNone/>
-            </a:pPr>
             <a:r>
               <a:rPr lang="en-US" sz="1400" dirty="0">
                 <a:solidFill>
@@ -6058,7 +6368,7 @@
       </p:sp>
       <p:sp>
         <p:nvSpPr>
-          <p:cNvPr id="25" name="Slide Number Placeholder 0"/>
+          <p:cNvPr id="26" name="Slide Number Placeholder 0"/>
           <p:cNvSpPr>
             <a:spLocks noGrp="1"/>
           </p:cNvSpPr>
@@ -6076,7 +6386,7 @@
           </a:prstGeom>
           <a:extLst>
             <a:ext uri="{C572A759-6A51-4108-AA02-DFA0A04FC94B}">
-              <ma14:wrappingTextBoxFlag xmlns:ma14="http://schemas.microsoft.com/office/mac/drawingml/2011/main" val="0"/>
+              <ma14:wrappingTextBoxFlag xmlns="" xmlns:ma14="http://schemas.microsoft.com/office/mac/drawingml/2011/main" val="0"/>
             </a:ext>
           </a:extLst>
         </p:spPr>
@@ -6094,7 +6404,7 @@
           <a:p>
             <a:pPr algn="r"/>
             <a:fld id="{F7021451-1387-4CA6-816F-3879F97B5CBC}" type="slidenum">
-              <a:rPr b="0" lang="en-US"/>
+              <a:rPr lang="en-US" b="0"/>
               <a:t>4</a:t>
             </a:fld>
             <a:endParaRPr lang="en-US"/>
@@ -6129,9 +6439,11 @@
       <p:sp>
         <p:nvSpPr>
           <p:cNvPr id="2" name="Text 0"/>
-          <p:cNvSpPr/>
+          <p:cNvSpPr>
+            <a:spLocks noGrp="1"/>
+          </p:cNvSpPr>
           <p:nvPr>
-            <p:ph idx="100" type="title" hasCustomPrompt="1"/>
+            <p:ph type="title" idx="100" hasCustomPrompt="1"/>
           </p:nvPr>
         </p:nvSpPr>
         <p:spPr>
@@ -6149,7 +6461,7 @@
           <a:bodyPr wrap="square" lIns="0" tIns="0" rIns="0" bIns="0" rtlCol="0" anchor="ctr"/>
           <a:lstStyle/>
           <a:p>
-            <a:pPr algn="l" indent="0" marL="0">
+            <a:pPr marL="0" indent="0" algn="l">
               <a:buNone/>
             </a:pPr>
             <a:r>
@@ -6170,9 +6482,11 @@
       <p:sp>
         <p:nvSpPr>
           <p:cNvPr id="3" name="Text 0"/>
-          <p:cNvSpPr/>
+          <p:cNvSpPr>
+            <a:spLocks noGrp="1"/>
+          </p:cNvSpPr>
           <p:nvPr>
-            <p:ph idx="101" type="body" hasCustomPrompt="1"/>
+            <p:ph type="body" idx="101" hasCustomPrompt="1"/>
           </p:nvPr>
         </p:nvSpPr>
         <p:spPr>
@@ -6190,7 +6504,7 @@
           <a:bodyPr wrap="square" lIns="0" tIns="0" rIns="0" bIns="0" rtlCol="0" anchor="t"/>
           <a:lstStyle/>
           <a:p>
-            <a:pPr indent="0" marL="0">
+            <a:pPr marL="0" indent="0">
               <a:buNone/>
             </a:pPr>
             <a:r>
@@ -6259,14 +6573,14 @@
       </p:sp>
       <p:pic>
         <p:nvPicPr>
-          <p:cNvPr id="6" name="p2a-node-ESP32-icon" descr="preencoded.png">    </p:cNvPr>
+          <p:cNvPr id="6" name="p2a-node-ESP32-icon" descr="preencoded.png"/>
           <p:cNvPicPr>
             <a:picLocks noChangeAspect="1"/>
           </p:cNvPicPr>
           <p:nvPr/>
         </p:nvPicPr>
         <p:blipFill>
-          <a:blip r:embed="rId1"/>
+          <a:blip r:embed="rId3"/>
           <a:stretch>
             <a:fillRect/>
           </a:stretch>
@@ -6302,7 +6616,7 @@
           <a:bodyPr wrap="square" lIns="0" tIns="0" rIns="0" bIns="0" rtlCol="0" anchor="t"/>
           <a:lstStyle/>
           <a:p>
-            <a:pPr algn="ctr" indent="0" marL="0">
+            <a:pPr marL="0" indent="0" algn="ctr">
               <a:buNone/>
             </a:pPr>
             <a:r>
@@ -6316,7 +6630,7 @@
             <a:endParaRPr lang="en-US" sz="1400" dirty="0"/>
           </a:p>
           <a:p>
-            <a:pPr algn="ctr" indent="0" marL="0">
+            <a:pPr marL="0" indent="0" algn="ctr">
               <a:buNone/>
             </a:pPr>
             <a:r>
@@ -6385,14 +6699,14 @@
       </p:sp>
       <p:pic>
         <p:nvPicPr>
-          <p:cNvPr id="10" name="p2a-node-Broker-icon" descr="preencoded.png">    </p:cNvPr>
+          <p:cNvPr id="10" name="p2a-node-Broker-icon" descr="preencoded.png"/>
           <p:cNvPicPr>
             <a:picLocks noChangeAspect="1"/>
           </p:cNvPicPr>
           <p:nvPr/>
         </p:nvPicPr>
         <p:blipFill>
-          <a:blip r:embed="rId2"/>
+          <a:blip r:embed="rId4"/>
           <a:stretch>
             <a:fillRect/>
           </a:stretch>
@@ -6428,7 +6742,7 @@
           <a:bodyPr wrap="square" lIns="0" tIns="0" rIns="0" bIns="0" rtlCol="0" anchor="t"/>
           <a:lstStyle/>
           <a:p>
-            <a:pPr algn="ctr" indent="0" marL="0">
+            <a:pPr marL="0" indent="0" algn="ctr">
               <a:buNone/>
             </a:pPr>
             <a:r>
@@ -6442,7 +6756,7 @@
             <a:endParaRPr lang="en-US" sz="1400" dirty="0"/>
           </a:p>
           <a:p>
-            <a:pPr algn="ctr" indent="0" marL="0">
+            <a:pPr marL="0" indent="0" algn="ctr">
               <a:buNone/>
             </a:pPr>
             <a:r>
@@ -6511,14 +6825,14 @@
       </p:sp>
       <p:pic>
         <p:nvPicPr>
-          <p:cNvPr id="14" name="p2a-node-Node-RED-icon" descr="preencoded.png">    </p:cNvPr>
+          <p:cNvPr id="14" name="p2a-node-Node-RED-icon" descr="preencoded.png"/>
           <p:cNvPicPr>
             <a:picLocks noChangeAspect="1"/>
           </p:cNvPicPr>
           <p:nvPr/>
         </p:nvPicPr>
         <p:blipFill>
-          <a:blip r:embed="rId3"/>
+          <a:blip r:embed="rId5"/>
           <a:stretch>
             <a:fillRect/>
           </a:stretch>
@@ -6554,7 +6868,7 @@
           <a:bodyPr wrap="square" lIns="0" tIns="0" rIns="0" bIns="0" rtlCol="0" anchor="t"/>
           <a:lstStyle/>
           <a:p>
-            <a:pPr algn="ctr" indent="0" marL="0">
+            <a:pPr marL="0" indent="0" algn="ctr">
               <a:buNone/>
             </a:pPr>
             <a:r>
@@ -6568,7 +6882,7 @@
             <a:endParaRPr lang="en-US" sz="1400" dirty="0"/>
           </a:p>
           <a:p>
-            <a:pPr algn="ctr" indent="0" marL="0">
+            <a:pPr marL="0" indent="0" algn="ctr">
               <a:buNone/>
             </a:pPr>
             <a:r>
@@ -6731,7 +7045,7 @@
           <a:bodyPr wrap="square" lIns="0" tIns="0" rIns="0" bIns="0" rtlCol="0" anchor="t"/>
           <a:lstStyle/>
           <a:p>
-            <a:pPr indent="0" marL="0">
+            <a:pPr marL="0" indent="0">
               <a:buNone/>
             </a:pPr>
             <a:r>
@@ -6767,7 +7081,7 @@
           <a:bodyPr wrap="square" lIns="0" tIns="0" rIns="0" bIns="0" rtlCol="0" anchor="t"/>
           <a:lstStyle/>
           <a:p>
-            <a:pPr indent="0" marL="0">
+            <a:pPr marL="0" indent="0">
               <a:spcAft>
                 <a:spcPts val="500"/>
               </a:spcAft>
@@ -6784,24 +7098,46 @@
               </a:rPr>
               <a:t>telemetry</a:t>
             </a:r>
-            <a:pPr indent="0" marL="0">
+            <a:r>
+              <a:rPr lang="en-US" sz="1400" dirty="0">
+                <a:solidFill>
+                  <a:schemeClr val="tx1"/>
+                </a:solidFill>
+              </a:rPr>
+              <a:t>  số đo cảm biến, 2,5 giây một lần</a:t>
+            </a:r>
+            <a:endParaRPr lang="en-US" sz="1400" dirty="0"/>
+          </a:p>
+          <a:p>
+            <a:pPr marL="0" indent="0">
               <a:spcAft>
                 <a:spcPts val="500"/>
               </a:spcAft>
               <a:buNone/>
             </a:pPr>
             <a:r>
+              <a:rPr lang="en-US" sz="1300" b="1" dirty="0">
+                <a:solidFill>
+                  <a:schemeClr val="accent1"/>
+                </a:solidFill>
+                <a:latin typeface="Courier New" pitchFamily="34" charset="0"/>
+                <a:ea typeface="Courier New" pitchFamily="34" charset="-122"/>
+                <a:cs typeface="Courier New" pitchFamily="34" charset="-120"/>
+              </a:rPr>
+              <a:t>state</a:t>
+            </a:r>
+            <a:r>
               <a:rPr lang="en-US" sz="1400" dirty="0">
                 <a:solidFill>
                   <a:schemeClr val="tx1"/>
                 </a:solidFill>
               </a:rPr>
-              <a:t>  số đo cảm biến, 2,5 giây một lần</a:t>
+              <a:t>  bơm, quạt, đèn đang bật hay tắt</a:t>
             </a:r>
             <a:endParaRPr lang="en-US" sz="1400" dirty="0"/>
           </a:p>
           <a:p>
-            <a:pPr indent="0" marL="0">
+            <a:pPr marL="0" indent="0">
               <a:spcAft>
                 <a:spcPts val="500"/>
               </a:spcAft>
@@ -6816,32 +7152,26 @@
                 <a:ea typeface="Courier New" pitchFamily="34" charset="-122"/>
                 <a:cs typeface="Courier New" pitchFamily="34" charset="-120"/>
               </a:rPr>
-              <a:t>state</a:t>
-            </a:r>
-            <a:pPr indent="0" marL="0">
+              <a:t>availability</a:t>
+            </a:r>
+            <a:r>
+              <a:rPr lang="en-US" sz="1400" dirty="0">
+                <a:solidFill>
+                  <a:schemeClr val="tx1"/>
+                </a:solidFill>
+              </a:rPr>
+              <a:t>  thiết bị online hay offline</a:t>
+            </a:r>
+            <a:endParaRPr lang="en-US" sz="1400" dirty="0"/>
+          </a:p>
+          <a:p>
+            <a:pPr marL="0" indent="0">
               <a:spcAft>
                 <a:spcPts val="500"/>
               </a:spcAft>
               <a:buNone/>
             </a:pPr>
             <a:r>
-              <a:rPr lang="en-US" sz="1400" dirty="0">
-                <a:solidFill>
-                  <a:schemeClr val="tx1"/>
-                </a:solidFill>
-              </a:rPr>
-              <a:t>  bơm, quạt, đèn đang bật hay tắt</a:t>
-            </a:r>
-            <a:endParaRPr lang="en-US" sz="1400" dirty="0"/>
-          </a:p>
-          <a:p>
-            <a:pPr indent="0" marL="0">
-              <a:spcAft>
-                <a:spcPts val="500"/>
-              </a:spcAft>
-              <a:buNone/>
-            </a:pPr>
-            <a:r>
               <a:rPr lang="en-US" sz="1300" b="1" dirty="0">
                 <a:solidFill>
                   <a:schemeClr val="accent1"/>
@@ -6850,48 +7180,8 @@
                 <a:ea typeface="Courier New" pitchFamily="34" charset="-122"/>
                 <a:cs typeface="Courier New" pitchFamily="34" charset="-120"/>
               </a:rPr>
-              <a:t>availability</a:t>
-            </a:r>
-            <a:pPr indent="0" marL="0">
-              <a:spcAft>
-                <a:spcPts val="500"/>
-              </a:spcAft>
-              <a:buNone/>
-            </a:pPr>
-            <a:r>
-              <a:rPr lang="en-US" sz="1400" dirty="0">
-                <a:solidFill>
-                  <a:schemeClr val="tx1"/>
-                </a:solidFill>
-              </a:rPr>
-              <a:t>  thiết bị online hay offline</a:t>
-            </a:r>
-            <a:endParaRPr lang="en-US" sz="1400" dirty="0"/>
-          </a:p>
-          <a:p>
-            <a:pPr indent="0" marL="0">
-              <a:spcAft>
-                <a:spcPts val="500"/>
-              </a:spcAft>
-              <a:buNone/>
-            </a:pPr>
-            <a:r>
-              <a:rPr lang="en-US" sz="1300" b="1" dirty="0">
-                <a:solidFill>
-                  <a:schemeClr val="accent1"/>
-                </a:solidFill>
-                <a:latin typeface="Courier New" pitchFamily="34" charset="0"/>
-                <a:ea typeface="Courier New" pitchFamily="34" charset="-122"/>
-                <a:cs typeface="Courier New" pitchFamily="34" charset="-120"/>
-              </a:rPr>
               <a:t>ack</a:t>
             </a:r>
-            <a:pPr indent="0" marL="0">
-              <a:spcAft>
-                <a:spcPts val="500"/>
-              </a:spcAft>
-              <a:buNone/>
-            </a:pPr>
             <a:r>
               <a:rPr lang="en-US" sz="1400" dirty="0">
                 <a:solidFill>
@@ -6952,7 +7242,7 @@
           <a:bodyPr wrap="square" lIns="0" tIns="0" rIns="0" bIns="0" rtlCol="0" anchor="t"/>
           <a:lstStyle/>
           <a:p>
-            <a:pPr indent="0" marL="0">
+            <a:pPr marL="0" indent="0">
               <a:buNone/>
             </a:pPr>
             <a:r>
@@ -6988,7 +7278,7 @@
           <a:bodyPr wrap="square" lIns="0" tIns="0" rIns="0" bIns="0" rtlCol="0" anchor="t"/>
           <a:lstStyle/>
           <a:p>
-            <a:pPr indent="0" marL="0">
+            <a:pPr marL="0" indent="0">
               <a:spcAft>
                 <a:spcPts val="500"/>
               </a:spcAft>
@@ -7005,24 +7295,46 @@
               </a:rPr>
               <a:t>cmd/mist</a:t>
             </a:r>
-            <a:pPr indent="0" marL="0">
+            <a:r>
+              <a:rPr lang="en-US" sz="1400" dirty="0">
+                <a:solidFill>
+                  <a:schemeClr val="tx1"/>
+                </a:solidFill>
+              </a:rPr>
+              <a:t>  lệnh bơm phun sương</a:t>
+            </a:r>
+            <a:endParaRPr lang="en-US" sz="1400" dirty="0"/>
+          </a:p>
+          <a:p>
+            <a:pPr marL="0" indent="0">
               <a:spcAft>
                 <a:spcPts val="500"/>
               </a:spcAft>
               <a:buNone/>
             </a:pPr>
             <a:r>
+              <a:rPr lang="en-US" sz="1300" b="1" dirty="0">
+                <a:solidFill>
+                  <a:schemeClr val="accent2"/>
+                </a:solidFill>
+                <a:latin typeface="Courier New" pitchFamily="34" charset="0"/>
+                <a:ea typeface="Courier New" pitchFamily="34" charset="-122"/>
+                <a:cs typeface="Courier New" pitchFamily="34" charset="-120"/>
+              </a:rPr>
+              <a:t>cmd/fan</a:t>
+            </a:r>
+            <a:r>
               <a:rPr lang="en-US" sz="1400" dirty="0">
                 <a:solidFill>
                   <a:schemeClr val="tx1"/>
                 </a:solidFill>
               </a:rPr>
-              <a:t>  lệnh bơm phun sương</a:t>
+              <a:t>  lệnh quạt</a:t>
             </a:r>
             <a:endParaRPr lang="en-US" sz="1400" dirty="0"/>
           </a:p>
           <a:p>
-            <a:pPr indent="0" marL="0">
+            <a:pPr marL="0" indent="0">
               <a:spcAft>
                 <a:spcPts val="500"/>
               </a:spcAft>
@@ -7037,32 +7349,26 @@
                 <a:ea typeface="Courier New" pitchFamily="34" charset="-122"/>
                 <a:cs typeface="Courier New" pitchFamily="34" charset="-120"/>
               </a:rPr>
-              <a:t>cmd/fan</a:t>
-            </a:r>
-            <a:pPr indent="0" marL="0">
+              <a:t>cmd/light</a:t>
+            </a:r>
+            <a:r>
+              <a:rPr lang="en-US" sz="1400" dirty="0">
+                <a:solidFill>
+                  <a:schemeClr val="tx1"/>
+                </a:solidFill>
+              </a:rPr>
+              <a:t>  lệnh đèn</a:t>
+            </a:r>
+            <a:endParaRPr lang="en-US" sz="1400" dirty="0"/>
+          </a:p>
+          <a:p>
+            <a:pPr marL="0" indent="0">
               <a:spcAft>
                 <a:spcPts val="500"/>
               </a:spcAft>
               <a:buNone/>
             </a:pPr>
             <a:r>
-              <a:rPr lang="en-US" sz="1400" dirty="0">
-                <a:solidFill>
-                  <a:schemeClr val="tx1"/>
-                </a:solidFill>
-              </a:rPr>
-              <a:t>  lệnh quạt</a:t>
-            </a:r>
-            <a:endParaRPr lang="en-US" sz="1400" dirty="0"/>
-          </a:p>
-          <a:p>
-            <a:pPr indent="0" marL="0">
-              <a:spcAft>
-                <a:spcPts val="500"/>
-              </a:spcAft>
-              <a:buNone/>
-            </a:pPr>
-            <a:r>
               <a:rPr lang="en-US" sz="1300" b="1" dirty="0">
                 <a:solidFill>
                   <a:schemeClr val="accent2"/>
@@ -7071,63 +7377,23 @@
                 <a:ea typeface="Courier New" pitchFamily="34" charset="-122"/>
                 <a:cs typeface="Courier New" pitchFamily="34" charset="-120"/>
               </a:rPr>
-              <a:t>cmd/light</a:t>
-            </a:r>
-            <a:pPr indent="0" marL="0">
-              <a:spcAft>
-                <a:spcPts val="500"/>
-              </a:spcAft>
-              <a:buNone/>
-            </a:pPr>
+              <a:t>config</a:t>
+            </a:r>
             <a:r>
               <a:rPr lang="en-US" sz="1400" dirty="0">
                 <a:solidFill>
                   <a:schemeClr val="tx1"/>
                 </a:solidFill>
               </a:rPr>
-              <a:t>  lệnh đèn</a:t>
+              <a:t>  đổi ngưỡng tự động</a:t>
             </a:r>
             <a:endParaRPr lang="en-US" sz="1400" dirty="0"/>
           </a:p>
-          <a:p>
-            <a:pPr indent="0" marL="0">
-              <a:spcAft>
-                <a:spcPts val="500"/>
-              </a:spcAft>
-              <a:buNone/>
-            </a:pPr>
-            <a:r>
-              <a:rPr lang="en-US" sz="1300" b="1" dirty="0">
-                <a:solidFill>
-                  <a:schemeClr val="accent2"/>
-                </a:solidFill>
-                <a:latin typeface="Courier New" pitchFamily="34" charset="0"/>
-                <a:ea typeface="Courier New" pitchFamily="34" charset="-122"/>
-                <a:cs typeface="Courier New" pitchFamily="34" charset="-120"/>
-              </a:rPr>
-              <a:t>config</a:t>
-            </a:r>
-            <a:pPr indent="0" marL="0">
-              <a:spcAft>
-                <a:spcPts val="500"/>
-              </a:spcAft>
-              <a:buNone/>
-            </a:pPr>
-            <a:r>
-              <a:rPr lang="en-US" sz="1400" dirty="0">
-                <a:solidFill>
-                  <a:schemeClr val="tx1"/>
-                </a:solidFill>
-              </a:rPr>
-              <a:t>  đổi ngưỡng tự động</a:t>
-            </a:r>
-            <a:endParaRPr lang="en-US" sz="1400" dirty="0"/>
-          </a:p>
-        </p:txBody>
-      </p:sp>
-      <p:sp>
-        <p:nvSpPr>
-          <p:cNvPr id="25" name="Slide Number Placeholder 0"/>
+        </p:txBody>
+      </p:sp>
+      <p:sp>
+        <p:nvSpPr>
+          <p:cNvPr id="26" name="Slide Number Placeholder 0"/>
           <p:cNvSpPr>
             <a:spLocks noGrp="1"/>
           </p:cNvSpPr>
@@ -7145,7 +7411,7 @@
           </a:prstGeom>
           <a:extLst>
             <a:ext uri="{C572A759-6A51-4108-AA02-DFA0A04FC94B}">
-              <ma14:wrappingTextBoxFlag xmlns:ma14="http://schemas.microsoft.com/office/mac/drawingml/2011/main" val="0"/>
+              <ma14:wrappingTextBoxFlag xmlns="" xmlns:ma14="http://schemas.microsoft.com/office/mac/drawingml/2011/main" val="0"/>
             </a:ext>
           </a:extLst>
         </p:spPr>
@@ -7163,7 +7429,7 @@
           <a:p>
             <a:pPr algn="r"/>
             <a:fld id="{F7021451-1387-4CA6-816F-3879F97B5CBC}" type="slidenum">
-              <a:rPr b="0" lang="en-US"/>
+              <a:rPr lang="en-US" b="0"/>
               <a:t>5</a:t>
             </a:fld>
             <a:endParaRPr lang="en-US"/>
@@ -7198,9 +7464,11 @@
       <p:sp>
         <p:nvSpPr>
           <p:cNvPr id="2" name="Text 0"/>
-          <p:cNvSpPr/>
+          <p:cNvSpPr>
+            <a:spLocks noGrp="1"/>
+          </p:cNvSpPr>
           <p:nvPr>
-            <p:ph idx="100" type="title" hasCustomPrompt="1"/>
+            <p:ph type="title" idx="100" hasCustomPrompt="1"/>
           </p:nvPr>
         </p:nvSpPr>
         <p:spPr>
@@ -7218,7 +7486,7 @@
           <a:bodyPr wrap="square" lIns="0" tIns="0" rIns="0" bIns="0" rtlCol="0" anchor="ctr"/>
           <a:lstStyle/>
           <a:p>
-            <a:pPr algn="l" indent="0" marL="0">
+            <a:pPr marL="0" indent="0" algn="l">
               <a:buNone/>
             </a:pPr>
             <a:r>
@@ -7239,9 +7507,11 @@
       <p:sp>
         <p:nvSpPr>
           <p:cNvPr id="3" name="Text 0"/>
-          <p:cNvSpPr/>
+          <p:cNvSpPr>
+            <a:spLocks noGrp="1"/>
+          </p:cNvSpPr>
           <p:nvPr>
-            <p:ph idx="101" type="body" hasCustomPrompt="1"/>
+            <p:ph type="body" idx="101" hasCustomPrompt="1"/>
           </p:nvPr>
         </p:nvSpPr>
         <p:spPr>
@@ -7259,7 +7529,7 @@
           <a:bodyPr wrap="square" lIns="0" tIns="0" rIns="0" bIns="0" rtlCol="0" anchor="t"/>
           <a:lstStyle/>
           <a:p>
-            <a:pPr indent="0" marL="0">
+            <a:pPr marL="0" indent="0">
               <a:buNone/>
             </a:pPr>
             <a:r>
@@ -7328,14 +7598,14 @@
       </p:sp>
       <p:pic>
         <p:nvPicPr>
-          <p:cNvPr id="6" name="p2-svc1-icon" descr="preencoded.png">    </p:cNvPr>
+          <p:cNvPr id="6" name="p2-svc1-icon" descr="preencoded.png"/>
           <p:cNvPicPr>
             <a:picLocks noChangeAspect="1"/>
           </p:cNvPicPr>
           <p:nvPr/>
         </p:nvPicPr>
         <p:blipFill>
-          <a:blip r:embed="rId1"/>
+          <a:blip r:embed="rId3"/>
           <a:stretch>
             <a:fillRect/>
           </a:stretch>
@@ -7371,7 +7641,7 @@
           <a:bodyPr wrap="square" lIns="0" tIns="0" rIns="0" bIns="0" rtlCol="0" anchor="t"/>
           <a:lstStyle/>
           <a:p>
-            <a:pPr indent="0" marL="0">
+            <a:pPr marL="0" indent="0">
               <a:buNone/>
             </a:pPr>
             <a:r>
@@ -7385,7 +7655,7 @@
             <a:endParaRPr lang="en-US" sz="1400" dirty="0"/>
           </a:p>
           <a:p>
-            <a:pPr indent="0" marL="0">
+            <a:pPr marL="0" indent="0">
               <a:buNone/>
             </a:pPr>
             <a:r>
@@ -7421,7 +7691,7 @@
           <a:bodyPr wrap="square" lIns="0" tIns="0" rIns="0" bIns="0" rtlCol="0" anchor="t"/>
           <a:lstStyle/>
           <a:p>
-            <a:pPr indent="0" marL="0">
+            <a:pPr marL="0" indent="0">
               <a:spcAft>
                 <a:spcPts val="500"/>
               </a:spcAft>
@@ -7438,24 +7708,46 @@
               </a:rPr>
               <a:t>availability</a:t>
             </a:r>
-            <a:pPr indent="0" marL="0">
+            <a:r>
+              <a:rPr lang="en-US" sz="1300" dirty="0">
+                <a:solidFill>
+                  <a:schemeClr val="tx1"/>
+                </a:solidFill>
+              </a:rPr>
+              <a:t>  ESP32 báo "online" khi vừa kết nối</a:t>
+            </a:r>
+            <a:endParaRPr lang="en-US" sz="1400" dirty="0"/>
+          </a:p>
+          <a:p>
+            <a:pPr marL="0" indent="0">
               <a:spcAft>
                 <a:spcPts val="500"/>
               </a:spcAft>
               <a:buNone/>
             </a:pPr>
             <a:r>
+              <a:rPr lang="en-US" sz="1200" b="1" dirty="0">
+                <a:solidFill>
+                  <a:schemeClr val="accent1"/>
+                </a:solidFill>
+                <a:latin typeface="Courier New" pitchFamily="34" charset="0"/>
+                <a:ea typeface="Courier New" pitchFamily="34" charset="-122"/>
+                <a:cs typeface="Courier New" pitchFamily="34" charset="-120"/>
+              </a:rPr>
+              <a:t>LWT</a:t>
+            </a:r>
+            <a:r>
               <a:rPr lang="en-US" sz="1300" dirty="0">
                 <a:solidFill>
                   <a:schemeClr val="tx1"/>
                 </a:solidFill>
               </a:rPr>
-              <a:t>  ESP32 báo "online" khi vừa kết nối</a:t>
+              <a:t>  ESP32 mất điện, mất mạng đột ngột: broker tự báo "offline" thay nó</a:t>
             </a:r>
             <a:endParaRPr lang="en-US" sz="1400" dirty="0"/>
           </a:p>
           <a:p>
-            <a:pPr indent="0" marL="0">
+            <a:pPr marL="0" indent="0">
               <a:spcAft>
                 <a:spcPts val="500"/>
               </a:spcAft>
@@ -7470,48 +7762,8 @@
                 <a:ea typeface="Courier New" pitchFamily="34" charset="-122"/>
                 <a:cs typeface="Courier New" pitchFamily="34" charset="-120"/>
               </a:rPr>
-              <a:t>LWT</a:t>
-            </a:r>
-            <a:pPr indent="0" marL="0">
-              <a:spcAft>
-                <a:spcPts val="500"/>
-              </a:spcAft>
-              <a:buNone/>
-            </a:pPr>
-            <a:r>
-              <a:rPr lang="en-US" sz="1300" dirty="0">
-                <a:solidFill>
-                  <a:schemeClr val="tx1"/>
-                </a:solidFill>
-              </a:rPr>
-              <a:t>  ESP32 mất điện, mất mạng đột ngột: broker tự báo "offline" thay nó</a:t>
-            </a:r>
-            <a:endParaRPr lang="en-US" sz="1400" dirty="0"/>
-          </a:p>
-          <a:p>
-            <a:pPr indent="0" marL="0">
-              <a:spcAft>
-                <a:spcPts val="500"/>
-              </a:spcAft>
-              <a:buNone/>
-            </a:pPr>
-            <a:r>
-              <a:rPr lang="en-US" sz="1200" b="1" dirty="0">
-                <a:solidFill>
-                  <a:schemeClr val="accent1"/>
-                </a:solidFill>
-                <a:latin typeface="Courier New" pitchFamily="34" charset="0"/>
-                <a:ea typeface="Courier New" pitchFamily="34" charset="-122"/>
-                <a:cs typeface="Courier New" pitchFamily="34" charset="-120"/>
-              </a:rPr>
               <a:t>server</a:t>
             </a:r>
-            <a:pPr indent="0" marL="0">
-              <a:spcAft>
-                <a:spcPts val="500"/>
-              </a:spcAft>
-              <a:buNone/>
-            </a:pPr>
             <a:r>
               <a:rPr lang="en-US" sz="1300" dirty="0">
                 <a:solidFill>
@@ -7578,14 +7830,14 @@
       </p:sp>
       <p:pic>
         <p:nvPicPr>
-          <p:cNvPr id="11" name="p2-svc2-icon" descr="preencoded.png">    </p:cNvPr>
+          <p:cNvPr id="11" name="p2-svc2-icon" descr="preencoded.png"/>
           <p:cNvPicPr>
             <a:picLocks noChangeAspect="1"/>
           </p:cNvPicPr>
           <p:nvPr/>
         </p:nvPicPr>
         <p:blipFill>
-          <a:blip r:embed="rId2"/>
+          <a:blip r:embed="rId4"/>
           <a:stretch>
             <a:fillRect/>
           </a:stretch>
@@ -7621,7 +7873,7 @@
           <a:bodyPr wrap="square" lIns="0" tIns="0" rIns="0" bIns="0" rtlCol="0" anchor="t"/>
           <a:lstStyle/>
           <a:p>
-            <a:pPr indent="0" marL="0">
+            <a:pPr marL="0" indent="0">
               <a:buNone/>
             </a:pPr>
             <a:r>
@@ -7635,7 +7887,7 @@
             <a:endParaRPr lang="en-US" sz="1400" dirty="0"/>
           </a:p>
           <a:p>
-            <a:pPr indent="0" marL="0">
+            <a:pPr marL="0" indent="0">
               <a:buNone/>
             </a:pPr>
             <a:r>
@@ -7671,7 +7923,7 @@
           <a:bodyPr wrap="square" lIns="0" tIns="0" rIns="0" bIns="0" rtlCol="0" anchor="t"/>
           <a:lstStyle/>
           <a:p>
-            <a:pPr indent="0" marL="0">
+            <a:pPr marL="0" indent="0">
               <a:spcAft>
                 <a:spcPts val="500"/>
               </a:spcAft>
@@ -7688,24 +7940,46 @@
               </a:rPr>
               <a:t>telemetry</a:t>
             </a:r>
-            <a:pPr indent="0" marL="0">
+            <a:r>
+              <a:rPr lang="en-US" sz="1300" dirty="0">
+                <a:solidFill>
+                  <a:schemeClr val="tx1"/>
+                </a:solidFill>
+              </a:rPr>
+              <a:t>  Cứ 2,5 giây gửi nhiệt độ, độ ẩm, ánh sáng, mực nước</a:t>
+            </a:r>
+            <a:endParaRPr lang="en-US" sz="1400" dirty="0"/>
+          </a:p>
+          <a:p>
+            <a:pPr marL="0" indent="0">
               <a:spcAft>
                 <a:spcPts val="500"/>
               </a:spcAft>
               <a:buNone/>
             </a:pPr>
             <a:r>
+              <a:rPr lang="en-US" sz="1200" b="1" dirty="0">
+                <a:solidFill>
+                  <a:schemeClr val="accent1"/>
+                </a:solidFill>
+                <a:latin typeface="Courier New" pitchFamily="34" charset="0"/>
+                <a:ea typeface="Courier New" pitchFamily="34" charset="-122"/>
+                <a:cs typeface="Courier New" pitchFamily="34" charset="-120"/>
+              </a:rPr>
+              <a:t>state</a:t>
+            </a:r>
+            <a:r>
               <a:rPr lang="en-US" sz="1300" dirty="0">
                 <a:solidFill>
                   <a:schemeClr val="tx1"/>
                 </a:solidFill>
               </a:rPr>
-              <a:t>  Cứ 2,5 giây gửi nhiệt độ, độ ẩm, ánh sáng, mực nước</a:t>
+              <a:t>  Bơm, quạt, đèn đang bật hay tắt; chế độ tự động hay bấm tay</a:t>
             </a:r>
             <a:endParaRPr lang="en-US" sz="1400" dirty="0"/>
           </a:p>
           <a:p>
-            <a:pPr indent="0" marL="0">
+            <a:pPr marL="0" indent="0">
               <a:spcAft>
                 <a:spcPts val="500"/>
               </a:spcAft>
@@ -7720,48 +7994,8 @@
                 <a:ea typeface="Courier New" pitchFamily="34" charset="-122"/>
                 <a:cs typeface="Courier New" pitchFamily="34" charset="-120"/>
               </a:rPr>
-              <a:t>state</a:t>
-            </a:r>
-            <a:pPr indent="0" marL="0">
-              <a:spcAft>
-                <a:spcPts val="500"/>
-              </a:spcAft>
-              <a:buNone/>
-            </a:pPr>
-            <a:r>
-              <a:rPr lang="en-US" sz="1300" dirty="0">
-                <a:solidFill>
-                  <a:schemeClr val="tx1"/>
-                </a:solidFill>
-              </a:rPr>
-              <a:t>  Bơm, quạt, đèn đang bật hay tắt; chế độ tự động hay bấm tay</a:t>
-            </a:r>
-            <a:endParaRPr lang="en-US" sz="1400" dirty="0"/>
-          </a:p>
-          <a:p>
-            <a:pPr indent="0" marL="0">
-              <a:spcAft>
-                <a:spcPts val="500"/>
-              </a:spcAft>
-              <a:buNone/>
-            </a:pPr>
-            <a:r>
-              <a:rPr lang="en-US" sz="1200" b="1" dirty="0">
-                <a:solidFill>
-                  <a:schemeClr val="accent1"/>
-                </a:solidFill>
-                <a:latin typeface="Courier New" pitchFamily="34" charset="0"/>
-                <a:ea typeface="Courier New" pitchFamily="34" charset="-122"/>
-                <a:cs typeface="Courier New" pitchFamily="34" charset="-120"/>
-              </a:rPr>
               <a:t>server</a:t>
             </a:r>
-            <a:pPr indent="0" marL="0">
-              <a:spcAft>
-                <a:spcPts val="500"/>
-              </a:spcAft>
-              <a:buNone/>
-            </a:pPr>
             <a:r>
               <a:rPr lang="en-US" sz="1300" dirty="0">
                 <a:solidFill>
@@ -7828,14 +8062,14 @@
       </p:sp>
       <p:pic>
         <p:nvPicPr>
-          <p:cNvPr id="16" name="p2-svc3-icon" descr="preencoded.png">    </p:cNvPr>
+          <p:cNvPr id="16" name="p2-svc3-icon" descr="preencoded.png"/>
           <p:cNvPicPr>
             <a:picLocks noChangeAspect="1"/>
           </p:cNvPicPr>
           <p:nvPr/>
         </p:nvPicPr>
         <p:blipFill>
-          <a:blip r:embed="rId3"/>
+          <a:blip r:embed="rId5"/>
           <a:stretch>
             <a:fillRect/>
           </a:stretch>
@@ -7871,7 +8105,7 @@
           <a:bodyPr wrap="square" lIns="0" tIns="0" rIns="0" bIns="0" rtlCol="0" anchor="t"/>
           <a:lstStyle/>
           <a:p>
-            <a:pPr indent="0" marL="0">
+            <a:pPr marL="0" indent="0">
               <a:buNone/>
             </a:pPr>
             <a:r>
@@ -7885,7 +8119,7 @@
             <a:endParaRPr lang="en-US" sz="1400" dirty="0"/>
           </a:p>
           <a:p>
-            <a:pPr indent="0" marL="0">
+            <a:pPr marL="0" indent="0">
               <a:buNone/>
             </a:pPr>
             <a:r>
@@ -7921,7 +8155,7 @@
           <a:bodyPr wrap="square" lIns="0" tIns="0" rIns="0" bIns="0" rtlCol="0" anchor="t"/>
           <a:lstStyle/>
           <a:p>
-            <a:pPr indent="0" marL="0">
+            <a:pPr marL="0" indent="0">
               <a:spcAft>
                 <a:spcPts val="500"/>
               </a:spcAft>
@@ -7938,24 +8172,46 @@
               </a:rPr>
               <a:t>cmd/…</a:t>
             </a:r>
-            <a:pPr indent="0" marL="0">
+            <a:r>
+              <a:rPr lang="en-US" sz="1300" dirty="0">
+                <a:solidFill>
+                  <a:schemeClr val="tx1"/>
+                </a:solidFill>
+              </a:rPr>
+              <a:t>  Lệnh gồm: mã lệnh, chế độ, bật hay tắt, thời hạn</a:t>
+            </a:r>
+            <a:endParaRPr lang="en-US" sz="1400" dirty="0"/>
+          </a:p>
+          <a:p>
+            <a:pPr marL="0" indent="0">
               <a:spcAft>
                 <a:spcPts val="500"/>
               </a:spcAft>
               <a:buNone/>
             </a:pPr>
             <a:r>
+              <a:rPr lang="en-US" sz="1200" b="1" dirty="0">
+                <a:solidFill>
+                  <a:schemeClr val="accent2"/>
+                </a:solidFill>
+                <a:latin typeface="Courier New" pitchFamily="34" charset="0"/>
+                <a:ea typeface="Courier New" pitchFamily="34" charset="-122"/>
+                <a:cs typeface="Courier New" pitchFamily="34" charset="-120"/>
+              </a:rPr>
+              <a:t>ack</a:t>
+            </a:r>
+            <a:r>
               <a:rPr lang="en-US" sz="1300" dirty="0">
                 <a:solidFill>
                   <a:schemeClr val="tx1"/>
                 </a:solidFill>
               </a:rPr>
-              <a:t>  Lệnh gồm: mã lệnh, chế độ, bật hay tắt, thời hạn</a:t>
+              <a:t>  ESP32 trả lời: đã làm (APPLIED) hoặc từ chối kèm lý do, ví dụ đang cạn nước</a:t>
             </a:r>
             <a:endParaRPr lang="en-US" sz="1400" dirty="0"/>
           </a:p>
           <a:p>
-            <a:pPr indent="0" marL="0">
+            <a:pPr marL="0" indent="0">
               <a:spcAft>
                 <a:spcPts val="500"/>
               </a:spcAft>
@@ -7970,48 +8226,8 @@
                 <a:ea typeface="Courier New" pitchFamily="34" charset="-122"/>
                 <a:cs typeface="Courier New" pitchFamily="34" charset="-120"/>
               </a:rPr>
-              <a:t>ack</a:t>
-            </a:r>
-            <a:pPr indent="0" marL="0">
-              <a:spcAft>
-                <a:spcPts val="500"/>
-              </a:spcAft>
-              <a:buNone/>
-            </a:pPr>
-            <a:r>
-              <a:rPr lang="en-US" sz="1300" dirty="0">
-                <a:solidFill>
-                  <a:schemeClr val="tx1"/>
-                </a:solidFill>
-              </a:rPr>
-              <a:t>  ESP32 trả lời: đã làm (APPLIED) hoặc từ chối kèm lý do, ví dụ đang cạn nước</a:t>
-            </a:r>
-            <a:endParaRPr lang="en-US" sz="1400" dirty="0"/>
-          </a:p>
-          <a:p>
-            <a:pPr indent="0" marL="0">
-              <a:spcAft>
-                <a:spcPts val="500"/>
-              </a:spcAft>
-              <a:buNone/>
-            </a:pPr>
-            <a:r>
-              <a:rPr lang="en-US" sz="1200" b="1" dirty="0">
-                <a:solidFill>
-                  <a:schemeClr val="accent2"/>
-                </a:solidFill>
-                <a:latin typeface="Courier New" pitchFamily="34" charset="0"/>
-                <a:ea typeface="Courier New" pitchFamily="34" charset="-122"/>
-                <a:cs typeface="Courier New" pitchFamily="34" charset="-120"/>
-              </a:rPr>
               <a:t>server</a:t>
             </a:r>
-            <a:pPr indent="0" marL="0">
-              <a:spcAft>
-                <a:spcPts val="500"/>
-              </a:spcAft>
-              <a:buNone/>
-            </a:pPr>
             <a:r>
               <a:rPr lang="en-US" sz="1300" dirty="0">
                 <a:solidFill>
@@ -8078,14 +8294,14 @@
       </p:sp>
       <p:pic>
         <p:nvPicPr>
-          <p:cNvPr id="21" name="p2-svc4-icon" descr="preencoded.png">    </p:cNvPr>
+          <p:cNvPr id="21" name="p2-svc4-icon" descr="preencoded.png"/>
           <p:cNvPicPr>
             <a:picLocks noChangeAspect="1"/>
           </p:cNvPicPr>
           <p:nvPr/>
         </p:nvPicPr>
         <p:blipFill>
-          <a:blip r:embed="rId4"/>
+          <a:blip r:embed="rId6"/>
           <a:stretch>
             <a:fillRect/>
           </a:stretch>
@@ -8121,7 +8337,7 @@
           <a:bodyPr wrap="square" lIns="0" tIns="0" rIns="0" bIns="0" rtlCol="0" anchor="t"/>
           <a:lstStyle/>
           <a:p>
-            <a:pPr indent="0" marL="0">
+            <a:pPr marL="0" indent="0">
               <a:buNone/>
             </a:pPr>
             <a:r>
@@ -8135,7 +8351,7 @@
             <a:endParaRPr lang="en-US" sz="1400" dirty="0"/>
           </a:p>
           <a:p>
-            <a:pPr indent="0" marL="0">
+            <a:pPr marL="0" indent="0">
               <a:buNone/>
             </a:pPr>
             <a:r>
@@ -8171,7 +8387,7 @@
           <a:bodyPr wrap="square" lIns="0" tIns="0" rIns="0" bIns="0" rtlCol="0" anchor="t"/>
           <a:lstStyle/>
           <a:p>
-            <a:pPr indent="0" marL="0">
+            <a:pPr marL="0" indent="0">
               <a:spcAft>
                 <a:spcPts val="500"/>
               </a:spcAft>
@@ -8188,30 +8404,24 @@
               </a:rPr>
               <a:t>config</a:t>
             </a:r>
-            <a:pPr indent="0" marL="0">
+            <a:r>
+              <a:rPr lang="en-US" sz="1300" dirty="0">
+                <a:solidFill>
+                  <a:schemeClr val="tx1"/>
+                </a:solidFill>
+              </a:rPr>
+              <a:t>  Server gửi ngưỡng mới, ESP32 trả lời đã áp dụng</a:t>
+            </a:r>
+            <a:endParaRPr lang="en-US" sz="1400" dirty="0"/>
+          </a:p>
+          <a:p>
+            <a:pPr marL="0" indent="0">
               <a:spcAft>
                 <a:spcPts val="500"/>
               </a:spcAft>
               <a:buNone/>
             </a:pPr>
             <a:r>
-              <a:rPr lang="en-US" sz="1300" dirty="0">
-                <a:solidFill>
-                  <a:schemeClr val="tx1"/>
-                </a:solidFill>
-              </a:rPr>
-              <a:t>  Server gửi ngưỡng mới, ESP32 trả lời đã áp dụng</a:t>
-            </a:r>
-            <a:endParaRPr lang="en-US" sz="1400" dirty="0"/>
-          </a:p>
-          <a:p>
-            <a:pPr indent="0" marL="0">
-              <a:spcAft>
-                <a:spcPts val="500"/>
-              </a:spcAft>
-              <a:buNone/>
-            </a:pPr>
-            <a:r>
               <a:rPr lang="en-US" sz="1200" b="1" dirty="0">
                 <a:solidFill>
                   <a:schemeClr val="accent3"/>
@@ -8222,12 +8432,6 @@
               </a:rPr>
               <a:t>giới hạn</a:t>
             </a:r>
-            <a:pPr indent="0" marL="0">
-              <a:spcAft>
-                <a:spcPts val="500"/>
-              </a:spcAft>
-              <a:buNone/>
-            </a:pPr>
             <a:r>
               <a:rPr lang="en-US" sz="1300" dirty="0">
                 <a:solidFill>
@@ -8260,7 +8464,7 @@
           </a:prstGeom>
           <a:extLst>
             <a:ext uri="{C572A759-6A51-4108-AA02-DFA0A04FC94B}">
-              <ma14:wrappingTextBoxFlag xmlns:ma14="http://schemas.microsoft.com/office/mac/drawingml/2011/main" val="0"/>
+              <ma14:wrappingTextBoxFlag xmlns="" xmlns:ma14="http://schemas.microsoft.com/office/mac/drawingml/2011/main" val="0"/>
             </a:ext>
           </a:extLst>
         </p:spPr>
@@ -8278,7 +8482,7 @@
           <a:p>
             <a:pPr algn="r"/>
             <a:fld id="{F7021451-1387-4CA6-816F-3879F97B5CBC}" type="slidenum">
-              <a:rPr b="0" lang="en-US"/>
+              <a:rPr lang="en-US" b="0"/>
               <a:t>6</a:t>
             </a:fld>
             <a:endParaRPr lang="en-US"/>
@@ -8313,9 +8517,11 @@
       <p:sp>
         <p:nvSpPr>
           <p:cNvPr id="2" name="Text 0"/>
-          <p:cNvSpPr/>
+          <p:cNvSpPr>
+            <a:spLocks noGrp="1"/>
+          </p:cNvSpPr>
           <p:nvPr>
-            <p:ph idx="100" type="title" hasCustomPrompt="1"/>
+            <p:ph type="title" idx="100" hasCustomPrompt="1"/>
           </p:nvPr>
         </p:nvSpPr>
         <p:spPr>
@@ -8333,7 +8539,7 @@
           <a:bodyPr wrap="square" lIns="0" tIns="0" rIns="0" bIns="0" rtlCol="0" anchor="ctr"/>
           <a:lstStyle/>
           <a:p>
-            <a:pPr algn="l" indent="0" marL="0">
+            <a:pPr marL="0" indent="0" algn="l">
               <a:buNone/>
             </a:pPr>
             <a:r>
@@ -8354,9 +8560,11 @@
       <p:sp>
         <p:nvSpPr>
           <p:cNvPr id="3" name="Text 0"/>
-          <p:cNvSpPr/>
+          <p:cNvSpPr>
+            <a:spLocks noGrp="1"/>
+          </p:cNvSpPr>
           <p:nvPr>
-            <p:ph idx="101" type="body" hasCustomPrompt="1"/>
+            <p:ph type="body" idx="101" hasCustomPrompt="1"/>
           </p:nvPr>
         </p:nvSpPr>
         <p:spPr>
@@ -8374,7 +8582,7 @@
           <a:bodyPr wrap="square" lIns="0" tIns="0" rIns="0" bIns="0" rtlCol="0" anchor="t"/>
           <a:lstStyle/>
           <a:p>
-            <a:pPr indent="0" marL="0">
+            <a:pPr marL="0" indent="0">
               <a:buNone/>
             </a:pPr>
             <a:r>
@@ -8416,14 +8624,14 @@
       </p:sp>
       <p:pic>
         <p:nvPicPr>
-          <p:cNvPr id="5" name="p3a-rep-icon" descr="preencoded.png">    </p:cNvPr>
+          <p:cNvPr id="5" name="p3a-rep-icon" descr="preencoded.png"/>
           <p:cNvPicPr>
             <a:picLocks noChangeAspect="1"/>
           </p:cNvPicPr>
           <p:nvPr/>
         </p:nvPicPr>
         <p:blipFill>
-          <a:blip r:embed="rId1"/>
+          <a:blip r:embed="rId3"/>
           <a:stretch>
             <a:fillRect/>
           </a:stretch>
@@ -8459,7 +8667,7 @@
           <a:bodyPr wrap="square" lIns="0" tIns="0" rIns="0" bIns="0" rtlCol="0" anchor="t"/>
           <a:lstStyle/>
           <a:p>
-            <a:pPr indent="0" marL="0">
+            <a:pPr marL="0" indent="0">
               <a:buNone/>
             </a:pPr>
             <a:r>
@@ -8592,7 +8800,7 @@
           <a:bodyPr wrap="square" lIns="0" tIns="0" rIns="0" bIns="0" rtlCol="0" anchor="t"/>
           <a:lstStyle/>
           <a:p>
-            <a:pPr indent="0" marL="0">
+            <a:pPr marL="0" indent="0">
               <a:buNone/>
             </a:pPr>
             <a:r>
@@ -8655,7 +8863,7 @@
           <a:bodyPr wrap="square" lIns="0" tIns="0" rIns="0" bIns="0" rtlCol="0" anchor="ctr"/>
           <a:lstStyle/>
           <a:p>
-            <a:pPr algn="ctr" indent="0" marL="0">
+            <a:pPr marL="0" indent="0" algn="ctr">
               <a:buNone/>
             </a:pPr>
             <a:r>
@@ -8691,7 +8899,7 @@
           <a:bodyPr wrap="square" lIns="0" tIns="0" rIns="0" bIns="0" rtlCol="0" anchor="t"/>
           <a:lstStyle/>
           <a:p>
-            <a:pPr algn="ctr" indent="0" marL="0">
+            <a:pPr marL="0" indent="0" algn="ctr">
               <a:buNone/>
             </a:pPr>
             <a:r>
@@ -8754,7 +8962,7 @@
           <a:bodyPr wrap="square" lIns="0" tIns="0" rIns="0" bIns="0" rtlCol="0" anchor="ctr"/>
           <a:lstStyle/>
           <a:p>
-            <a:pPr algn="ctr" indent="0" marL="0">
+            <a:pPr marL="0" indent="0" algn="ctr">
               <a:buNone/>
             </a:pPr>
             <a:r>
@@ -8790,7 +8998,7 @@
           <a:bodyPr wrap="square" lIns="0" tIns="0" rIns="0" bIns="0" rtlCol="0" anchor="t"/>
           <a:lstStyle/>
           <a:p>
-            <a:pPr algn="ctr" indent="0" marL="0">
+            <a:pPr marL="0" indent="0" algn="ctr">
               <a:buNone/>
             </a:pPr>
             <a:r>
@@ -8853,7 +9061,7 @@
           <a:bodyPr wrap="square" lIns="0" tIns="0" rIns="0" bIns="0" rtlCol="0" anchor="ctr"/>
           <a:lstStyle/>
           <a:p>
-            <a:pPr algn="ctr" indent="0" marL="0">
+            <a:pPr marL="0" indent="0" algn="ctr">
               <a:buNone/>
             </a:pPr>
             <a:r>
@@ -8889,7 +9097,7 @@
           <a:bodyPr wrap="square" lIns="0" tIns="0" rIns="0" bIns="0" rtlCol="0" anchor="t"/>
           <a:lstStyle/>
           <a:p>
-            <a:pPr algn="ctr" indent="0" marL="0">
+            <a:pPr marL="0" indent="0" algn="ctr">
               <a:buNone/>
             </a:pPr>
             <a:r>
@@ -8958,14 +9166,14 @@
       </p:sp>
       <p:pic>
         <p:nvPicPr>
-          <p:cNvPr id="20" name="p3a-mgmt-icon" descr="preencoded.png">    </p:cNvPr>
+          <p:cNvPr id="20" name="p3a-mgmt-icon" descr="preencoded.png"/>
           <p:cNvPicPr>
             <a:picLocks noChangeAspect="1"/>
           </p:cNvPicPr>
           <p:nvPr/>
         </p:nvPicPr>
         <p:blipFill>
-          <a:blip r:embed="rId2"/>
+          <a:blip r:embed="rId4"/>
           <a:stretch>
             <a:fillRect/>
           </a:stretch>
@@ -9001,7 +9209,7 @@
           <a:bodyPr wrap="square" lIns="0" tIns="0" rIns="0" bIns="0" rtlCol="0" anchor="t"/>
           <a:lstStyle/>
           <a:p>
-            <a:pPr indent="0" marL="0">
+            <a:pPr marL="0" indent="0">
               <a:buNone/>
             </a:pPr>
             <a:r>
@@ -9040,7 +9248,7 @@
           <a:bodyPr wrap="square" lIns="0" tIns="0" rIns="0" bIns="0" rtlCol="0" anchor="t"/>
           <a:lstStyle/>
           <a:p>
-            <a:pPr indent="0" marL="0">
+            <a:pPr marL="0" indent="0">
               <a:buNone/>
             </a:pPr>
             <a:r>
@@ -9103,7 +9311,7 @@
           <a:bodyPr wrap="square" lIns="0" tIns="0" rIns="0" bIns="0" rtlCol="0" anchor="ctr"/>
           <a:lstStyle/>
           <a:p>
-            <a:pPr indent="0" marL="0">
+            <a:pPr marL="0" indent="0">
               <a:buNone/>
             </a:pPr>
             <a:r>
@@ -9199,7 +9407,7 @@
       </p:sp>
       <p:sp>
         <p:nvSpPr>
-          <p:cNvPr id="25" name="Slide Number Placeholder 0"/>
+          <p:cNvPr id="26" name="Slide Number Placeholder 0"/>
           <p:cNvSpPr>
             <a:spLocks noGrp="1"/>
           </p:cNvSpPr>
@@ -9217,7 +9425,7 @@
           </a:prstGeom>
           <a:extLst>
             <a:ext uri="{C572A759-6A51-4108-AA02-DFA0A04FC94B}">
-              <ma14:wrappingTextBoxFlag xmlns:ma14="http://schemas.microsoft.com/office/mac/drawingml/2011/main" val="0"/>
+              <ma14:wrappingTextBoxFlag xmlns="" xmlns:ma14="http://schemas.microsoft.com/office/mac/drawingml/2011/main" val="0"/>
             </a:ext>
           </a:extLst>
         </p:spPr>
@@ -9235,7 +9443,7 @@
           <a:p>
             <a:pPr algn="r"/>
             <a:fld id="{F7021451-1387-4CA6-816F-3879F97B5CBC}" type="slidenum">
-              <a:rPr b="0" lang="en-US"/>
+              <a:rPr lang="en-US" b="0"/>
               <a:t>7</a:t>
             </a:fld>
             <a:endParaRPr lang="en-US"/>
@@ -9270,9 +9478,11 @@
       <p:sp>
         <p:nvSpPr>
           <p:cNvPr id="2" name="Text 0"/>
-          <p:cNvSpPr/>
+          <p:cNvSpPr>
+            <a:spLocks noGrp="1"/>
+          </p:cNvSpPr>
           <p:nvPr>
-            <p:ph idx="100" type="title" hasCustomPrompt="1"/>
+            <p:ph type="title" idx="100" hasCustomPrompt="1"/>
           </p:nvPr>
         </p:nvSpPr>
         <p:spPr>
@@ -9290,7 +9500,7 @@
           <a:bodyPr wrap="square" lIns="0" tIns="0" rIns="0" bIns="0" rtlCol="0" anchor="ctr"/>
           <a:lstStyle/>
           <a:p>
-            <a:pPr algn="l" indent="0" marL="0">
+            <a:pPr marL="0" indent="0" algn="l">
               <a:buNone/>
             </a:pPr>
             <a:r>
@@ -9311,9 +9521,11 @@
       <p:sp>
         <p:nvSpPr>
           <p:cNvPr id="3" name="Text 0"/>
-          <p:cNvSpPr/>
+          <p:cNvSpPr>
+            <a:spLocks noGrp="1"/>
+          </p:cNvSpPr>
           <p:nvPr>
-            <p:ph idx="101" type="body" hasCustomPrompt="1"/>
+            <p:ph type="body" idx="101" hasCustomPrompt="1"/>
           </p:nvPr>
         </p:nvSpPr>
         <p:spPr>
@@ -9331,7 +9543,7 @@
           <a:bodyPr wrap="square" lIns="0" tIns="0" rIns="0" bIns="0" rtlCol="0" anchor="t"/>
           <a:lstStyle/>
           <a:p>
-            <a:pPr indent="0" marL="0">
+            <a:pPr marL="0" indent="0">
               <a:buNone/>
             </a:pPr>
             <a:r>
@@ -9373,14 +9585,14 @@
       </p:sp>
       <p:pic>
         <p:nvPicPr>
-          <p:cNvPr id="5" name="p3b-ctrl-icon" descr="preencoded.png">    </p:cNvPr>
+          <p:cNvPr id="5" name="p3b-ctrl-icon" descr="preencoded.png"/>
           <p:cNvPicPr>
             <a:picLocks noChangeAspect="1"/>
           </p:cNvPicPr>
           <p:nvPr/>
         </p:nvPicPr>
         <p:blipFill>
-          <a:blip r:embed="rId1"/>
+          <a:blip r:embed="rId3"/>
           <a:stretch>
             <a:fillRect/>
           </a:stretch>
@@ -9416,7 +9628,7 @@
           <a:bodyPr wrap="square" lIns="0" tIns="0" rIns="0" bIns="0" rtlCol="0" anchor="t"/>
           <a:lstStyle/>
           <a:p>
-            <a:pPr indent="0" marL="0">
+            <a:pPr marL="0" indent="0">
               <a:buNone/>
             </a:pPr>
             <a:r>
@@ -9549,7 +9761,7 @@
           <a:bodyPr wrap="square" lIns="0" tIns="0" rIns="0" bIns="0" rtlCol="0" anchor="t"/>
           <a:lstStyle/>
           <a:p>
-            <a:pPr indent="0" marL="0">
+            <a:pPr marL="0" indent="0">
               <a:buNone/>
             </a:pPr>
             <a:r>
@@ -9612,7 +9824,7 @@
           <a:bodyPr wrap="square" lIns="0" tIns="0" rIns="0" bIns="0" rtlCol="0" anchor="t"/>
           <a:lstStyle/>
           <a:p>
-            <a:pPr indent="0" marL="0">
+            <a:pPr marL="0" indent="0">
               <a:buNone/>
             </a:pPr>
             <a:r>
@@ -9626,7 +9838,7 @@
             <a:endParaRPr lang="en-US" sz="1400" dirty="0"/>
           </a:p>
           <a:p>
-            <a:pPr indent="0" marL="0">
+            <a:pPr marL="0" indent="0">
               <a:buNone/>
             </a:pPr>
             <a:r>
@@ -9689,7 +9901,7 @@
           <a:bodyPr wrap="square" lIns="0" tIns="0" rIns="0" bIns="0" rtlCol="0" anchor="t"/>
           <a:lstStyle/>
           <a:p>
-            <a:pPr indent="0" marL="0">
+            <a:pPr marL="0" indent="0">
               <a:buNone/>
             </a:pPr>
             <a:r>
@@ -9703,7 +9915,7 @@
             <a:endParaRPr lang="en-US" sz="1400" dirty="0"/>
           </a:p>
           <a:p>
-            <a:pPr indent="0" marL="0">
+            <a:pPr marL="0" indent="0">
               <a:buNone/>
             </a:pPr>
             <a:r>
@@ -9766,7 +9978,7 @@
           <a:bodyPr wrap="square" lIns="0" tIns="0" rIns="0" bIns="0" rtlCol="0" anchor="t"/>
           <a:lstStyle/>
           <a:p>
-            <a:pPr indent="0" marL="0">
+            <a:pPr marL="0" indent="0">
               <a:buNone/>
             </a:pPr>
             <a:r>
@@ -9780,7 +9992,7 @@
             <a:endParaRPr lang="en-US" sz="1400" dirty="0"/>
           </a:p>
           <a:p>
-            <a:pPr indent="0" marL="0">
+            <a:pPr marL="0" indent="0">
               <a:buNone/>
             </a:pPr>
             <a:r>
@@ -9822,14 +10034,14 @@
       </p:sp>
       <p:pic>
         <p:nvPicPr>
-          <p:cNvPr id="16" name="p3b-rule-icon" descr="preencoded.png">    </p:cNvPr>
+          <p:cNvPr id="16" name="p3b-rule-icon" descr="preencoded.png"/>
           <p:cNvPicPr>
             <a:picLocks noChangeAspect="1"/>
           </p:cNvPicPr>
           <p:nvPr/>
         </p:nvPicPr>
         <p:blipFill>
-          <a:blip r:embed="rId2"/>
+          <a:blip r:embed="rId4"/>
           <a:stretch>
             <a:fillRect/>
           </a:stretch>
@@ -9865,7 +10077,7 @@
           <a:bodyPr wrap="square" lIns="0" tIns="0" rIns="0" bIns="0" rtlCol="0" anchor="t"/>
           <a:lstStyle/>
           <a:p>
-            <a:pPr indent="0" marL="0">
+            <a:pPr marL="0" indent="0">
               <a:buNone/>
             </a:pPr>
             <a:r>
@@ -9937,14 +10149,14 @@
       </p:sp>
       <p:pic>
         <p:nvPicPr>
-          <p:cNvPr id="20" name="p3b-rule1-icon" descr="preencoded.png">    </p:cNvPr>
+          <p:cNvPr id="20" name="p3b-rule1-icon" descr="preencoded.png"/>
           <p:cNvPicPr>
             <a:picLocks noChangeAspect="1"/>
           </p:cNvPicPr>
           <p:nvPr/>
         </p:nvPicPr>
         <p:blipFill>
-          <a:blip r:embed="rId3"/>
+          <a:blip r:embed="rId5"/>
           <a:stretch>
             <a:fillRect/>
           </a:stretch>
@@ -9980,7 +10192,7 @@
           <a:bodyPr wrap="square" lIns="0" tIns="0" rIns="0" bIns="0" rtlCol="0" anchor="t"/>
           <a:lstStyle/>
           <a:p>
-            <a:pPr indent="0" marL="0">
+            <a:pPr marL="0" indent="0">
               <a:buNone/>
             </a:pPr>
             <a:r>
@@ -9994,7 +10206,7 @@
             <a:endParaRPr lang="en-US" sz="1400" dirty="0"/>
           </a:p>
           <a:p>
-            <a:pPr indent="0" marL="0">
+            <a:pPr marL="0" indent="0">
               <a:buNone/>
             </a:pPr>
             <a:r>
@@ -10063,14 +10275,14 @@
       </p:sp>
       <p:pic>
         <p:nvPicPr>
-          <p:cNvPr id="24" name="p3b-rule2-icon" descr="preencoded.png">    </p:cNvPr>
+          <p:cNvPr id="24" name="p3b-rule2-icon" descr="preencoded.png"/>
           <p:cNvPicPr>
             <a:picLocks noChangeAspect="1"/>
           </p:cNvPicPr>
           <p:nvPr/>
         </p:nvPicPr>
         <p:blipFill>
-          <a:blip r:embed="rId4"/>
+          <a:blip r:embed="rId6"/>
           <a:stretch>
             <a:fillRect/>
           </a:stretch>
@@ -10106,7 +10318,7 @@
           <a:bodyPr wrap="square" lIns="0" tIns="0" rIns="0" bIns="0" rtlCol="0" anchor="t"/>
           <a:lstStyle/>
           <a:p>
-            <a:pPr indent="0" marL="0">
+            <a:pPr marL="0" indent="0">
               <a:buNone/>
             </a:pPr>
             <a:r>
@@ -10120,7 +10332,7 @@
             <a:endParaRPr lang="en-US" sz="1400" dirty="0"/>
           </a:p>
           <a:p>
-            <a:pPr indent="0" marL="0">
+            <a:pPr marL="0" indent="0">
               <a:buNone/>
             </a:pPr>
             <a:r>
@@ -10189,14 +10401,14 @@
       </p:sp>
       <p:pic>
         <p:nvPicPr>
-          <p:cNvPr id="28" name="p3b-rule3-icon" descr="preencoded.png">    </p:cNvPr>
+          <p:cNvPr id="28" name="p3b-rule3-icon" descr="preencoded.png"/>
           <p:cNvPicPr>
             <a:picLocks noChangeAspect="1"/>
           </p:cNvPicPr>
           <p:nvPr/>
         </p:nvPicPr>
         <p:blipFill>
-          <a:blip r:embed="rId5"/>
+          <a:blip r:embed="rId7"/>
           <a:stretch>
             <a:fillRect/>
           </a:stretch>
@@ -10232,7 +10444,7 @@
           <a:bodyPr wrap="square" lIns="0" tIns="0" rIns="0" bIns="0" rtlCol="0" anchor="t"/>
           <a:lstStyle/>
           <a:p>
-            <a:pPr indent="0" marL="0">
+            <a:pPr marL="0" indent="0">
               <a:buNone/>
             </a:pPr>
             <a:r>
@@ -10246,7 +10458,7 @@
             <a:endParaRPr lang="en-US" sz="1400" dirty="0"/>
           </a:p>
           <a:p>
-            <a:pPr indent="0" marL="0">
+            <a:pPr marL="0" indent="0">
               <a:buNone/>
             </a:pPr>
             <a:r>
@@ -10263,7 +10475,7 @@
       </p:sp>
       <p:sp>
         <p:nvSpPr>
-          <p:cNvPr id="25" name="Slide Number Placeholder 0"/>
+          <p:cNvPr id="30" name="Slide Number Placeholder 0"/>
           <p:cNvSpPr>
             <a:spLocks noGrp="1"/>
           </p:cNvSpPr>
@@ -10281,7 +10493,7 @@
           </a:prstGeom>
           <a:extLst>
             <a:ext uri="{C572A759-6A51-4108-AA02-DFA0A04FC94B}">
-              <ma14:wrappingTextBoxFlag xmlns:ma14="http://schemas.microsoft.com/office/mac/drawingml/2011/main" val="0"/>
+              <ma14:wrappingTextBoxFlag xmlns="" xmlns:ma14="http://schemas.microsoft.com/office/mac/drawingml/2011/main" val="0"/>
             </a:ext>
           </a:extLst>
         </p:spPr>
@@ -10299,7 +10511,7 @@
           <a:p>
             <a:pPr algn="r"/>
             <a:fld id="{F7021451-1387-4CA6-816F-3879F97B5CBC}" type="slidenum">
-              <a:rPr b="0" lang="en-US"/>
+              <a:rPr lang="en-US" b="0"/>
               <a:t>8</a:t>
             </a:fld>
             <a:endParaRPr lang="en-US"/>
@@ -10334,9 +10546,11 @@
       <p:sp>
         <p:nvSpPr>
           <p:cNvPr id="2" name="Text 0"/>
-          <p:cNvSpPr/>
+          <p:cNvSpPr>
+            <a:spLocks noGrp="1"/>
+          </p:cNvSpPr>
           <p:nvPr>
-            <p:ph idx="100" type="title" hasCustomPrompt="1"/>
+            <p:ph type="title" idx="100" hasCustomPrompt="1"/>
           </p:nvPr>
         </p:nvSpPr>
         <p:spPr>
@@ -10354,7 +10568,7 @@
           <a:bodyPr wrap="square" lIns="0" tIns="0" rIns="0" bIns="0" rtlCol="0" anchor="ctr"/>
           <a:lstStyle/>
           <a:p>
-            <a:pPr algn="l" indent="0" marL="0">
+            <a:pPr marL="0" indent="0" algn="l">
               <a:buNone/>
             </a:pPr>
             <a:r>
@@ -10375,9 +10589,11 @@
       <p:sp>
         <p:nvSpPr>
           <p:cNvPr id="3" name="Text 0"/>
-          <p:cNvSpPr/>
+          <p:cNvSpPr>
+            <a:spLocks noGrp="1"/>
+          </p:cNvSpPr>
           <p:nvPr>
-            <p:ph idx="101" type="body" hasCustomPrompt="1"/>
+            <p:ph type="body" idx="101" hasCustomPrompt="1"/>
           </p:nvPr>
         </p:nvSpPr>
         <p:spPr>
@@ -10395,7 +10611,7 @@
           <a:bodyPr wrap="square" lIns="0" tIns="0" rIns="0" bIns="0" rtlCol="0" anchor="t"/>
           <a:lstStyle/>
           <a:p>
-            <a:pPr indent="0" marL="0">
+            <a:pPr marL="0" indent="0">
               <a:buNone/>
             </a:pPr>
             <a:r>
@@ -10412,14 +10628,14 @@
       </p:sp>
       <p:sp>
         <p:nvSpPr>
-          <p:cNvPr id="4" name="close-stat1"/>
+          <p:cNvPr id="12" name="close-next-title"/>
           <p:cNvSpPr txBox="1"/>
           <p:nvPr/>
         </p:nvSpPr>
         <p:spPr>
           <a:xfrm>
-            <a:off x="731520" y="2011680"/>
-            <a:ext cx="2560320" cy="822960"/>
+            <a:off x="731520" y="1965960"/>
+            <a:ext cx="5486400" cy="411480"/>
           </a:xfrm>
           <a:prstGeom prst="rect">
             <a:avLst/>
@@ -10431,318 +10647,18 @@
           <a:bodyPr wrap="square" lIns="0" tIns="0" rIns="0" bIns="0" rtlCol="0" anchor="t"/>
           <a:lstStyle/>
           <a:p>
-            <a:pPr indent="0" marL="0">
-              <a:buNone/>
-            </a:pPr>
-            <a:r>
-              <a:rPr lang="en-US" sz="4000" b="1" dirty="0">
-                <a:solidFill>
-                  <a:srgbClr val="F2B8D6"/>
+            <a:pPr marL="0" indent="0">
+              <a:buNone/>
+            </a:pPr>
+            <a:r>
+              <a:rPr lang="en-US" sz="2000" b="1" dirty="0">
+                <a:solidFill>
+                  <a:schemeClr val="bg1"/>
                 </a:solidFill>
                 <a:latin typeface="Cambria" pitchFamily="34" charset="0"/>
                 <a:ea typeface="Cambria" pitchFamily="34" charset="-122"/>
                 <a:cs typeface="Cambria" pitchFamily="34" charset="-120"/>
               </a:rPr>
-              <a:t>199/199</a:t>
-            </a:r>
-            <a:endParaRPr lang="en-US" sz="4000" dirty="0"/>
-          </a:p>
-        </p:txBody>
-      </p:sp>
-      <p:sp>
-        <p:nvSpPr>
-          <p:cNvPr id="5" name="close-stat1-label"/>
-          <p:cNvSpPr txBox="1"/>
-          <p:nvPr/>
-        </p:nvSpPr>
-        <p:spPr>
-          <a:xfrm>
-            <a:off x="731520" y="2880360"/>
-            <a:ext cx="2377440" cy="822960"/>
-          </a:xfrm>
-          <a:prstGeom prst="rect">
-            <a:avLst/>
-          </a:prstGeom>
-          <a:noFill/>
-          <a:ln/>
-        </p:spPr>
-        <p:txBody>
-          <a:bodyPr wrap="square" lIns="0" tIns="0" rIns="0" bIns="0" rtlCol="0" anchor="t"/>
-          <a:lstStyle/>
-          <a:p>
-            <a:pPr indent="0" marL="0">
-              <a:buNone/>
-            </a:pPr>
-            <a:r>
-              <a:rPr lang="en-US" sz="1400" dirty="0">
-                <a:solidFill>
-                  <a:srgbClr val="CFE3D6"/>
-                </a:solidFill>
-              </a:rPr>
-              <a:t>lần đo gửi lên server khớp đúng số trên thiết bị (chạy liên tục 12 phút)</a:t>
-            </a:r>
-            <a:endParaRPr lang="en-US" sz="1400" dirty="0"/>
-          </a:p>
-        </p:txBody>
-      </p:sp>
-      <p:sp>
-        <p:nvSpPr>
-          <p:cNvPr id="6" name="close-stat2"/>
-          <p:cNvSpPr txBox="1"/>
-          <p:nvPr/>
-        </p:nvSpPr>
-        <p:spPr>
-          <a:xfrm>
-            <a:off x="3474720" y="2011680"/>
-            <a:ext cx="2560320" cy="822960"/>
-          </a:xfrm>
-          <a:prstGeom prst="rect">
-            <a:avLst/>
-          </a:prstGeom>
-          <a:noFill/>
-          <a:ln/>
-        </p:spPr>
-        <p:txBody>
-          <a:bodyPr wrap="square" lIns="0" tIns="0" rIns="0" bIns="0" rtlCol="0" anchor="t"/>
-          <a:lstStyle/>
-          <a:p>
-            <a:pPr indent="0" marL="0">
-              <a:buNone/>
-            </a:pPr>
-            <a:r>
-              <a:rPr lang="en-US" sz="4000" b="1" dirty="0">
-                <a:solidFill>
-                  <a:srgbClr val="F2B8D6"/>
-                </a:solidFill>
-                <a:latin typeface="Cambria" pitchFamily="34" charset="0"/>
-                <a:ea typeface="Cambria" pitchFamily="34" charset="-122"/>
-                <a:cs typeface="Cambria" pitchFamily="34" charset="-120"/>
-              </a:rPr>
-              <a:t>10/10</a:t>
-            </a:r>
-            <a:endParaRPr lang="en-US" sz="4000" dirty="0"/>
-          </a:p>
-        </p:txBody>
-      </p:sp>
-      <p:sp>
-        <p:nvSpPr>
-          <p:cNvPr id="7" name="close-stat2-label"/>
-          <p:cNvSpPr txBox="1"/>
-          <p:nvPr/>
-        </p:nvSpPr>
-        <p:spPr>
-          <a:xfrm>
-            <a:off x="3474720" y="2880360"/>
-            <a:ext cx="2377440" cy="822960"/>
-          </a:xfrm>
-          <a:prstGeom prst="rect">
-            <a:avLst/>
-          </a:prstGeom>
-          <a:noFill/>
-          <a:ln/>
-        </p:spPr>
-        <p:txBody>
-          <a:bodyPr wrap="square" lIns="0" tIns="0" rIns="0" bIns="0" rtlCol="0" anchor="t"/>
-          <a:lstStyle/>
-          <a:p>
-            <a:pPr indent="0" marL="0">
-              <a:buNone/>
-            </a:pPr>
-            <a:r>
-              <a:rPr lang="en-US" sz="1400" dirty="0">
-                <a:solidFill>
-                  <a:srgbClr val="CFE3D6"/>
-                </a:solidFill>
-              </a:rPr>
-              <a:t>tình huống điều khiển chạy đúng, kể cả lúc cạn nước và mất mạng</a:t>
-            </a:r>
-            <a:endParaRPr lang="en-US" sz="1400" dirty="0"/>
-          </a:p>
-        </p:txBody>
-      </p:sp>
-      <p:sp>
-        <p:nvSpPr>
-          <p:cNvPr id="8" name="close-stat3"/>
-          <p:cNvSpPr txBox="1"/>
-          <p:nvPr/>
-        </p:nvSpPr>
-        <p:spPr>
-          <a:xfrm>
-            <a:off x="6217920" y="2011680"/>
-            <a:ext cx="2560320" cy="822960"/>
-          </a:xfrm>
-          <a:prstGeom prst="rect">
-            <a:avLst/>
-          </a:prstGeom>
-          <a:noFill/>
-          <a:ln/>
-        </p:spPr>
-        <p:txBody>
-          <a:bodyPr wrap="square" lIns="0" tIns="0" rIns="0" bIns="0" rtlCol="0" anchor="t"/>
-          <a:lstStyle/>
-          <a:p>
-            <a:pPr indent="0" marL="0">
-              <a:buNone/>
-            </a:pPr>
-            <a:r>
-              <a:rPr lang="en-US" sz="4000" b="1" dirty="0">
-                <a:solidFill>
-                  <a:srgbClr val="F2B8D6"/>
-                </a:solidFill>
-                <a:latin typeface="Cambria" pitchFamily="34" charset="0"/>
-                <a:ea typeface="Cambria" pitchFamily="34" charset="-122"/>
-                <a:cs typeface="Cambria" pitchFamily="34" charset="-120"/>
-              </a:rPr>
-              <a:t>3/3</a:t>
-            </a:r>
-            <a:endParaRPr lang="en-US" sz="4000" dirty="0"/>
-          </a:p>
-        </p:txBody>
-      </p:sp>
-      <p:sp>
-        <p:nvSpPr>
-          <p:cNvPr id="9" name="close-stat3-label"/>
-          <p:cNvSpPr txBox="1"/>
-          <p:nvPr/>
-        </p:nvSpPr>
-        <p:spPr>
-          <a:xfrm>
-            <a:off x="6217920" y="2880360"/>
-            <a:ext cx="2377440" cy="822960"/>
-          </a:xfrm>
-          <a:prstGeom prst="rect">
-            <a:avLst/>
-          </a:prstGeom>
-          <a:noFill/>
-          <a:ln/>
-        </p:spPr>
-        <p:txBody>
-          <a:bodyPr wrap="square" lIns="0" tIns="0" rIns="0" bIns="0" rtlCol="0" anchor="t"/>
-          <a:lstStyle/>
-          <a:p>
-            <a:pPr indent="0" marL="0">
-              <a:buNone/>
-            </a:pPr>
-            <a:r>
-              <a:rPr lang="en-US" sz="1400" dirty="0">
-                <a:solidFill>
-                  <a:srgbClr val="CFE3D6"/>
-                </a:solidFill>
-              </a:rPr>
-              <a:t>lần chạy lại toàn bộ đều đạt, kết quả giống nhau</a:t>
-            </a:r>
-            <a:endParaRPr lang="en-US" sz="1400" dirty="0"/>
-          </a:p>
-        </p:txBody>
-      </p:sp>
-      <p:sp>
-        <p:nvSpPr>
-          <p:cNvPr id="10" name="close-stat4"/>
-          <p:cNvSpPr txBox="1"/>
-          <p:nvPr/>
-        </p:nvSpPr>
-        <p:spPr>
-          <a:xfrm>
-            <a:off x="8961120" y="2011680"/>
-            <a:ext cx="2560320" cy="822960"/>
-          </a:xfrm>
-          <a:prstGeom prst="rect">
-            <a:avLst/>
-          </a:prstGeom>
-          <a:noFill/>
-          <a:ln/>
-        </p:spPr>
-        <p:txBody>
-          <a:bodyPr wrap="square" lIns="0" tIns="0" rIns="0" bIns="0" rtlCol="0" anchor="t"/>
-          <a:lstStyle/>
-          <a:p>
-            <a:pPr indent="0" marL="0">
-              <a:buNone/>
-            </a:pPr>
-            <a:r>
-              <a:rPr lang="en-US" sz="4000" b="1" dirty="0">
-                <a:solidFill>
-                  <a:srgbClr val="F2B8D6"/>
-                </a:solidFill>
-                <a:latin typeface="Cambria" pitchFamily="34" charset="0"/>
-                <a:ea typeface="Cambria" pitchFamily="34" charset="-122"/>
-                <a:cs typeface="Cambria" pitchFamily="34" charset="-120"/>
-              </a:rPr>
-              <a:t>~0,6 s</a:t>
-            </a:r>
-            <a:endParaRPr lang="en-US" sz="4000" dirty="0"/>
-          </a:p>
-        </p:txBody>
-      </p:sp>
-      <p:sp>
-        <p:nvSpPr>
-          <p:cNvPr id="11" name="close-stat4-label"/>
-          <p:cNvSpPr txBox="1"/>
-          <p:nvPr/>
-        </p:nvSpPr>
-        <p:spPr>
-          <a:xfrm>
-            <a:off x="8961120" y="2880360"/>
-            <a:ext cx="2377440" cy="822960"/>
-          </a:xfrm>
-          <a:prstGeom prst="rect">
-            <a:avLst/>
-          </a:prstGeom>
-          <a:noFill/>
-          <a:ln/>
-        </p:spPr>
-        <p:txBody>
-          <a:bodyPr wrap="square" lIns="0" tIns="0" rIns="0" bIns="0" rtlCol="0" anchor="t"/>
-          <a:lstStyle/>
-          <a:p>
-            <a:pPr indent="0" marL="0">
-              <a:buNone/>
-            </a:pPr>
-            <a:r>
-              <a:rPr lang="en-US" sz="1400" dirty="0">
-                <a:solidFill>
-                  <a:srgbClr val="CFE3D6"/>
-                </a:solidFill>
-              </a:rPr>
-              <a:t>từ lúc bấm nút đến khi thấy thiết bị xác nhận</a:t>
-            </a:r>
-            <a:endParaRPr lang="en-US" sz="1400" dirty="0"/>
-          </a:p>
-        </p:txBody>
-      </p:sp>
-      <p:sp>
-        <p:nvSpPr>
-          <p:cNvPr id="12" name="close-next-title"/>
-          <p:cNvSpPr txBox="1"/>
-          <p:nvPr/>
-        </p:nvSpPr>
-        <p:spPr>
-          <a:xfrm>
-            <a:off x="731520" y="4069080"/>
-            <a:ext cx="5486400" cy="411480"/>
-          </a:xfrm>
-          <a:prstGeom prst="rect">
-            <a:avLst/>
-          </a:prstGeom>
-          <a:noFill/>
-          <a:ln/>
-        </p:spPr>
-        <p:txBody>
-          <a:bodyPr wrap="square" lIns="0" tIns="0" rIns="0" bIns="0" rtlCol="0" anchor="t"/>
-          <a:lstStyle/>
-          <a:p>
-            <a:pPr indent="0" marL="0">
-              <a:buNone/>
-            </a:pPr>
-            <a:r>
-              <a:rPr lang="en-US" sz="2000" b="1" dirty="0">
-                <a:solidFill>
-                  <a:schemeClr val="bg1"/>
-                </a:solidFill>
-                <a:latin typeface="Cambria" pitchFamily="34" charset="0"/>
-                <a:ea typeface="Cambria" pitchFamily="34" charset="-122"/>
-                <a:cs typeface="Cambria" pitchFamily="34" charset="-120"/>
-              </a:rPr>
               <a:t>Hướng phát triển</a:t>
             </a:r>
             <a:endParaRPr lang="en-US" sz="2000" dirty="0"/>
@@ -10757,7 +10673,7 @@
         </p:nvSpPr>
         <p:spPr>
           <a:xfrm>
-            <a:off x="731520" y="4663440"/>
+            <a:off x="731520" y="2560320"/>
             <a:ext cx="548640" cy="548640"/>
           </a:xfrm>
           <a:prstGeom prst="ellipse">
@@ -10776,21 +10692,21 @@
       </p:sp>
       <p:pic>
         <p:nvPicPr>
-          <p:cNvPr id="14" name="close-next1-icon" descr="preencoded.png">    </p:cNvPr>
+          <p:cNvPr id="14" name="close-next1-icon" descr="preencoded.png"/>
           <p:cNvPicPr>
             <a:picLocks noChangeAspect="1"/>
           </p:cNvPicPr>
           <p:nvPr/>
         </p:nvPicPr>
         <p:blipFill>
-          <a:blip r:embed="rId1"/>
+          <a:blip r:embed="rId3"/>
           <a:stretch>
             <a:fillRect/>
           </a:stretch>
         </p:blipFill>
         <p:spPr>
           <a:xfrm>
-            <a:off x="852221" y="4784141"/>
+            <a:off x="852221" y="2681021"/>
             <a:ext cx="307238" cy="307238"/>
           </a:xfrm>
           <a:prstGeom prst="rect">
@@ -10806,7 +10722,7 @@
         </p:nvSpPr>
         <p:spPr>
           <a:xfrm>
-            <a:off x="1463040" y="4663440"/>
+            <a:off x="1463040" y="2560320"/>
             <a:ext cx="2743200" cy="594360"/>
           </a:xfrm>
           <a:prstGeom prst="rect">
@@ -10819,7 +10735,7 @@
           <a:bodyPr wrap="square" lIns="0" tIns="0" rIns="0" bIns="0" rtlCol="0" anchor="ctr"/>
           <a:lstStyle/>
           <a:p>
-            <a:pPr indent="0" marL="0">
+            <a:pPr marL="0" indent="0">
               <a:buNone/>
             </a:pPr>
             <a:r>
@@ -10842,7 +10758,7 @@
         </p:nvSpPr>
         <p:spPr>
           <a:xfrm>
-            <a:off x="4389120" y="4663440"/>
+            <a:off x="4389120" y="2560320"/>
             <a:ext cx="548640" cy="548640"/>
           </a:xfrm>
           <a:prstGeom prst="ellipse">
@@ -10861,21 +10777,21 @@
       </p:sp>
       <p:pic>
         <p:nvPicPr>
-          <p:cNvPr id="17" name="close-next2-icon" descr="preencoded.png">    </p:cNvPr>
+          <p:cNvPr id="17" name="close-next2-icon" descr="preencoded.png"/>
           <p:cNvPicPr>
             <a:picLocks noChangeAspect="1"/>
           </p:cNvPicPr>
           <p:nvPr/>
         </p:nvPicPr>
         <p:blipFill>
-          <a:blip r:embed="rId2"/>
+          <a:blip r:embed="rId4"/>
           <a:stretch>
             <a:fillRect/>
           </a:stretch>
         </p:blipFill>
         <p:spPr>
           <a:xfrm>
-            <a:off x="4509821" y="4784141"/>
+            <a:off x="4509821" y="2681021"/>
             <a:ext cx="307238" cy="307238"/>
           </a:xfrm>
           <a:prstGeom prst="rect">
@@ -10891,7 +10807,7 @@
         </p:nvSpPr>
         <p:spPr>
           <a:xfrm>
-            <a:off x="5120640" y="4663440"/>
+            <a:off x="5120640" y="2560320"/>
             <a:ext cx="2743200" cy="594360"/>
           </a:xfrm>
           <a:prstGeom prst="rect">
@@ -10904,7 +10820,7 @@
           <a:bodyPr wrap="square" lIns="0" tIns="0" rIns="0" bIns="0" rtlCol="0" anchor="ctr"/>
           <a:lstStyle/>
           <a:p>
-            <a:pPr indent="0" marL="0">
+            <a:pPr marL="0" indent="0">
               <a:buNone/>
             </a:pPr>
             <a:r>
@@ -10927,7 +10843,7 @@
         </p:nvSpPr>
         <p:spPr>
           <a:xfrm>
-            <a:off x="8046720" y="4663440"/>
+            <a:off x="8046720" y="2560320"/>
             <a:ext cx="548640" cy="548640"/>
           </a:xfrm>
           <a:prstGeom prst="ellipse">
@@ -10946,21 +10862,21 @@
       </p:sp>
       <p:pic>
         <p:nvPicPr>
-          <p:cNvPr id="20" name="close-next3-icon" descr="preencoded.png">    </p:cNvPr>
+          <p:cNvPr id="20" name="close-next3-icon" descr="preencoded.png"/>
           <p:cNvPicPr>
             <a:picLocks noChangeAspect="1"/>
           </p:cNvPicPr>
           <p:nvPr/>
         </p:nvPicPr>
         <p:blipFill>
-          <a:blip r:embed="rId3"/>
+          <a:blip r:embed="rId5"/>
           <a:stretch>
             <a:fillRect/>
           </a:stretch>
         </p:blipFill>
         <p:spPr>
           <a:xfrm>
-            <a:off x="8167421" y="4784141"/>
+            <a:off x="8167421" y="2681021"/>
             <a:ext cx="307238" cy="307238"/>
           </a:xfrm>
           <a:prstGeom prst="rect">
@@ -10976,7 +10892,7 @@
         </p:nvSpPr>
         <p:spPr>
           <a:xfrm>
-            <a:off x="8778240" y="4663440"/>
+            <a:off x="8778240" y="2560320"/>
             <a:ext cx="2743200" cy="594360"/>
           </a:xfrm>
           <a:prstGeom prst="rect">
@@ -10989,7 +10905,7 @@
           <a:bodyPr wrap="square" lIns="0" tIns="0" rIns="0" bIns="0" rtlCol="0" anchor="ctr"/>
           <a:lstStyle/>
           <a:p>
-            <a:pPr indent="0" marL="0">
+            <a:pPr marL="0" indent="0">
               <a:buNone/>
             </a:pPr>
             <a:r>
@@ -11025,7 +10941,7 @@
           <a:bodyPr wrap="square" lIns="0" tIns="0" rIns="0" bIns="0" rtlCol="0" anchor="t"/>
           <a:lstStyle/>
           <a:p>
-            <a:pPr indent="0" marL="0">
+            <a:pPr marL="0" indent="0">
               <a:buNone/>
             </a:pPr>
             <a:r>
@@ -11060,7 +10976,7 @@
           </a:prstGeom>
           <a:extLst>
             <a:ext uri="{C572A759-6A51-4108-AA02-DFA0A04FC94B}">
-              <ma14:wrappingTextBoxFlag xmlns:ma14="http://schemas.microsoft.com/office/mac/drawingml/2011/main" val="0"/>
+              <ma14:wrappingTextBoxFlag xmlns="" xmlns:ma14="http://schemas.microsoft.com/office/mac/drawingml/2011/main" val="0"/>
             </a:ext>
           </a:extLst>
         </p:spPr>
@@ -11078,7 +10994,7 @@
           <a:p>
             <a:pPr algn="r"/>
             <a:fld id="{F7021451-1387-4CA6-816F-3879F97B5CBC}" type="slidenum">
-              <a:rPr b="0" lang="en-US"/>
+              <a:rPr lang="en-US" b="0"/>
               <a:t>9</a:t>
             </a:fld>
             <a:endParaRPr lang="en-US"/>
@@ -11386,4 +11302,319 @@
     </a:ext>
   </a:extLst>
 </a:theme>
+</file>
+
+<file path=ppt/theme/theme2.xml><?xml version="1.0" encoding="utf-8"?>
+<a:theme xmlns:a="http://schemas.openxmlformats.org/drawingml/2006/main" name="Office Theme">
+  <a:themeElements>
+    <a:clrScheme name="Office">
+      <a:dk1>
+        <a:sysClr val="windowText" lastClr="000000"/>
+      </a:dk1>
+      <a:lt1>
+        <a:sysClr val="window" lastClr="FFFFFF"/>
+      </a:lt1>
+      <a:dk2>
+        <a:srgbClr val="0E2841"/>
+      </a:dk2>
+      <a:lt2>
+        <a:srgbClr val="E8E8E8"/>
+      </a:lt2>
+      <a:accent1>
+        <a:srgbClr val="156082"/>
+      </a:accent1>
+      <a:accent2>
+        <a:srgbClr val="E97132"/>
+      </a:accent2>
+      <a:accent3>
+        <a:srgbClr val="196B24"/>
+      </a:accent3>
+      <a:accent4>
+        <a:srgbClr val="0F9ED5"/>
+      </a:accent4>
+      <a:accent5>
+        <a:srgbClr val="A02B93"/>
+      </a:accent5>
+      <a:accent6>
+        <a:srgbClr val="4EA72E"/>
+      </a:accent6>
+      <a:hlink>
+        <a:srgbClr val="467886"/>
+      </a:hlink>
+      <a:folHlink>
+        <a:srgbClr val="96607D"/>
+      </a:folHlink>
+    </a:clrScheme>
+    <a:fontScheme name="Office">
+      <a:majorFont>
+        <a:latin typeface="Aptos Display" panose="02110004020202020204"/>
+        <a:ea typeface=""/>
+        <a:cs typeface=""/>
+        <a:font script="Jpan" typeface="游ゴシック Light"/>
+        <a:font script="Hang" typeface="맑은 고딕"/>
+        <a:font script="Hans" typeface="等线 Light"/>
+        <a:font script="Hant" typeface="新細明體"/>
+        <a:font script="Arab" typeface="Times New Roman"/>
+        <a:font script="Hebr" typeface="Times New Roman"/>
+        <a:font script="Thai" typeface="Angsana New"/>
+        <a:font script="Ethi" typeface="Nyala"/>
+        <a:font script="Beng" typeface="Vrinda"/>
+        <a:font script="Gujr" typeface="Shruti"/>
+        <a:font script="Khmr" typeface="MoolBoran"/>
+        <a:font script="Knda" typeface="Tunga"/>
+        <a:font script="Guru" typeface="Raavi"/>
+        <a:font script="Cans" typeface="Euphemia"/>
+        <a:font script="Cher" typeface="Plantagenet Cherokee"/>
+        <a:font script="Yiii" typeface="Microsoft Yi Baiti"/>
+        <a:font script="Tibt" typeface="Microsoft Himalaya"/>
+        <a:font script="Thaa" typeface="MV Boli"/>
+        <a:font script="Deva" typeface="Mangal"/>
+        <a:font script="Telu" typeface="Gautami"/>
+        <a:font script="Taml" typeface="Latha"/>
+        <a:font script="Syrc" typeface="Estrangelo Edessa"/>
+        <a:font script="Orya" typeface="Kalinga"/>
+        <a:font script="Mlym" typeface="Kartika"/>
+        <a:font script="Laoo" typeface="DokChampa"/>
+        <a:font script="Sinh" typeface="Iskoola Pota"/>
+        <a:font script="Mong" typeface="Mongolian Baiti"/>
+        <a:font script="Viet" typeface="Times New Roman"/>
+        <a:font script="Uigh" typeface="Microsoft Uighur"/>
+        <a:font script="Geor" typeface="Sylfaen"/>
+        <a:font script="Armn" typeface="Arial"/>
+        <a:font script="Bugi" typeface="Leelawadee UI"/>
+        <a:font script="Bopo" typeface="Microsoft JhengHei"/>
+        <a:font script="Java" typeface="Javanese Text"/>
+        <a:font script="Lisu" typeface="Segoe UI"/>
+        <a:font script="Mymr" typeface="Myanmar Text"/>
+        <a:font script="Nkoo" typeface="Ebrima"/>
+        <a:font script="Olck" typeface="Nirmala UI"/>
+        <a:font script="Osma" typeface="Ebrima"/>
+        <a:font script="Phag" typeface="Phagspa"/>
+        <a:font script="Syrn" typeface="Estrangelo Edessa"/>
+        <a:font script="Syrj" typeface="Estrangelo Edessa"/>
+        <a:font script="Syre" typeface="Estrangelo Edessa"/>
+        <a:font script="Sora" typeface="Nirmala UI"/>
+        <a:font script="Tale" typeface="Microsoft Tai Le"/>
+        <a:font script="Talu" typeface="Microsoft New Tai Lue"/>
+        <a:font script="Tfng" typeface="Ebrima"/>
+      </a:majorFont>
+      <a:minorFont>
+        <a:latin typeface="Aptos" panose="02110004020202020204"/>
+        <a:ea typeface=""/>
+        <a:cs typeface=""/>
+        <a:font script="Jpan" typeface="游ゴシック"/>
+        <a:font script="Hang" typeface="맑은 고딕"/>
+        <a:font script="Hans" typeface="等线"/>
+        <a:font script="Hant" typeface="新細明體"/>
+        <a:font script="Arab" typeface="Arial"/>
+        <a:font script="Hebr" typeface="Arial"/>
+        <a:font script="Thai" typeface="Cordia New"/>
+        <a:font script="Ethi" typeface="Nyala"/>
+        <a:font script="Beng" typeface="Vrinda"/>
+        <a:font script="Gujr" typeface="Shruti"/>
+        <a:font script="Khmr" typeface="DaunPenh"/>
+        <a:font script="Knda" typeface="Tunga"/>
+        <a:font script="Guru" typeface="Raavi"/>
+        <a:font script="Cans" typeface="Euphemia"/>
+        <a:font script="Cher" typeface="Plantagenet Cherokee"/>
+        <a:font script="Yiii" typeface="Microsoft Yi Baiti"/>
+        <a:font script="Tibt" typeface="Microsoft Himalaya"/>
+        <a:font script="Thaa" typeface="MV Boli"/>
+        <a:font script="Deva" typeface="Mangal"/>
+        <a:font script="Telu" typeface="Gautami"/>
+        <a:font script="Taml" typeface="Latha"/>
+        <a:font script="Syrc" typeface="Estrangelo Edessa"/>
+        <a:font script="Orya" typeface="Kalinga"/>
+        <a:font script="Mlym" typeface="Kartika"/>
+        <a:font script="Laoo" typeface="DokChampa"/>
+        <a:font script="Sinh" typeface="Iskoola Pota"/>
+        <a:font script="Mong" typeface="Mongolian Baiti"/>
+        <a:font script="Viet" typeface="Arial"/>
+        <a:font script="Uigh" typeface="Microsoft Uighur"/>
+        <a:font script="Geor" typeface="Sylfaen"/>
+        <a:font script="Armn" typeface="Arial"/>
+        <a:font script="Bugi" typeface="Leelawadee UI"/>
+        <a:font script="Bopo" typeface="Microsoft JhengHei"/>
+        <a:font script="Java" typeface="Javanese Text"/>
+        <a:font script="Lisu" typeface="Segoe UI"/>
+        <a:font script="Mymr" typeface="Myanmar Text"/>
+        <a:font script="Nkoo" typeface="Ebrima"/>
+        <a:font script="Olck" typeface="Nirmala UI"/>
+        <a:font script="Osma" typeface="Ebrima"/>
+        <a:font script="Phag" typeface="Phagspa"/>
+        <a:font script="Syrn" typeface="Estrangelo Edessa"/>
+        <a:font script="Syrj" typeface="Estrangelo Edessa"/>
+        <a:font script="Syre" typeface="Estrangelo Edessa"/>
+        <a:font script="Sora" typeface="Nirmala UI"/>
+        <a:font script="Tale" typeface="Microsoft Tai Le"/>
+        <a:font script="Talu" typeface="Microsoft New Tai Lue"/>
+        <a:font script="Tfng" typeface="Ebrima"/>
+      </a:minorFont>
+    </a:fontScheme>
+    <a:fmtScheme name="Office">
+      <a:fillStyleLst>
+        <a:solidFill>
+          <a:schemeClr val="phClr"/>
+        </a:solidFill>
+        <a:gradFill rotWithShape="1">
+          <a:gsLst>
+            <a:gs pos="0">
+              <a:schemeClr val="phClr">
+                <a:lumMod val="110000"/>
+                <a:satMod val="105000"/>
+                <a:tint val="67000"/>
+              </a:schemeClr>
+            </a:gs>
+            <a:gs pos="50000">
+              <a:schemeClr val="phClr">
+                <a:lumMod val="105000"/>
+                <a:satMod val="103000"/>
+                <a:tint val="73000"/>
+              </a:schemeClr>
+            </a:gs>
+            <a:gs pos="100000">
+              <a:schemeClr val="phClr">
+                <a:lumMod val="105000"/>
+                <a:satMod val="109000"/>
+                <a:tint val="81000"/>
+              </a:schemeClr>
+            </a:gs>
+          </a:gsLst>
+          <a:lin ang="5400000" scaled="0"/>
+        </a:gradFill>
+        <a:gradFill rotWithShape="1">
+          <a:gsLst>
+            <a:gs pos="0">
+              <a:schemeClr val="phClr">
+                <a:satMod val="103000"/>
+                <a:lumMod val="102000"/>
+                <a:tint val="94000"/>
+              </a:schemeClr>
+            </a:gs>
+            <a:gs pos="50000">
+              <a:schemeClr val="phClr">
+                <a:satMod val="110000"/>
+                <a:lumMod val="100000"/>
+                <a:shade val="100000"/>
+              </a:schemeClr>
+            </a:gs>
+            <a:gs pos="100000">
+              <a:schemeClr val="phClr">
+                <a:lumMod val="99000"/>
+                <a:satMod val="120000"/>
+                <a:shade val="78000"/>
+              </a:schemeClr>
+            </a:gs>
+          </a:gsLst>
+          <a:lin ang="5400000" scaled="0"/>
+        </a:gradFill>
+      </a:fillStyleLst>
+      <a:lnStyleLst>
+        <a:ln w="12700" cap="flat" cmpd="sng" algn="ctr">
+          <a:solidFill>
+            <a:schemeClr val="phClr"/>
+          </a:solidFill>
+          <a:prstDash val="solid"/>
+          <a:miter lim="800000"/>
+        </a:ln>
+        <a:ln w="19050" cap="flat" cmpd="sng" algn="ctr">
+          <a:solidFill>
+            <a:schemeClr val="phClr"/>
+          </a:solidFill>
+          <a:prstDash val="solid"/>
+          <a:miter lim="800000"/>
+        </a:ln>
+        <a:ln w="25400" cap="flat" cmpd="sng" algn="ctr">
+          <a:solidFill>
+            <a:schemeClr val="phClr"/>
+          </a:solidFill>
+          <a:prstDash val="solid"/>
+          <a:miter lim="800000"/>
+        </a:ln>
+      </a:lnStyleLst>
+      <a:effectStyleLst>
+        <a:effectStyle>
+          <a:effectLst/>
+        </a:effectStyle>
+        <a:effectStyle>
+          <a:effectLst/>
+        </a:effectStyle>
+        <a:effectStyle>
+          <a:effectLst>
+            <a:outerShdw blurRad="57150" dist="19050" dir="5400000" algn="ctr" rotWithShape="0">
+              <a:srgbClr val="000000">
+                <a:alpha val="63000"/>
+              </a:srgbClr>
+            </a:outerShdw>
+          </a:effectLst>
+        </a:effectStyle>
+      </a:effectStyleLst>
+      <a:bgFillStyleLst>
+        <a:solidFill>
+          <a:schemeClr val="phClr"/>
+        </a:solidFill>
+        <a:solidFill>
+          <a:schemeClr val="phClr">
+            <a:tint val="95000"/>
+            <a:satMod val="170000"/>
+          </a:schemeClr>
+        </a:solidFill>
+        <a:gradFill rotWithShape="1">
+          <a:gsLst>
+            <a:gs pos="0">
+              <a:schemeClr val="phClr">
+                <a:tint val="93000"/>
+                <a:satMod val="150000"/>
+                <a:shade val="98000"/>
+                <a:lumMod val="102000"/>
+              </a:schemeClr>
+            </a:gs>
+            <a:gs pos="50000">
+              <a:schemeClr val="phClr">
+                <a:tint val="98000"/>
+                <a:satMod val="130000"/>
+                <a:shade val="90000"/>
+                <a:lumMod val="103000"/>
+              </a:schemeClr>
+            </a:gs>
+            <a:gs pos="100000">
+              <a:schemeClr val="phClr">
+                <a:shade val="63000"/>
+                <a:satMod val="120000"/>
+              </a:schemeClr>
+            </a:gs>
+          </a:gsLst>
+          <a:lin ang="5400000" scaled="0"/>
+        </a:gradFill>
+      </a:bgFillStyleLst>
+    </a:fmtScheme>
+  </a:themeElements>
+  <a:objectDefaults>
+    <a:lnDef>
+      <a:spPr/>
+      <a:bodyPr/>
+      <a:lstStyle/>
+      <a:style>
+        <a:lnRef idx="2">
+          <a:schemeClr val="accent1"/>
+        </a:lnRef>
+        <a:fillRef idx="0">
+          <a:schemeClr val="accent1"/>
+        </a:fillRef>
+        <a:effectRef idx="1">
+          <a:schemeClr val="accent1"/>
+        </a:effectRef>
+        <a:fontRef idx="minor">
+          <a:schemeClr val="tx1"/>
+        </a:fontRef>
+      </a:style>
+    </a:lnDef>
+  </a:objectDefaults>
+  <a:extraClrSchemeLst/>
+  <a:extLst>
+    <a:ext uri="{05A4C25C-085E-4340-85A3-A5531E510DB2}">
+      <thm15:themeFamily xmlns:thm15="http://schemas.microsoft.com/office/thememl/2012/main" name="Office Theme" id="{2E142A2C-CD16-42D6-873A-C26D2A0506FA}" vid="{1BDDFF52-6CD6-40A5-AB3C-68EB2F1E4D0A}"/>
+    </a:ext>
+  </a:extLst>
+</a:theme>
 </file>
</xml_diff>

<commit_message>
docs: them slide danh sach thiet bi
Co-Authored-By: Claude Opus 5.5 (1M context) <noreply@anthropic.com>
</commit_message>
<xml_diff>
--- a/docs/kien-truc-he-thong.pptx
+++ b/docs/kien-truc-he-thong.pptx
@@ -11,6 +11,7 @@
     <p:sldId id="256" r:id="rId2"/>
     <p:sldId id="257" r:id="rId3"/>
     <p:sldId id="258" r:id="rId4"/>
+    <p:sldId id="265" r:id="rId16"/>
     <p:sldId id="259" r:id="rId5"/>
     <p:sldId id="260" r:id="rId6"/>
     <p:sldId id="261" r:id="rId7"/>
@@ -395,6 +396,82 @@
 </p:notes>
 </file>
 
+<file path=ppt/notesSlides/notesSlide10.xml><?xml version="1.0" encoding="utf-8"?>
+<p:notes xmlns:a="http://schemas.openxmlformats.org/drawingml/2006/main" xmlns:p="http://schemas.openxmlformats.org/presentationml/2006/main" xmlns:r="http://schemas.openxmlformats.org/officeDocument/2006/relationships">
+  <p:cSld>
+    <p:spTree>
+      <p:nvGrpSpPr>
+        <p:cNvPr id="1" name=""/>
+        <p:cNvGrpSpPr/>
+        <p:nvPr/>
+      </p:nvGrpSpPr>
+      <p:grpSpPr>
+        <a:xfrm>
+          <a:off x="0" y="0"/>
+          <a:ext cx="0" cy="0"/>
+          <a:chOff x="0" y="0"/>
+          <a:chExt cx="0" cy="0"/>
+        </a:xfrm>
+      </p:grpSpPr>
+      <p:sp>
+        <p:nvSpPr>
+          <p:cNvPr id="3" name="Notes Placeholder 2"/>
+          <p:cNvSpPr>
+            <a:spLocks noGrp="1"/>
+          </p:cNvSpPr>
+          <p:nvPr>
+            <p:ph type="body" idx="1"/>
+          </p:nvPr>
+        </p:nvSpPr>
+        <p:spPr/>
+        <p:txBody>
+          <a:bodyPr/>
+          <a:lstStyle/>
+          <a:p>
+            <a:r>
+              <a:t>Ý CHÍNH: Toàn bộ thiết bị của hệ thống, mỗi loại một chiếc.</a:t>
+            </a:r>
+          </a:p>
+          <a:p>
+            <a:r>
+              <a:t>- ESP32 là bộ não. Khi mô phỏng dùng ESP32 DevKit V1 trên Wokwi; khi làm thật (phần Bonus) dùng ESP32-S3 DevKitC-1, nên số chân khác nhau – nhớ đối chiếu đúng cột khi đấu dây.</a:t>
+            </a:r>
+          </a:p>
+          <a:p>
+            <a:r>
+              <a:t>- 3 cảm biến: DHT22 (nhiệt độ, độ ẩm), quang trở LDR (sáng/tối), mực nước (Wokwi giả lập bằng một biến trở, kéo xuống thấp là "cạn nước").</a:t>
+            </a:r>
+          </a:p>
+          <a:p>
+            <a:r>
+              <a:t>- 3 relay là công tắc điện do ESP32 bật/tắt, nối với bơm phun sương, quạt và đèn LED. Trên Wokwi chỉ có relay, không có bơm/quạt/đèn thật.</a:t>
+            </a:r>
+          </a:p>
+          <a:p>
+            <a:r>
+              <a:t>- Màn hình ST7789 chỉ có trên board thật, hiện số đo ngay tại vườn.</a:t>
+            </a:r>
+          </a:p>
+          <a:p>
+            <a:r>
+              <a:t>- Máy tính chạy Node-RED làm server và dashboard; broker dùng broker công cộng broker.emqx.io nên không cần máy chủ riêng.</a:t>
+            </a:r>
+          </a:p>
+          <a:p>
+            <a:r>
+              <a:t>CÂU HỎI CÓ THỂ GẶP: "Sao board thật dùng chân khác?" → ESP32-S3 có sơ đồ chân khác ESP32 thường; chương trình cho board thật (s3_physical.cpp) khai báo chân riêng.</a:t>
+            </a:r>
+          </a:p>
+        </p:txBody>
+      </p:sp>
+    </p:spTree>
+  </p:cSld>
+  <p:clrMapOvr>
+    <a:masterClrMapping/>
+  </p:clrMapOvr>
+</p:notes>
+</file>
+
 <file path=ppt/notesSlides/notesSlide2.xml><?xml version="1.0" encoding="utf-8"?>
 <p:notes xmlns:a="http://schemas.openxmlformats.org/drawingml/2006/main" xmlns:r="http://schemas.openxmlformats.org/officeDocument/2006/relationships" xmlns:p="http://schemas.openxmlformats.org/presentationml/2006/main">
   <p:cSld>
@@ -3107,6 +3184,1227 @@
           </a:p>
         </p:txBody>
       </p:sp>
+    </p:spTree>
+  </p:cSld>
+  <p:clrMapOvr>
+    <a:masterClrMapping/>
+  </p:clrMapOvr>
+</p:sld>
+</file>
+
+<file path=ppt/slides/slide10.xml><?xml version="1.0" encoding="utf-8"?>
+<p:sld xmlns:a="http://schemas.openxmlformats.org/drawingml/2006/main" xmlns:p="http://schemas.openxmlformats.org/presentationml/2006/main" xmlns:r="http://schemas.openxmlformats.org/officeDocument/2006/relationships">
+  <p:cSld>
+    <p:spTree>
+      <p:nvGrpSpPr>
+        <p:cNvPr id="1" name=""/>
+        <p:cNvGrpSpPr/>
+        <p:nvPr/>
+      </p:nvGrpSpPr>
+      <p:grpSpPr/>
+      <p:sp>
+        <p:nvSpPr>
+          <p:cNvPr id="2" name="Title 1"/>
+          <p:cNvSpPr>
+            <a:spLocks noGrp="1"/>
+          </p:cNvSpPr>
+          <p:nvPr>
+            <p:ph type="title" idx="100"/>
+          </p:nvPr>
+        </p:nvSpPr>
+        <p:spPr>
+          <a:xfrm>
+            <a:off x="548640" y="320040"/>
+            <a:ext cx="11064240" cy="685800"/>
+          </a:xfrm>
+        </p:spPr>
+        <p:txBody>
+          <a:bodyPr lIns="0" rIns="0" tIns="0" bIns="0"/>
+          <a:lstStyle/>
+          <a:p>
+            <a:pPr algn="l"/>
+            <a:r>
+              <a:t>Phần 1: Danh sách thiết bị</a:t>
+            </a:r>
+          </a:p>
+        </p:txBody>
+      </p:sp>
+      <p:sp>
+        <p:nvSpPr>
+          <p:cNvPr id="3" name="Text Placeholder 2"/>
+          <p:cNvSpPr>
+            <a:spLocks noGrp="1"/>
+          </p:cNvSpPr>
+          <p:nvPr>
+            <p:ph type="body" idx="101"/>
+          </p:nvPr>
+        </p:nvSpPr>
+        <p:spPr>
+          <a:xfrm>
+            <a:off x="548640" y="1005840"/>
+            <a:ext cx="11064240" cy="411480"/>
+          </a:xfrm>
+        </p:spPr>
+        <p:txBody>
+          <a:bodyPr lIns="0" rIns="0" tIns="0" bIns="0"/>
+          <a:lstStyle/>
+          <a:p>
+            <a:pPr/>
+            <a:r>
+              <a:t>Mỗi thiết bị một chiếc; trên Wokwi là linh kiện mô phỏng, cột cuối là chân nối khi lắp board thật</a:t>
+            </a:r>
+          </a:p>
+        </p:txBody>
+      </p:sp>
+      <p:graphicFrame>
+        <p:nvGraphicFramePr>
+          <p:cNvPr id="4" name="devices-table"/>
+          <p:cNvGraphicFramePr>
+            <a:graphicFrameLocks noGrp="1"/>
+          </p:cNvGraphicFramePr>
+          <p:nvPr/>
+        </p:nvGraphicFramePr>
+        <p:xfrm>
+          <a:off x="548640" y="1600200"/>
+          <a:ext cx="11064240" cy="4206240"/>
+        </p:xfrm>
+        <a:graphic>
+          <a:graphicData uri="http://schemas.openxmlformats.org/drawingml/2006/table">
+            <a:tbl>
+              <a:tblPr firstRow="1" bandRow="1">
+                <a:tableStyleId>{5C22544A-7EE6-4342-B048-85BDC9FD1C3A}</a:tableStyleId>
+              </a:tblPr>
+              <a:tblGrid>
+                <a:gridCol w="548640"/>
+                <a:gridCol w="2743200"/>
+                <a:gridCol w="4480560"/>
+                <a:gridCol w="1645920"/>
+                <a:gridCol w="1645920"/>
+              </a:tblGrid>
+              <a:tr h="420624">
+                <a:tc>
+                  <a:txBody>
+                    <a:bodyPr wrap="square"/>
+                    <a:lstStyle/>
+                    <a:p>
+                      <a:pPr algn="ctr"/>
+                      <a:r>
+                        <a:rPr sz="1400" b="1">
+                          <a:solidFill>
+                            <a:srgbClr val="FFFFFF"/>
+                          </a:solidFill>
+                        </a:rPr>
+                        <a:t>STT</a:t>
+                      </a:r>
+                    </a:p>
+                  </a:txBody>
+                  <a:tcPr marL="91440" marR="91440" marT="27432" marB="27432" anchor="ctr">
+                    <a:solidFill>
+                      <a:srgbClr val="17402C"/>
+                    </a:solidFill>
+                  </a:tcPr>
+                </a:tc>
+                <a:tc>
+                  <a:txBody>
+                    <a:bodyPr wrap="square"/>
+                    <a:lstStyle/>
+                    <a:p>
+                      <a:pPr algn="l"/>
+                      <a:r>
+                        <a:rPr sz="1400" b="1">
+                          <a:solidFill>
+                            <a:srgbClr val="FFFFFF"/>
+                          </a:solidFill>
+                        </a:rPr>
+                        <a:t>Thiết bị</a:t>
+                      </a:r>
+                    </a:p>
+                  </a:txBody>
+                  <a:tcPr marL="91440" marR="91440" marT="27432" marB="27432" anchor="ctr">
+                    <a:solidFill>
+                      <a:srgbClr val="17402C"/>
+                    </a:solidFill>
+                  </a:tcPr>
+                </a:tc>
+                <a:tc>
+                  <a:txBody>
+                    <a:bodyPr wrap="square"/>
+                    <a:lstStyle/>
+                    <a:p>
+                      <a:pPr algn="l"/>
+                      <a:r>
+                        <a:rPr sz="1400" b="1">
+                          <a:solidFill>
+                            <a:srgbClr val="FFFFFF"/>
+                          </a:solidFill>
+                        </a:rPr>
+                        <a:t>Dùng để</a:t>
+                      </a:r>
+                    </a:p>
+                  </a:txBody>
+                  <a:tcPr marL="91440" marR="91440" marT="27432" marB="27432" anchor="ctr">
+                    <a:solidFill>
+                      <a:srgbClr val="17402C"/>
+                    </a:solidFill>
+                  </a:tcPr>
+                </a:tc>
+                <a:tc>
+                  <a:txBody>
+                    <a:bodyPr wrap="square"/>
+                    <a:lstStyle/>
+                    <a:p>
+                      <a:pPr algn="ctr"/>
+                      <a:r>
+                        <a:rPr sz="1400" b="1">
+                          <a:solidFill>
+                            <a:srgbClr val="FFFFFF"/>
+                          </a:solidFill>
+                        </a:rPr>
+                        <a:t>Chân trên Wokwi</a:t>
+                      </a:r>
+                    </a:p>
+                  </a:txBody>
+                  <a:tcPr marL="91440" marR="91440" marT="27432" marB="27432" anchor="ctr">
+                    <a:solidFill>
+                      <a:srgbClr val="17402C"/>
+                    </a:solidFill>
+                  </a:tcPr>
+                </a:tc>
+                <a:tc>
+                  <a:txBody>
+                    <a:bodyPr wrap="square"/>
+                    <a:lstStyle/>
+                    <a:p>
+                      <a:pPr algn="ctr"/>
+                      <a:r>
+                        <a:rPr sz="1400" b="1">
+                          <a:solidFill>
+                            <a:srgbClr val="FFFFFF"/>
+                          </a:solidFill>
+                        </a:rPr>
+                        <a:t>Chân board thật</a:t>
+                      </a:r>
+                    </a:p>
+                  </a:txBody>
+                  <a:tcPr marL="91440" marR="91440" marT="27432" marB="27432" anchor="ctr">
+                    <a:solidFill>
+                      <a:srgbClr val="17402C"/>
+                    </a:solidFill>
+                  </a:tcPr>
+                </a:tc>
+              </a:tr>
+              <a:tr h="420624">
+                <a:tc>
+                  <a:txBody>
+                    <a:bodyPr wrap="square"/>
+                    <a:lstStyle/>
+                    <a:p>
+                      <a:pPr algn="ctr"/>
+                      <a:r>
+                        <a:rPr sz="1300" b="0">
+                          <a:solidFill>
+                            <a:srgbClr val="1C2B22"/>
+                          </a:solidFill>
+                        </a:rPr>
+                        <a:t>1</a:t>
+                      </a:r>
+                    </a:p>
+                  </a:txBody>
+                  <a:tcPr marL="91440" marR="91440" marT="27432" marB="27432" anchor="ctr">
+                    <a:solidFill>
+                      <a:srgbClr val="EEF4EF"/>
+                    </a:solidFill>
+                  </a:tcPr>
+                </a:tc>
+                <a:tc>
+                  <a:txBody>
+                    <a:bodyPr wrap="square"/>
+                    <a:lstStyle/>
+                    <a:p>
+                      <a:pPr algn="l"/>
+                      <a:r>
+                        <a:rPr sz="1300" b="1">
+                          <a:solidFill>
+                            <a:srgbClr val="1C2B22"/>
+                          </a:solidFill>
+                        </a:rPr>
+                        <a:t>Vi điều khiển ESP32</a:t>
+                      </a:r>
+                    </a:p>
+                  </a:txBody>
+                  <a:tcPr marL="91440" marR="91440" marT="27432" marB="27432" anchor="ctr">
+                    <a:solidFill>
+                      <a:srgbClr val="EEF4EF"/>
+                    </a:solidFill>
+                  </a:tcPr>
+                </a:tc>
+                <a:tc>
+                  <a:txBody>
+                    <a:bodyPr wrap="square"/>
+                    <a:lstStyle/>
+                    <a:p>
+                      <a:pPr algn="l"/>
+                      <a:r>
+                        <a:rPr sz="1300" b="0">
+                          <a:solidFill>
+                            <a:srgbClr val="1C2B22"/>
+                          </a:solidFill>
+                        </a:rPr>
+                        <a:t>Bộ não: đọc cảm biến, bật/tắt relay, Wi-Fi + MQTT</a:t>
+                      </a:r>
+                    </a:p>
+                  </a:txBody>
+                  <a:tcPr marL="91440" marR="91440" marT="27432" marB="27432" anchor="ctr">
+                    <a:solidFill>
+                      <a:srgbClr val="EEF4EF"/>
+                    </a:solidFill>
+                  </a:tcPr>
+                </a:tc>
+                <a:tc>
+                  <a:txBody>
+                    <a:bodyPr wrap="square"/>
+                    <a:lstStyle/>
+                    <a:p>
+                      <a:pPr algn="ctr"/>
+                      <a:r>
+                        <a:rPr sz="1300" b="0">
+                          <a:solidFill>
+                            <a:srgbClr val="2E7D4F"/>
+                          </a:solidFill>
+                        </a:rPr>
+                        <a:t>ESP32 DevKit V1</a:t>
+                      </a:r>
+                    </a:p>
+                  </a:txBody>
+                  <a:tcPr marL="91440" marR="91440" marT="27432" marB="27432" anchor="ctr">
+                    <a:solidFill>
+                      <a:srgbClr val="EEF4EF"/>
+                    </a:solidFill>
+                  </a:tcPr>
+                </a:tc>
+                <a:tc>
+                  <a:txBody>
+                    <a:bodyPr wrap="square"/>
+                    <a:lstStyle/>
+                    <a:p>
+                      <a:pPr algn="ctr"/>
+                      <a:r>
+                        <a:rPr sz="1300" b="0">
+                          <a:solidFill>
+                            <a:srgbClr val="B5367A"/>
+                          </a:solidFill>
+                        </a:rPr>
+                        <a:t>ESP32-S3 DevKitC-1</a:t>
+                      </a:r>
+                    </a:p>
+                  </a:txBody>
+                  <a:tcPr marL="91440" marR="91440" marT="27432" marB="27432" anchor="ctr">
+                    <a:solidFill>
+                      <a:srgbClr val="EEF4EF"/>
+                    </a:solidFill>
+                  </a:tcPr>
+                </a:tc>
+              </a:tr>
+              <a:tr h="420624">
+                <a:tc>
+                  <a:txBody>
+                    <a:bodyPr wrap="square"/>
+                    <a:lstStyle/>
+                    <a:p>
+                      <a:pPr algn="ctr"/>
+                      <a:r>
+                        <a:rPr sz="1300" b="0">
+                          <a:solidFill>
+                            <a:srgbClr val="1C2B22"/>
+                          </a:solidFill>
+                        </a:rPr>
+                        <a:t>2</a:t>
+                      </a:r>
+                    </a:p>
+                  </a:txBody>
+                  <a:tcPr marL="91440" marR="91440" marT="27432" marB="27432" anchor="ctr">
+                    <a:solidFill>
+                      <a:srgbClr val="FFFFFF"/>
+                    </a:solidFill>
+                  </a:tcPr>
+                </a:tc>
+                <a:tc>
+                  <a:txBody>
+                    <a:bodyPr wrap="square"/>
+                    <a:lstStyle/>
+                    <a:p>
+                      <a:pPr algn="l"/>
+                      <a:r>
+                        <a:rPr sz="1300" b="1">
+                          <a:solidFill>
+                            <a:srgbClr val="1C2B22"/>
+                          </a:solidFill>
+                        </a:rPr>
+                        <a:t>Cảm biến DHT22</a:t>
+                      </a:r>
+                    </a:p>
+                  </a:txBody>
+                  <a:tcPr marL="91440" marR="91440" marT="27432" marB="27432" anchor="ctr">
+                    <a:solidFill>
+                      <a:srgbClr val="FFFFFF"/>
+                    </a:solidFill>
+                  </a:tcPr>
+                </a:tc>
+                <a:tc>
+                  <a:txBody>
+                    <a:bodyPr wrap="square"/>
+                    <a:lstStyle/>
+                    <a:p>
+                      <a:pPr algn="l"/>
+                      <a:r>
+                        <a:rPr sz="1300" b="0">
+                          <a:solidFill>
+                            <a:srgbClr val="1C2B22"/>
+                          </a:solidFill>
+                        </a:rPr>
+                        <a:t>Đo nhiệt độ và độ ẩm không khí</a:t>
+                      </a:r>
+                    </a:p>
+                  </a:txBody>
+                  <a:tcPr marL="91440" marR="91440" marT="27432" marB="27432" anchor="ctr">
+                    <a:solidFill>
+                      <a:srgbClr val="FFFFFF"/>
+                    </a:solidFill>
+                  </a:tcPr>
+                </a:tc>
+                <a:tc>
+                  <a:txBody>
+                    <a:bodyPr wrap="square"/>
+                    <a:lstStyle/>
+                    <a:p>
+                      <a:pPr algn="ctr"/>
+                      <a:r>
+                        <a:rPr sz="1300" b="0">
+                          <a:solidFill>
+                            <a:srgbClr val="2E7D4F"/>
+                          </a:solidFill>
+                        </a:rPr>
+                        <a:t>GPIO15</a:t>
+                      </a:r>
+                    </a:p>
+                  </a:txBody>
+                  <a:tcPr marL="91440" marR="91440" marT="27432" marB="27432" anchor="ctr">
+                    <a:solidFill>
+                      <a:srgbClr val="FFFFFF"/>
+                    </a:solidFill>
+                  </a:tcPr>
+                </a:tc>
+                <a:tc>
+                  <a:txBody>
+                    <a:bodyPr wrap="square"/>
+                    <a:lstStyle/>
+                    <a:p>
+                      <a:pPr algn="ctr"/>
+                      <a:r>
+                        <a:rPr sz="1300" b="0">
+                          <a:solidFill>
+                            <a:srgbClr val="B5367A"/>
+                          </a:solidFill>
+                        </a:rPr>
+                        <a:t>GPIO4</a:t>
+                      </a:r>
+                    </a:p>
+                  </a:txBody>
+                  <a:tcPr marL="91440" marR="91440" marT="27432" marB="27432" anchor="ctr">
+                    <a:solidFill>
+                      <a:srgbClr val="FFFFFF"/>
+                    </a:solidFill>
+                  </a:tcPr>
+                </a:tc>
+              </a:tr>
+              <a:tr h="420624">
+                <a:tc>
+                  <a:txBody>
+                    <a:bodyPr wrap="square"/>
+                    <a:lstStyle/>
+                    <a:p>
+                      <a:pPr algn="ctr"/>
+                      <a:r>
+                        <a:rPr sz="1300" b="0">
+                          <a:solidFill>
+                            <a:srgbClr val="1C2B22"/>
+                          </a:solidFill>
+                        </a:rPr>
+                        <a:t>3</a:t>
+                      </a:r>
+                    </a:p>
+                  </a:txBody>
+                  <a:tcPr marL="91440" marR="91440" marT="27432" marB="27432" anchor="ctr">
+                    <a:solidFill>
+                      <a:srgbClr val="EEF4EF"/>
+                    </a:solidFill>
+                  </a:tcPr>
+                </a:tc>
+                <a:tc>
+                  <a:txBody>
+                    <a:bodyPr wrap="square"/>
+                    <a:lstStyle/>
+                    <a:p>
+                      <a:pPr algn="l"/>
+                      <a:r>
+                        <a:rPr sz="1300" b="1">
+                          <a:solidFill>
+                            <a:srgbClr val="1C2B22"/>
+                          </a:solidFill>
+                        </a:rPr>
+                        <a:t>Quang trở LDR</a:t>
+                      </a:r>
+                    </a:p>
+                  </a:txBody>
+                  <a:tcPr marL="91440" marR="91440" marT="27432" marB="27432" anchor="ctr">
+                    <a:solidFill>
+                      <a:srgbClr val="EEF4EF"/>
+                    </a:solidFill>
+                  </a:tcPr>
+                </a:tc>
+                <a:tc>
+                  <a:txBody>
+                    <a:bodyPr wrap="square"/>
+                    <a:lstStyle/>
+                    <a:p>
+                      <a:pPr algn="l"/>
+                      <a:r>
+                        <a:rPr sz="1300" b="0">
+                          <a:solidFill>
+                            <a:srgbClr val="1C2B22"/>
+                          </a:solidFill>
+                        </a:rPr>
+                        <a:t>Biết trời sáng hay tối</a:t>
+                      </a:r>
+                    </a:p>
+                  </a:txBody>
+                  <a:tcPr marL="91440" marR="91440" marT="27432" marB="27432" anchor="ctr">
+                    <a:solidFill>
+                      <a:srgbClr val="EEF4EF"/>
+                    </a:solidFill>
+                  </a:tcPr>
+                </a:tc>
+                <a:tc>
+                  <a:txBody>
+                    <a:bodyPr wrap="square"/>
+                    <a:lstStyle/>
+                    <a:p>
+                      <a:pPr algn="ctr"/>
+                      <a:r>
+                        <a:rPr sz="1300" b="0">
+                          <a:solidFill>
+                            <a:srgbClr val="2E7D4F"/>
+                          </a:solidFill>
+                        </a:rPr>
+                        <a:t>GPIO34</a:t>
+                      </a:r>
+                    </a:p>
+                  </a:txBody>
+                  <a:tcPr marL="91440" marR="91440" marT="27432" marB="27432" anchor="ctr">
+                    <a:solidFill>
+                      <a:srgbClr val="EEF4EF"/>
+                    </a:solidFill>
+                  </a:tcPr>
+                </a:tc>
+                <a:tc>
+                  <a:txBody>
+                    <a:bodyPr wrap="square"/>
+                    <a:lstStyle/>
+                    <a:p>
+                      <a:pPr algn="ctr"/>
+                      <a:r>
+                        <a:rPr sz="1300" b="0">
+                          <a:solidFill>
+                            <a:srgbClr val="B5367A"/>
+                          </a:solidFill>
+                        </a:rPr>
+                        <a:t>GPIO1</a:t>
+                      </a:r>
+                    </a:p>
+                  </a:txBody>
+                  <a:tcPr marL="91440" marR="91440" marT="27432" marB="27432" anchor="ctr">
+                    <a:solidFill>
+                      <a:srgbClr val="EEF4EF"/>
+                    </a:solidFill>
+                  </a:tcPr>
+                </a:tc>
+              </a:tr>
+              <a:tr h="420624">
+                <a:tc>
+                  <a:txBody>
+                    <a:bodyPr wrap="square"/>
+                    <a:lstStyle/>
+                    <a:p>
+                      <a:pPr algn="ctr"/>
+                      <a:r>
+                        <a:rPr sz="1300" b="0">
+                          <a:solidFill>
+                            <a:srgbClr val="1C2B22"/>
+                          </a:solidFill>
+                        </a:rPr>
+                        <a:t>4</a:t>
+                      </a:r>
+                    </a:p>
+                  </a:txBody>
+                  <a:tcPr marL="91440" marR="91440" marT="27432" marB="27432" anchor="ctr">
+                    <a:solidFill>
+                      <a:srgbClr val="FFFFFF"/>
+                    </a:solidFill>
+                  </a:tcPr>
+                </a:tc>
+                <a:tc>
+                  <a:txBody>
+                    <a:bodyPr wrap="square"/>
+                    <a:lstStyle/>
+                    <a:p>
+                      <a:pPr algn="l"/>
+                      <a:r>
+                        <a:rPr sz="1300" b="1">
+                          <a:solidFill>
+                            <a:srgbClr val="1C2B22"/>
+                          </a:solidFill>
+                        </a:rPr>
+                        <a:t>Cảm biến mực nước</a:t>
+                      </a:r>
+                    </a:p>
+                  </a:txBody>
+                  <a:tcPr marL="91440" marR="91440" marT="27432" marB="27432" anchor="ctr">
+                    <a:solidFill>
+                      <a:srgbClr val="FFFFFF"/>
+                    </a:solidFill>
+                  </a:tcPr>
+                </a:tc>
+                <a:tc>
+                  <a:txBody>
+                    <a:bodyPr wrap="square"/>
+                    <a:lstStyle/>
+                    <a:p>
+                      <a:pPr algn="l"/>
+                      <a:r>
+                        <a:rPr sz="1300" b="0">
+                          <a:solidFill>
+                            <a:srgbClr val="1C2B22"/>
+                          </a:solidFill>
+                        </a:rPr>
+                        <a:t>Biết bình nước còn hay sắp cạn (Wokwi dùng biến trở)</a:t>
+                      </a:r>
+                    </a:p>
+                  </a:txBody>
+                  <a:tcPr marL="91440" marR="91440" marT="27432" marB="27432" anchor="ctr">
+                    <a:solidFill>
+                      <a:srgbClr val="FFFFFF"/>
+                    </a:solidFill>
+                  </a:tcPr>
+                </a:tc>
+                <a:tc>
+                  <a:txBody>
+                    <a:bodyPr wrap="square"/>
+                    <a:lstStyle/>
+                    <a:p>
+                      <a:pPr algn="ctr"/>
+                      <a:r>
+                        <a:rPr sz="1300" b="0">
+                          <a:solidFill>
+                            <a:srgbClr val="2E7D4F"/>
+                          </a:solidFill>
+                        </a:rPr>
+                        <a:t>GPIO35</a:t>
+                      </a:r>
+                    </a:p>
+                  </a:txBody>
+                  <a:tcPr marL="91440" marR="91440" marT="27432" marB="27432" anchor="ctr">
+                    <a:solidFill>
+                      <a:srgbClr val="FFFFFF"/>
+                    </a:solidFill>
+                  </a:tcPr>
+                </a:tc>
+                <a:tc>
+                  <a:txBody>
+                    <a:bodyPr wrap="square"/>
+                    <a:lstStyle/>
+                    <a:p>
+                      <a:pPr algn="ctr"/>
+                      <a:r>
+                        <a:rPr sz="1300" b="0">
+                          <a:solidFill>
+                            <a:srgbClr val="B5367A"/>
+                          </a:solidFill>
+                        </a:rPr>
+                        <a:t>GPIO2</a:t>
+                      </a:r>
+                    </a:p>
+                  </a:txBody>
+                  <a:tcPr marL="91440" marR="91440" marT="27432" marB="27432" anchor="ctr">
+                    <a:solidFill>
+                      <a:srgbClr val="FFFFFF"/>
+                    </a:solidFill>
+                  </a:tcPr>
+                </a:tc>
+              </a:tr>
+              <a:tr h="420624">
+                <a:tc>
+                  <a:txBody>
+                    <a:bodyPr wrap="square"/>
+                    <a:lstStyle/>
+                    <a:p>
+                      <a:pPr algn="ctr"/>
+                      <a:r>
+                        <a:rPr sz="1300" b="0">
+                          <a:solidFill>
+                            <a:srgbClr val="1C2B22"/>
+                          </a:solidFill>
+                        </a:rPr>
+                        <a:t>5</a:t>
+                      </a:r>
+                    </a:p>
+                  </a:txBody>
+                  <a:tcPr marL="91440" marR="91440" marT="27432" marB="27432" anchor="ctr">
+                    <a:solidFill>
+                      <a:srgbClr val="EEF4EF"/>
+                    </a:solidFill>
+                  </a:tcPr>
+                </a:tc>
+                <a:tc>
+                  <a:txBody>
+                    <a:bodyPr wrap="square"/>
+                    <a:lstStyle/>
+                    <a:p>
+                      <a:pPr algn="l"/>
+                      <a:r>
+                        <a:rPr sz="1300" b="1">
+                          <a:solidFill>
+                            <a:srgbClr val="1C2B22"/>
+                          </a:solidFill>
+                        </a:rPr>
+                        <a:t>Relay + bơm phun sương</a:t>
+                      </a:r>
+                    </a:p>
+                  </a:txBody>
+                  <a:tcPr marL="91440" marR="91440" marT="27432" marB="27432" anchor="ctr">
+                    <a:solidFill>
+                      <a:srgbClr val="EEF4EF"/>
+                    </a:solidFill>
+                  </a:tcPr>
+                </a:tc>
+                <a:tc>
+                  <a:txBody>
+                    <a:bodyPr wrap="square"/>
+                    <a:lstStyle/>
+                    <a:p>
+                      <a:pPr algn="l"/>
+                      <a:r>
+                        <a:rPr sz="1300" b="0">
+                          <a:solidFill>
+                            <a:srgbClr val="1C2B22"/>
+                          </a:solidFill>
+                        </a:rPr>
+                        <a:t>Phun sương tăng độ ẩm, làm mát</a:t>
+                      </a:r>
+                    </a:p>
+                  </a:txBody>
+                  <a:tcPr marL="91440" marR="91440" marT="27432" marB="27432" anchor="ctr">
+                    <a:solidFill>
+                      <a:srgbClr val="EEF4EF"/>
+                    </a:solidFill>
+                  </a:tcPr>
+                </a:tc>
+                <a:tc>
+                  <a:txBody>
+                    <a:bodyPr wrap="square"/>
+                    <a:lstStyle/>
+                    <a:p>
+                      <a:pPr algn="ctr"/>
+                      <a:r>
+                        <a:rPr sz="1300" b="0">
+                          <a:solidFill>
+                            <a:srgbClr val="2E7D4F"/>
+                          </a:solidFill>
+                        </a:rPr>
+                        <a:t>GPIO25</a:t>
+                      </a:r>
+                    </a:p>
+                  </a:txBody>
+                  <a:tcPr marL="91440" marR="91440" marT="27432" marB="27432" anchor="ctr">
+                    <a:solidFill>
+                      <a:srgbClr val="EEF4EF"/>
+                    </a:solidFill>
+                  </a:tcPr>
+                </a:tc>
+                <a:tc>
+                  <a:txBody>
+                    <a:bodyPr wrap="square"/>
+                    <a:lstStyle/>
+                    <a:p>
+                      <a:pPr algn="ctr"/>
+                      <a:r>
+                        <a:rPr sz="1300" b="0">
+                          <a:solidFill>
+                            <a:srgbClr val="B5367A"/>
+                          </a:solidFill>
+                        </a:rPr>
+                        <a:t>GPIO7</a:t>
+                      </a:r>
+                    </a:p>
+                  </a:txBody>
+                  <a:tcPr marL="91440" marR="91440" marT="27432" marB="27432" anchor="ctr">
+                    <a:solidFill>
+                      <a:srgbClr val="EEF4EF"/>
+                    </a:solidFill>
+                  </a:tcPr>
+                </a:tc>
+              </a:tr>
+              <a:tr h="420624">
+                <a:tc>
+                  <a:txBody>
+                    <a:bodyPr wrap="square"/>
+                    <a:lstStyle/>
+                    <a:p>
+                      <a:pPr algn="ctr"/>
+                      <a:r>
+                        <a:rPr sz="1300" b="0">
+                          <a:solidFill>
+                            <a:srgbClr val="1C2B22"/>
+                          </a:solidFill>
+                        </a:rPr>
+                        <a:t>6</a:t>
+                      </a:r>
+                    </a:p>
+                  </a:txBody>
+                  <a:tcPr marL="91440" marR="91440" marT="27432" marB="27432" anchor="ctr">
+                    <a:solidFill>
+                      <a:srgbClr val="FFFFFF"/>
+                    </a:solidFill>
+                  </a:tcPr>
+                </a:tc>
+                <a:tc>
+                  <a:txBody>
+                    <a:bodyPr wrap="square"/>
+                    <a:lstStyle/>
+                    <a:p>
+                      <a:pPr algn="l"/>
+                      <a:r>
+                        <a:rPr sz="1300" b="1">
+                          <a:solidFill>
+                            <a:srgbClr val="1C2B22"/>
+                          </a:solidFill>
+                        </a:rPr>
+                        <a:t>Relay + quạt</a:t>
+                      </a:r>
+                    </a:p>
+                  </a:txBody>
+                  <a:tcPr marL="91440" marR="91440" marT="27432" marB="27432" anchor="ctr">
+                    <a:solidFill>
+                      <a:srgbClr val="FFFFFF"/>
+                    </a:solidFill>
+                  </a:tcPr>
+                </a:tc>
+                <a:tc>
+                  <a:txBody>
+                    <a:bodyPr wrap="square"/>
+                    <a:lstStyle/>
+                    <a:p>
+                      <a:pPr algn="l"/>
+                      <a:r>
+                        <a:rPr sz="1300" b="0">
+                          <a:solidFill>
+                            <a:srgbClr val="1C2B22"/>
+                          </a:solidFill>
+                        </a:rPr>
+                        <a:t>Thông gió, làm khô lá</a:t>
+                      </a:r>
+                    </a:p>
+                  </a:txBody>
+                  <a:tcPr marL="91440" marR="91440" marT="27432" marB="27432" anchor="ctr">
+                    <a:solidFill>
+                      <a:srgbClr val="FFFFFF"/>
+                    </a:solidFill>
+                  </a:tcPr>
+                </a:tc>
+                <a:tc>
+                  <a:txBody>
+                    <a:bodyPr wrap="square"/>
+                    <a:lstStyle/>
+                    <a:p>
+                      <a:pPr algn="ctr"/>
+                      <a:r>
+                        <a:rPr sz="1300" b="0">
+                          <a:solidFill>
+                            <a:srgbClr val="2E7D4F"/>
+                          </a:solidFill>
+                        </a:rPr>
+                        <a:t>GPIO26</a:t>
+                      </a:r>
+                    </a:p>
+                  </a:txBody>
+                  <a:tcPr marL="91440" marR="91440" marT="27432" marB="27432" anchor="ctr">
+                    <a:solidFill>
+                      <a:srgbClr val="FFFFFF"/>
+                    </a:solidFill>
+                  </a:tcPr>
+                </a:tc>
+                <a:tc>
+                  <a:txBody>
+                    <a:bodyPr wrap="square"/>
+                    <a:lstStyle/>
+                    <a:p>
+                      <a:pPr algn="ctr"/>
+                      <a:r>
+                        <a:rPr sz="1300" b="0">
+                          <a:solidFill>
+                            <a:srgbClr val="B5367A"/>
+                          </a:solidFill>
+                        </a:rPr>
+                        <a:t>GPIO6</a:t>
+                      </a:r>
+                    </a:p>
+                  </a:txBody>
+                  <a:tcPr marL="91440" marR="91440" marT="27432" marB="27432" anchor="ctr">
+                    <a:solidFill>
+                      <a:srgbClr val="FFFFFF"/>
+                    </a:solidFill>
+                  </a:tcPr>
+                </a:tc>
+              </a:tr>
+              <a:tr h="420624">
+                <a:tc>
+                  <a:txBody>
+                    <a:bodyPr wrap="square"/>
+                    <a:lstStyle/>
+                    <a:p>
+                      <a:pPr algn="ctr"/>
+                      <a:r>
+                        <a:rPr sz="1300" b="0">
+                          <a:solidFill>
+                            <a:srgbClr val="1C2B22"/>
+                          </a:solidFill>
+                        </a:rPr>
+                        <a:t>7</a:t>
+                      </a:r>
+                    </a:p>
+                  </a:txBody>
+                  <a:tcPr marL="91440" marR="91440" marT="27432" marB="27432" anchor="ctr">
+                    <a:solidFill>
+                      <a:srgbClr val="EEF4EF"/>
+                    </a:solidFill>
+                  </a:tcPr>
+                </a:tc>
+                <a:tc>
+                  <a:txBody>
+                    <a:bodyPr wrap="square"/>
+                    <a:lstStyle/>
+                    <a:p>
+                      <a:pPr algn="l"/>
+                      <a:r>
+                        <a:rPr sz="1300" b="1">
+                          <a:solidFill>
+                            <a:srgbClr val="1C2B22"/>
+                          </a:solidFill>
+                        </a:rPr>
+                        <a:t>Relay + đèn LED trồng cây</a:t>
+                      </a:r>
+                    </a:p>
+                  </a:txBody>
+                  <a:tcPr marL="91440" marR="91440" marT="27432" marB="27432" anchor="ctr">
+                    <a:solidFill>
+                      <a:srgbClr val="EEF4EF"/>
+                    </a:solidFill>
+                  </a:tcPr>
+                </a:tc>
+                <a:tc>
+                  <a:txBody>
+                    <a:bodyPr wrap="square"/>
+                    <a:lstStyle/>
+                    <a:p>
+                      <a:pPr algn="l"/>
+                      <a:r>
+                        <a:rPr sz="1300" b="0">
+                          <a:solidFill>
+                            <a:srgbClr val="1C2B22"/>
+                          </a:solidFill>
+                        </a:rPr>
+                        <a:t>Bù sáng khi trời tối</a:t>
+                      </a:r>
+                    </a:p>
+                  </a:txBody>
+                  <a:tcPr marL="91440" marR="91440" marT="27432" marB="27432" anchor="ctr">
+                    <a:solidFill>
+                      <a:srgbClr val="EEF4EF"/>
+                    </a:solidFill>
+                  </a:tcPr>
+                </a:tc>
+                <a:tc>
+                  <a:txBody>
+                    <a:bodyPr wrap="square"/>
+                    <a:lstStyle/>
+                    <a:p>
+                      <a:pPr algn="ctr"/>
+                      <a:r>
+                        <a:rPr sz="1300" b="0">
+                          <a:solidFill>
+                            <a:srgbClr val="2E7D4F"/>
+                          </a:solidFill>
+                        </a:rPr>
+                        <a:t>GPIO27</a:t>
+                      </a:r>
+                    </a:p>
+                  </a:txBody>
+                  <a:tcPr marL="91440" marR="91440" marT="27432" marB="27432" anchor="ctr">
+                    <a:solidFill>
+                      <a:srgbClr val="EEF4EF"/>
+                    </a:solidFill>
+                  </a:tcPr>
+                </a:tc>
+                <a:tc>
+                  <a:txBody>
+                    <a:bodyPr wrap="square"/>
+                    <a:lstStyle/>
+                    <a:p>
+                      <a:pPr algn="ctr"/>
+                      <a:r>
+                        <a:rPr sz="1300" b="0">
+                          <a:solidFill>
+                            <a:srgbClr val="B5367A"/>
+                          </a:solidFill>
+                        </a:rPr>
+                        <a:t>GPIO5</a:t>
+                      </a:r>
+                    </a:p>
+                  </a:txBody>
+                  <a:tcPr marL="91440" marR="91440" marT="27432" marB="27432" anchor="ctr">
+                    <a:solidFill>
+                      <a:srgbClr val="EEF4EF"/>
+                    </a:solidFill>
+                  </a:tcPr>
+                </a:tc>
+              </a:tr>
+              <a:tr h="420624">
+                <a:tc>
+                  <a:txBody>
+                    <a:bodyPr wrap="square"/>
+                    <a:lstStyle/>
+                    <a:p>
+                      <a:pPr algn="ctr"/>
+                      <a:r>
+                        <a:rPr sz="1300" b="0">
+                          <a:solidFill>
+                            <a:srgbClr val="1C2B22"/>
+                          </a:solidFill>
+                        </a:rPr>
+                        <a:t>8</a:t>
+                      </a:r>
+                    </a:p>
+                  </a:txBody>
+                  <a:tcPr marL="91440" marR="91440" marT="27432" marB="27432" anchor="ctr">
+                    <a:solidFill>
+                      <a:srgbClr val="FFFFFF"/>
+                    </a:solidFill>
+                  </a:tcPr>
+                </a:tc>
+                <a:tc>
+                  <a:txBody>
+                    <a:bodyPr wrap="square"/>
+                    <a:lstStyle/>
+                    <a:p>
+                      <a:pPr algn="l"/>
+                      <a:r>
+                        <a:rPr sz="1300" b="1">
+                          <a:solidFill>
+                            <a:srgbClr val="1C2B22"/>
+                          </a:solidFill>
+                        </a:rPr>
+                        <a:t>Màn hình ST7789 240×240</a:t>
+                      </a:r>
+                    </a:p>
+                  </a:txBody>
+                  <a:tcPr marL="91440" marR="91440" marT="27432" marB="27432" anchor="ctr">
+                    <a:solidFill>
+                      <a:srgbClr val="FFFFFF"/>
+                    </a:solidFill>
+                  </a:tcPr>
+                </a:tc>
+                <a:tc>
+                  <a:txBody>
+                    <a:bodyPr wrap="square"/>
+                    <a:lstStyle/>
+                    <a:p>
+                      <a:pPr algn="l"/>
+                      <a:r>
+                        <a:rPr sz="1300" b="0">
+                          <a:solidFill>
+                            <a:srgbClr val="1C2B22"/>
+                          </a:solidFill>
+                        </a:rPr>
+                        <a:t>Hiện số đo tại chỗ (chỉ có ở board thật)</a:t>
+                      </a:r>
+                    </a:p>
+                  </a:txBody>
+                  <a:tcPr marL="91440" marR="91440" marT="27432" marB="27432" anchor="ctr">
+                    <a:solidFill>
+                      <a:srgbClr val="FFFFFF"/>
+                    </a:solidFill>
+                  </a:tcPr>
+                </a:tc>
+                <a:tc>
+                  <a:txBody>
+                    <a:bodyPr wrap="square"/>
+                    <a:lstStyle/>
+                    <a:p>
+                      <a:pPr algn="ctr"/>
+                      <a:r>
+                        <a:rPr sz="1300" b="0">
+                          <a:solidFill>
+                            <a:srgbClr val="2E7D4F"/>
+                          </a:solidFill>
+                        </a:rPr>
+                        <a:t>—</a:t>
+                      </a:r>
+                    </a:p>
+                  </a:txBody>
+                  <a:tcPr marL="91440" marR="91440" marT="27432" marB="27432" anchor="ctr">
+                    <a:solidFill>
+                      <a:srgbClr val="FFFFFF"/>
+                    </a:solidFill>
+                  </a:tcPr>
+                </a:tc>
+                <a:tc>
+                  <a:txBody>
+                    <a:bodyPr wrap="square"/>
+                    <a:lstStyle/>
+                    <a:p>
+                      <a:pPr algn="ctr"/>
+                      <a:r>
+                        <a:rPr sz="1300" b="0">
+                          <a:solidFill>
+                            <a:srgbClr val="B5367A"/>
+                          </a:solidFill>
+                        </a:rPr>
+                        <a:t>SPI GPIO8–12</a:t>
+                      </a:r>
+                    </a:p>
+                  </a:txBody>
+                  <a:tcPr marL="91440" marR="91440" marT="27432" marB="27432" anchor="ctr">
+                    <a:solidFill>
+                      <a:srgbClr val="FFFFFF"/>
+                    </a:solidFill>
+                  </a:tcPr>
+                </a:tc>
+              </a:tr>
+              <a:tr h="420624">
+                <a:tc>
+                  <a:txBody>
+                    <a:bodyPr wrap="square"/>
+                    <a:lstStyle/>
+                    <a:p>
+                      <a:pPr algn="ctr"/>
+                      <a:r>
+                        <a:rPr sz="1300" b="0">
+                          <a:solidFill>
+                            <a:srgbClr val="1C2B22"/>
+                          </a:solidFill>
+                        </a:rPr>
+                        <a:t>9</a:t>
+                      </a:r>
+                    </a:p>
+                  </a:txBody>
+                  <a:tcPr marL="91440" marR="91440" marT="27432" marB="27432" anchor="ctr">
+                    <a:solidFill>
+                      <a:srgbClr val="EEF4EF"/>
+                    </a:solidFill>
+                  </a:tcPr>
+                </a:tc>
+                <a:tc>
+                  <a:txBody>
+                    <a:bodyPr wrap="square"/>
+                    <a:lstStyle/>
+                    <a:p>
+                      <a:pPr algn="l"/>
+                      <a:r>
+                        <a:rPr sz="1300" b="1">
+                          <a:solidFill>
+                            <a:srgbClr val="1C2B22"/>
+                          </a:solidFill>
+                        </a:rPr>
+                        <a:t>Máy tính chạy Node-RED</a:t>
+                      </a:r>
+                    </a:p>
+                  </a:txBody>
+                  <a:tcPr marL="91440" marR="91440" marT="27432" marB="27432" anchor="ctr">
+                    <a:solidFill>
+                      <a:srgbClr val="EEF4EF"/>
+                    </a:solidFill>
+                  </a:tcPr>
+                </a:tc>
+                <a:tc>
+                  <a:txBody>
+                    <a:bodyPr wrap="square"/>
+                    <a:lstStyle/>
+                    <a:p>
+                      <a:pPr algn="l"/>
+                      <a:r>
+                        <a:rPr sz="1300" b="0">
+                          <a:solidFill>
+                            <a:srgbClr val="1C2B22"/>
+                          </a:solidFill>
+                        </a:rPr>
+                        <a:t>Server + dashboard, kết nối broker.emqx.io</a:t>
+                      </a:r>
+                    </a:p>
+                  </a:txBody>
+                  <a:tcPr marL="91440" marR="91440" marT="27432" marB="27432" anchor="ctr">
+                    <a:solidFill>
+                      <a:srgbClr val="EEF4EF"/>
+                    </a:solidFill>
+                  </a:tcPr>
+                </a:tc>
+                <a:tc>
+                  <a:txBody>
+                    <a:bodyPr wrap="square"/>
+                    <a:lstStyle/>
+                    <a:p>
+                      <a:pPr algn="ctr"/>
+                      <a:r>
+                        <a:rPr sz="1300" b="0">
+                          <a:solidFill>
+                            <a:srgbClr val="2E7D4F"/>
+                          </a:solidFill>
+                        </a:rPr>
+                        <a:t>—</a:t>
+                      </a:r>
+                    </a:p>
+                  </a:txBody>
+                  <a:tcPr marL="91440" marR="91440" marT="27432" marB="27432" anchor="ctr">
+                    <a:solidFill>
+                      <a:srgbClr val="EEF4EF"/>
+                    </a:solidFill>
+                  </a:tcPr>
+                </a:tc>
+                <a:tc>
+                  <a:txBody>
+                    <a:bodyPr wrap="square"/>
+                    <a:lstStyle/>
+                    <a:p>
+                      <a:pPr algn="ctr"/>
+                      <a:r>
+                        <a:rPr sz="1300" b="0">
+                          <a:solidFill>
+                            <a:srgbClr val="B5367A"/>
+                          </a:solidFill>
+                        </a:rPr>
+                        <a:t>—</a:t>
+                      </a:r>
+                    </a:p>
+                  </a:txBody>
+                  <a:tcPr marL="91440" marR="91440" marT="27432" marB="27432" anchor="ctr">
+                    <a:solidFill>
+                      <a:srgbClr val="EEF4EF"/>
+                    </a:solidFill>
+                  </a:tcPr>
+                </a:tc>
+              </a:tr>
+            </a:tbl>
+          </a:graphicData>
+        </a:graphic>
+      </p:graphicFrame>
     </p:spTree>
   </p:cSld>
   <p:clrMapOvr>

</xml_diff>